<commit_message>
Simplify EK1 slides and explain SSDF plus ASVS choice
</commit_message>
<xml_diff>
--- a/presentation/taskflow-ek1.pptx
+++ b/presentation/taskflow-ek1.pptx
@@ -2,21 +2,21 @@
 <file path=ppt/presentation.xml><?xml version="1.0" encoding="utf-8"?>
 <p:presentation xmlns:p="http://schemas.openxmlformats.org/presentationml/2006/main">
   <p:sldMasterIdLst>
-    <p:sldMasterId xmlns:r="http://schemas.openxmlformats.org/officeDocument/2006/relationships" id="2147483648" r:id="Rf7f0282807184a22"/>
+    <p:sldMasterId xmlns:r="http://schemas.openxmlformats.org/officeDocument/2006/relationships" id="2147483648" r:id="Rfd2becc5ef064e6b"/>
   </p:sldMasterIdLst>
   <p:notesMasterIdLst>
-    <p:notesMasterId xmlns:r="http://schemas.openxmlformats.org/officeDocument/2006/relationships" r:id="Ra31c55d44baa4b1e"/>
+    <p:notesMasterId xmlns:r="http://schemas.openxmlformats.org/officeDocument/2006/relationships" r:id="Rf387fef931e1493b"/>
   </p:notesMasterIdLst>
   <p:sldIdLst>
-    <p:sldId xmlns:r="http://schemas.openxmlformats.org/officeDocument/2006/relationships" id="256" r:id="R88d475ab05c34349"/>
-    <p:sldId xmlns:r="http://schemas.openxmlformats.org/officeDocument/2006/relationships" id="257" r:id="R6fa87d75782e4b4d"/>
-    <p:sldId xmlns:r="http://schemas.openxmlformats.org/officeDocument/2006/relationships" id="258" r:id="Reb54495f9d714661"/>
-    <p:sldId xmlns:r="http://schemas.openxmlformats.org/officeDocument/2006/relationships" id="259" r:id="Rd12fb16f725e4ac7"/>
-    <p:sldId xmlns:r="http://schemas.openxmlformats.org/officeDocument/2006/relationships" id="260" r:id="Rc65dd73efa0b4a5c"/>
-    <p:sldId xmlns:r="http://schemas.openxmlformats.org/officeDocument/2006/relationships" id="261" r:id="Re795814e2f774ce4"/>
-    <p:sldId xmlns:r="http://schemas.openxmlformats.org/officeDocument/2006/relationships" id="262" r:id="R3f9a9f25083146f7"/>
-    <p:sldId xmlns:r="http://schemas.openxmlformats.org/officeDocument/2006/relationships" id="263" r:id="Rb3dcbf1a53da4b8d"/>
-    <p:sldId xmlns:r="http://schemas.openxmlformats.org/officeDocument/2006/relationships" id="264" r:id="R56cf156a48644b78"/>
+    <p:sldId xmlns:r="http://schemas.openxmlformats.org/officeDocument/2006/relationships" id="256" r:id="R55becc7d521a4a47"/>
+    <p:sldId xmlns:r="http://schemas.openxmlformats.org/officeDocument/2006/relationships" id="257" r:id="Rf92fcb5e00874b2b"/>
+    <p:sldId xmlns:r="http://schemas.openxmlformats.org/officeDocument/2006/relationships" id="258" r:id="R2ce952b0d59f45fe"/>
+    <p:sldId xmlns:r="http://schemas.openxmlformats.org/officeDocument/2006/relationships" id="259" r:id="Rb9a6b305661749c9"/>
+    <p:sldId xmlns:r="http://schemas.openxmlformats.org/officeDocument/2006/relationships" id="260" r:id="Re36c2f71c4824165"/>
+    <p:sldId xmlns:r="http://schemas.openxmlformats.org/officeDocument/2006/relationships" id="261" r:id="R80b40d06d7134cc8"/>
+    <p:sldId xmlns:r="http://schemas.openxmlformats.org/officeDocument/2006/relationships" id="262" r:id="R52477179437448c2"/>
+    <p:sldId xmlns:r="http://schemas.openxmlformats.org/officeDocument/2006/relationships" id="263" r:id="R7d14030a01fd4c1c"/>
+    <p:sldId xmlns:r="http://schemas.openxmlformats.org/officeDocument/2006/relationships" id="264" r:id="R9d94c29bc5f548a0"/>
   </p:sldIdLst>
   <p:sldSz cx="12192000" cy="6858000"/>
   <p:notesSz cx="6858000" cy="9144000"/>
@@ -450,12 +450,12 @@
           <a:lstStyle xmlns:a="http://schemas.openxmlformats.org/drawingml/2006/main"/>
           <a:p xmlns:a="http://schemas.openxmlformats.org/drawingml/2006/main">
             <a:r>
-              <a:t>Основная часть: 15 секунд.</a:t>
-            </a:r>
-          </a:p>
-          <a:p xmlns:a="http://schemas.openxmlformats.org/drawingml/2006/main">
-            <a:r>
-              <a:t>Мы представляем TaskFlow — локальный трекер задач для учебной команды. Наша цель — связать конкретные права пользователей с проверками кода и понятными условиями выпуска. Покажем выбранную основу, реальный разрыв и план работы пары.</a:t>
+              <a:t>Основная часть: 15 секунд. Роман.</a:t>
+            </a:r>
+          </a:p>
+          <a:p xmlns:a="http://schemas.openxmlformats.org/drawingml/2006/main">
+            <a:r>
+              <a:t>Мы делаем TaskFlow, трекер задач для небольшой команды. На первой защите показываем, как будем разрабатывать его безопасно: какие правила выбрали, что уже проверено и что делает каждый участник.</a:t>
             </a:r>
           </a:p>
           <a:p xmlns:a="http://schemas.openxmlformats.org/drawingml/2006/main">
@@ -480,7 +480,7 @@
           </a:p>
           <a:p xmlns:a="http://schemas.openxmlformats.org/drawingml/2006/main">
             <a:r>
-              <a:t>Обложка: иллюстрация OpenAI ImageGen, создана для этой презентации.</a:t>
+              <a:t>Обложка: иллюстрация OpenAI ImageGen.</a:t>
             </a:r>
           </a:p>
         </p:txBody>
@@ -550,12 +550,27 @@
           <a:lstStyle xmlns:a="http://schemas.openxmlformats.org/drawingml/2006/main"/>
           <a:p xmlns:a="http://schemas.openxmlformats.org/drawingml/2006/main">
             <a:r>
-              <a:t>Основная часть: 35 секунд.</a:t>
-            </a:r>
-          </a:p>
-          <a:p xmlns:a="http://schemas.openxmlformats.org/drawingml/2006/main">
-            <a:r>
-              <a:t>Владелец управляет проектом, участниками и удалением. Редактор создаёт и меняет задачи, пишет комментарии. Наблюдатель только читает. Посторонний не видит чужой проект. Роль действует внутри проекта, поэтому один человек может иметь разные права в разных проектах. Проверяем Django и SQLite на localhost с синтетическими данными. Публичный хостинг, вложения и реальные данные в область не входят. Исследуем baseline-mvp, планируемый продуктовый выпуск — v1.0.0.</a:t>
+              <a:t>Основная часть: 25 секунд. Роман.</a:t>
+            </a:r>
+          </a:p>
+          <a:p xmlns:a="http://schemas.openxmlformats.org/drawingml/2006/main">
+            <a:r>
+              <a:t>Владелец управляет задачами и участниками. Редактор меняет задачи и пишет комментарии. Наблюдатель только читает. Посторонний не видит чужой проект. Права действуют отдельно в каждом проекте. Приложение работает локально на Django и SQLite, данные учебные. Исходная версия для исследования называется baseline-mvp, будущий выпуск — v1.0.0.</a:t>
+            </a:r>
+          </a:p>
+          <a:p xmlns:a="http://schemas.openxmlformats.org/drawingml/2006/main">
+            <a:r>
+              <a:t/>
+            </a:r>
+          </a:p>
+          <a:p xmlns:a="http://schemas.openxmlformats.org/drawingml/2006/main">
+            <a:r>
+              <a:t>Для вопросов:</a:t>
+            </a:r>
+          </a:p>
+          <a:p xmlns:a="http://schemas.openxmlformats.org/drawingml/2006/main">
+            <a:r>
+              <a:t>Публичный хостинг, вложения и реальные пользовательские данные не входят в область проекта. Один пользователь может иметь разные роли в разных проектах.</a:t>
             </a:r>
           </a:p>
           <a:p xmlns:a="http://schemas.openxmlformats.org/drawingml/2006/main">
@@ -650,12 +665,12 @@
           <a:lstStyle xmlns:a="http://schemas.openxmlformats.org/drawingml/2006/main"/>
           <a:p xmlns:a="http://schemas.openxmlformats.org/drawingml/2006/main">
             <a:r>
-              <a:t>Основная часть: 45 секунд.</a:t>
-            </a:r>
-          </a:p>
-          <a:p xmlns:a="http://schemas.openxmlformats.org/drawingml/2006/main">
-            <a:r>
-              <a:t>Мы выбрали вариант A: основная рамка SSDF 1.1, дополнительный источник ASVS 5.0.0. SSDF охватывает жизненный цикл и позволяет превратить семь положений в действия двух участников без отдельного отдела безопасности. Источник открыт. SAMM больше помогает оценивать и развивать устойчивые практики; у нашего проекта пока короткая история. ГОСТ также применим, но не даёт отдельного преимущества для выбранной учебной области. ASVS уточняет техническую часть веб-проверок. Мы не заявляем полное соответствие стандартам или уровень ASVS.</a:t>
+              <a:t>Основная часть: 45 секунд. Роман.</a:t>
+            </a:r>
+          </a:p>
+          <a:p xmlns:a="http://schemas.openxmlformats.org/drawingml/2006/main">
+            <a:r>
+              <a:t>SSDF отвечает на вопрос, как организовать безопасную разработку. Он охватывает путь от требований до выпуска и исправлений, а способы выполнения мы подбираем под двух человек. Полный текст открыт. Из него мы выбрали семь правил, например проверку кода партнёром и сохранение результатов тестов. ASVS отвечает на вопрос, что именно проверять в веб-приложении: доступ, вход и обработку текста. Вместе получаем и порядок работы, и технические требования. Один SSDF не даёт подробного списка веб-проверок, а ASVS не описывает весь процесс команды.</a:t>
             </a:r>
           </a:p>
           <a:p xmlns:a="http://schemas.openxmlformats.org/drawingml/2006/main">
@@ -665,6 +680,21 @@
           </a:p>
           <a:p xmlns:a="http://schemas.openxmlformats.org/drawingml/2006/main">
             <a:r>
+              <a:t>Для вопросов:</a:t>
+            </a:r>
+          </a:p>
+          <a:p xmlns:a="http://schemas.openxmlformats.org/drawingml/2006/main">
+            <a:r>
+              <a:t>Семь правил в §2 паспорта: PO.1.2, PO.2.1, PS.1.1, PW.7.1–7.2, PW.8.1–8.2, PS.3.1, RV.2.1–2.2. Их действия, роли, результаты и условия принятия описаны отдельно. Полное соответствие SSDF или уровень ASVS не заявляем. ASVS содержит требования, а конкретные тесты команда проектирует сама.</a:t>
+            </a:r>
+          </a:p>
+          <a:p xmlns:a="http://schemas.openxmlformats.org/drawingml/2006/main">
+            <a:r>
+              <a:t/>
+            </a:r>
+          </a:p>
+          <a:p xmlns:a="http://schemas.openxmlformats.org/drawingml/2006/main">
+            <a:r>
               <a:t>Источники:</a:t>
             </a:r>
           </a:p>
@@ -680,22 +710,12 @@
           </a:p>
           <a:p xmlns:a="http://schemas.openxmlformats.org/drawingml/2006/main">
             <a:r>
-              <a:t>https://owaspsamm.org/model/</a:t>
-            </a:r>
-          </a:p>
-          <a:p xmlns:a="http://schemas.openxmlformats.org/drawingml/2006/main">
-            <a:r>
-              <a:t>https://protect.gost.ru/gost/details/f3818925-a96f-4f55-96e9-46b44720ee64</a:t>
-            </a:r>
-          </a:p>
-          <a:p xmlns:a="http://schemas.openxmlformats.org/drawingml/2006/main">
-            <a:r>
               <a:t>https://github.com/hse-rbpo-master-2026/course/blob/5ce5fdf4ba4bb32ac62d1b9c6728f3a6d8fa6884/lectures/L03.pdf</a:t>
             </a:r>
           </a:p>
           <a:p xmlns:a="http://schemas.openxmlformats.org/drawingml/2006/main">
             <a:r>
-              <a:t>https://github.com/rbeketov/rbpo-yavkaib/blob/main/docs/methodology-options.md</a:t>
+              <a:t>https://github.com/rbeketov/rbpo-yavkaib/blob/main/project.md</a:t>
             </a:r>
           </a:p>
         </p:txBody>
@@ -765,12 +785,12 @@
           <a:lstStyle xmlns:a="http://schemas.openxmlformats.org/drawingml/2006/main"/>
           <a:p xmlns:a="http://schemas.openxmlformats.org/drawingml/2006/main">
             <a:r>
-              <a:t>Основная часть: 35 секунд.</a:t>
-            </a:r>
-          </a:p>
-          <a:p xmlns:a="http://schemas.openxmlformats.org/drawingml/2006/main">
-            <a:r>
-              <a:t>Пример адаптации SSDF — проверка работающего кода PW.8. Требование продукта: наблюдатель не меняет задачу. Роман отправляет запрос от viewer и допустимый запрос от editor. В первом случае должны быть отказ и неизменная база, во втором — разрешённое изменение. Ярослав независимо повторяет запрет и читает проверку прав. Сохраняем версию, условия и результат. Если поведение не соответствует требованию, изменение не включаем. Это наша адаптация SSDF к паре, а не дословное требование стандарта.</a:t>
+              <a:t>Основная часть: 35 секунд. Роман.</a:t>
+            </a:r>
+          </a:p>
+          <a:p xmlns:a="http://schemas.openxmlformats.org/drawingml/2006/main">
+            <a:r>
+              <a:t>SAMM рассмотрели, потому что он помогает оценивать и улучшать практики команды. Но TaskFlow только начат, истории проверок мало. Сейчас нам важнее установить правила работы. ГОСТ рассмотрели как полноценную основу безопасной разработки. Задание курса разрешает выбрать основу и не требует именно ГОСТ. Мы взяли SSDF: его полный текст открыт, а выбранных практик достаточно для нашей области. Это выбор под задачу, а не утверждение, что SAMM или ГОСТ хуже.</a:t>
             </a:r>
           </a:p>
           <a:p xmlns:a="http://schemas.openxmlformats.org/drawingml/2006/main">
@@ -780,27 +800,57 @@
           </a:p>
           <a:p xmlns:a="http://schemas.openxmlformats.org/drawingml/2006/main">
             <a:r>
+              <a:t>Для вопросов:</a:t>
+            </a:r>
+          </a:p>
+          <a:p xmlns:a="http://schemas.openxmlformats.org/drawingml/2006/main">
+            <a:r>
+              <a:t>SAMM применим и к маленькой команде. Его можно использовать позже для оценки того, насколько устойчиво выполняются правила. ГОСТ не ограничен государственными или сертифицируемыми проектами. Обязательность по закону или договору устанавливается отдельно. Официальная карточка ГОСТ подтверждает сведения о стандарте, но не заменяет полный текст требований. Для альтернативного выбора потребовались бы назначенные положения из ЭИОС или другой законный доступ.</a:t>
+            </a:r>
+          </a:p>
+          <a:p xmlns:a="http://schemas.openxmlformats.org/drawingml/2006/main">
+            <a:r>
+              <a:t/>
+            </a:r>
+          </a:p>
+          <a:p xmlns:a="http://schemas.openxmlformats.org/drawingml/2006/main">
+            <a:r>
               <a:t>Источники:</a:t>
             </a:r>
           </a:p>
           <a:p xmlns:a="http://schemas.openxmlformats.org/drawingml/2006/main">
             <a:r>
+              <a:t>https://owaspsamm.org/model/</a:t>
+            </a:r>
+          </a:p>
+          <a:p xmlns:a="http://schemas.openxmlformats.org/drawingml/2006/main">
+            <a:r>
+              <a:t>https://owaspsamm.org/assessment/</a:t>
+            </a:r>
+          </a:p>
+          <a:p xmlns:a="http://schemas.openxmlformats.org/drawingml/2006/main">
+            <a:r>
+              <a:t>https://protect.gost.ru/gost/details/f3818925-a96f-4f55-96e9-46b44720ee64</a:t>
+            </a:r>
+          </a:p>
+          <a:p xmlns:a="http://schemas.openxmlformats.org/drawingml/2006/main">
+            <a:r>
               <a:t>https://csrc.nist.gov/pubs/sp/800/218/final</a:t>
             </a:r>
           </a:p>
           <a:p xmlns:a="http://schemas.openxmlformats.org/drawingml/2006/main">
             <a:r>
-              <a:t>https://github.com/rbeketov/rbpo-yavkaib/blob/main/project.md</a:t>
-            </a:r>
-          </a:p>
-          <a:p xmlns:a="http://schemas.openxmlformats.org/drawingml/2006/main">
-            <a:r>
-              <a:t>https://github.com/rbeketov/rbpo-yavkaib/blob/main/tracker/permissions.py</a:t>
-            </a:r>
-          </a:p>
-          <a:p xmlns:a="http://schemas.openxmlformats.org/drawingml/2006/main">
-            <a:r>
-              <a:t>https://github.com/rbeketov/rbpo-yavkaib/blob/main/tracker/tests.py</a:t>
+              <a:t>https://github.com/hse-rbpo-master-2026/course/blob/5ce5fdf4ba4bb32ac62d1b9c6728f3a6d8fa6884/seminars/S02.md</a:t>
+            </a:r>
+          </a:p>
+          <a:p xmlns:a="http://schemas.openxmlformats.org/drawingml/2006/main">
+            <a:r>
+              <a:t>https://github.com/hse-rbpo-master-2026/course/blob/5ce5fdf4ba4bb32ac62d1b9c6728f3a6d8fa6884/lectures/L03.pdf</a:t>
+            </a:r>
+          </a:p>
+          <a:p xmlns:a="http://schemas.openxmlformats.org/drawingml/2006/main">
+            <a:r>
+              <a:t>https://github.com/hse-rbpo-master-2026/course/blob/5ce5fdf4ba4bb32ac62d1b9c6728f3a6d8fa6884/lectures/L04.pdf</a:t>
             </a:r>
           </a:p>
         </p:txBody>
@@ -870,12 +920,12 @@
           <a:lstStyle xmlns:a="http://schemas.openxmlformats.org/drawingml/2006/main"/>
           <a:p xmlns:a="http://schemas.openxmlformats.org/drawingml/2006/main">
             <a:r>
-              <a:t>Основная часть: 35 секунд.</a:t>
-            </a:r>
-          </a:p>
-          <a:p xmlns:a="http://schemas.openxmlformats.org/drawingml/2006/main">
-            <a:r>
-              <a:t>В baseline прошли 27 тестов и пять инженерных проверок. Сохранены версии и хеши; код приложения с тех пор не изменялся. В срезе публичного API есть четыре успешных CI-запуска и ноль PR. Это не доказывает отсутствие устных обсуждений, но независимый review в репозитории не подтверждён. Поэтому G1 имеет высокий приоритет: код и тест могут содержать общую ошибку. Отдельные средние разрывы — отсутствие CVE-триажа и независимого запуска архива. Они ограничивают основание выпуска, но сами по себе не доказывают уязвимость.</a:t>
+              <a:t>Основная часть: 30 секунд. Ярослав.</a:t>
+            </a:r>
+          </a:p>
+          <a:p xmlns:a="http://schemas.openxmlformats.org/drawingml/2006/main">
+            <a:r>
+              <a:t>В исходной версии прошли 27 тестов. Результаты и версия кода сохранены. Но на дату исследования, четвёртое октября, в репозитории не было подтверждения независимой проверки вторым участником. Код и тест могут повторять одну ошибку. Поэтому первый шаг — взаимная проверка прав пользователей. Также нужно проверить библиотеки на известные уязвимости и повторить установку из архива.</a:t>
             </a:r>
           </a:p>
           <a:p xmlns:a="http://schemas.openxmlformats.org/drawingml/2006/main">
@@ -885,6 +935,21 @@
           </a:p>
           <a:p xmlns:a="http://schemas.openxmlformats.org/drawingml/2006/main">
             <a:r>
+              <a:t>Для вопросов:</a:t>
+            </a:r>
+          </a:p>
+          <a:p xmlns:a="http://schemas.openxmlformats.org/drawingml/2006/main">
+            <a:r>
+              <a:t>Это срез на 04.10.2026, а не утверждение о состоянии истории в любой будущий момент. G1 имеет высокий приоритет, G2 и G3 — средний. Пять инженерных проверок baseline прошли. Успех тестов не доказывает отсутствие всех уязвимостей. pip check проверяет согласованность зависимостей, но не заменяет аудит известных CVE.</a:t>
+            </a:r>
+          </a:p>
+          <a:p xmlns:a="http://schemas.openxmlformats.org/drawingml/2006/main">
+            <a:r>
+              <a:t/>
+            </a:r>
+          </a:p>
+          <a:p xmlns:a="http://schemas.openxmlformats.org/drawingml/2006/main">
+            <a:r>
               <a:t>Источники:</a:t>
             </a:r>
           </a:p>
@@ -900,7 +965,7 @@
           </a:p>
           <a:p xmlns:a="http://schemas.openxmlformats.org/drawingml/2006/main">
             <a:r>
-              <a:t>https://github.com/hse-rbpo-master-2026/course/blob/5ce5fdf4ba4bb32ac62d1b9c6728f3a6d8fa6884/lectures/L04.pdf</a:t>
+              <a:t>https://github.com/rbeketov/rbpo-yavkaib/blob/main/project.md</a:t>
             </a:r>
           </a:p>
         </p:txBody>
@@ -970,12 +1035,12 @@
           <a:lstStyle xmlns:a="http://schemas.openxmlformats.org/drawingml/2006/main"/>
           <a:p xmlns:a="http://schemas.openxmlformats.org/drawingml/2006/main">
             <a:r>
-              <a:t>Основная часть: 40 секунд.</a:t>
-            </a:r>
-          </a:p>
-          <a:p xmlns:a="http://schemas.openxmlformats.org/drawingml/2006/main">
-            <a:r>
-              <a:t>Перед реализацией автор фиксирует роль, объект и негативный сценарий. Перед merge должны пройти проверки, а другой участник читает код и повторяет существенный случай. Автор себя не одобряет, ИИ проверяющего не заменяет. Перед продуктовым выпуском Роман собирает результаты и архив, Ярослав воспроизводит установку, оба принимают решение. Без проверяющего, при нарушении прав или неразобранном существенном результате переход откладываем. Некритическое исключение оформляем со сроком до семи дней и согласием обоих. При споре сохраняем позиции, обращаемся к преподавателю и откладываем выпуск. Обязательность статуса GitHub технически не подтверждена, поэтому это правило пары.</a:t>
+              <a:t>Основная часть: 50 секунд. Ярослав.</a:t>
+            </a:r>
+          </a:p>
+          <a:p xmlns:a="http://schemas.openxmlformats.org/drawingml/2006/main">
+            <a:r>
+              <a:t>Перед изменением автор описывает ожидаемое поведение, затем меняет код и запускает тесты. Партнёр читает код и независимо повторяет важный сценарий. Например, наблюдатель отправляет прямой запрос на изменение задачи. Сервер должен отказать, а данные остаться прежними. Такой же запрос от редактора должен сработать. Сохраняем версию кода, условия и результат проверки. Так мы применяем правило SSDF PW.8. Если права нарушены или партнёр не проверил изменение, откладываем его. Перед выпуском Ярослав повторяет установку из архива, Роман собирает результаты. Решение о выпуске принимаем вместе.</a:t>
             </a:r>
           </a:p>
           <a:p xmlns:a="http://schemas.openxmlformats.org/drawingml/2006/main">
@@ -985,11 +1050,31 @@
           </a:p>
           <a:p xmlns:a="http://schemas.openxmlformats.org/drawingml/2006/main">
             <a:r>
+              <a:t>Для вопросов:</a:t>
+            </a:r>
+          </a:p>
+          <a:p xmlns:a="http://schemas.openxmlformats.org/drawingml/2006/main">
+            <a:r>
+              <a:t>PW.8.1–8.2 задаёт тестирование исполняемого кода. Сценарий, независимый повтор и правило приёмки являются нашей адаптацией. Нужен контрольный разрешённый запрос от editor, чтобы отличить проверку прав от общей поломки функции. Для версии сохраняем результат CI, отчёт и комментарий проверяющего. Автор не одобряет собственную работу. Некритическое исключение требует записи, срока до семи дней и согласия обоих. Нарушение прав исключением не допускается. При споре откладываем выпуск и обращаемся к преподавателю.</a:t>
+            </a:r>
+          </a:p>
+          <a:p xmlns:a="http://schemas.openxmlformats.org/drawingml/2006/main">
+            <a:r>
+              <a:t/>
+            </a:r>
+          </a:p>
+          <a:p xmlns:a="http://schemas.openxmlformats.org/drawingml/2006/main">
+            <a:r>
               <a:t>Источники:</a:t>
             </a:r>
           </a:p>
           <a:p xmlns:a="http://schemas.openxmlformats.org/drawingml/2006/main">
             <a:r>
+              <a:t>https://csrc.nist.gov/pubs/sp/800/218/final</a:t>
+            </a:r>
+          </a:p>
+          <a:p xmlns:a="http://schemas.openxmlformats.org/drawingml/2006/main">
+            <a:r>
               <a:t>https://github.com/rbeketov/rbpo-yavkaib/blob/main/project.md</a:t>
             </a:r>
           </a:p>
@@ -1000,7 +1085,7 @@
           </a:p>
           <a:p xmlns:a="http://schemas.openxmlformats.org/drawingml/2006/main">
             <a:r>
-              <a:t>https://github.com/hse-rbpo-master-2026/course/blob/5ce5fdf4ba4bb32ac62d1b9c6728f3a6d8fa6884/lectures/L05.pdf</a:t>
+              <a:t>https://github.com/rbeketov/rbpo-yavkaib/blob/main/tracker/tests.py</a:t>
             </a:r>
           </a:p>
         </p:txBody>
@@ -1070,12 +1155,12 @@
           <a:lstStyle xmlns:a="http://schemas.openxmlformats.org/drawingml/2006/main"/>
           <a:p xmlns:a="http://schemas.openxmlformats.org/drawingml/2006/main">
             <a:r>
-              <a:t>Основная часть: 35 секунд.</a:t>
-            </a:r>
-          </a:p>
-          <a:p xmlns:a="http://schemas.openxmlformats.org/drawingml/2006/main">
-            <a:r>
-              <a:t>Роман ведёт проверки прав и изоляции, а также зависимостей и конфигурации. Ярослав ведёт ввод, вывод и CSRF, независимо устанавливает архив. Каждый проверяет существенный результат партнёра. Личные задания оформляем в GitHub Issues, отчёты и изменения — через PR. Затем обсуждаем факты на общем созвоне и выбираем улучшение по результатам. Для ЭК1 это предварительный технологический профиль: апробацию и окончательный набор средств уточняем после лекций шесть–восемь.</a:t>
+              <a:t>Основная часть: 40 секунд. Ярослав.</a:t>
+            </a:r>
+          </a:p>
+          <a:p xmlns:a="http://schemas.openxmlformats.org/drawingml/2006/main">
+            <a:r>
+              <a:t>Роман проверяет права трёх ролей, изоляцию проектов, библиотеки и настройки. Ярослав проверяет ввод и вывод текста, защиту запросов от подделки и установку из архива в чистом окружении. Для каждого уже есть отдельное задание в GitHub. Сначала каждый сохраняет отчёт со своими результатами, затем проверяет работу партнёра. После этого созваниваемся, обсуждаем найденные проблемы и выбираем следующее улучшение. План технических проверок на первой защите предварительный, его уточняем после профильных лекций.</a:t>
             </a:r>
           </a:p>
           <a:p xmlns:a="http://schemas.openxmlformats.org/drawingml/2006/main">
@@ -1085,6 +1170,21 @@
           </a:p>
           <a:p xmlns:a="http://schemas.openxmlformats.org/drawingml/2006/main">
             <a:r>
+              <a:t>Для вопросов:</a:t>
+            </a:r>
+          </a:p>
+          <a:p xmlns:a="http://schemas.openxmlformats.org/drawingml/2006/main">
+            <a:r>
+              <a:t>М1: права и изоляция, ведущий Роман, проверяющий Ярослав. М2: ввод, вывод и CSRF, ведущий Ярослав, проверяющий Роман. М3: зависимости и воспроизводимость, Роман ведёт аудит и конфигурацию, Ярослав независимо устанавливает архив. CSRF — подделка запроса от имени вошедшего пользователя. Issue Ярослава пока без назначения аккаунту по договорённости.</a:t>
+            </a:r>
+          </a:p>
+          <a:p xmlns:a="http://schemas.openxmlformats.org/drawingml/2006/main">
+            <a:r>
+              <a:t/>
+            </a:r>
+          </a:p>
+          <a:p xmlns:a="http://schemas.openxmlformats.org/drawingml/2006/main">
+            <a:r>
               <a:t>Источники:</a:t>
             </a:r>
           </a:p>
@@ -1095,7 +1195,12 @@
           </a:p>
           <a:p xmlns:a="http://schemas.openxmlformats.org/drawingml/2006/main">
             <a:r>
-              <a:t>https://github.com/rbeketov/rbpo-yavkaib/issues</a:t>
+              <a:t>https://github.com/rbeketov/rbpo-yavkaib/issues/1</a:t>
+            </a:r>
+          </a:p>
+          <a:p xmlns:a="http://schemas.openxmlformats.org/drawingml/2006/main">
+            <a:r>
+              <a:t>https://github.com/rbeketov/rbpo-yavkaib/issues/2</a:t>
             </a:r>
           </a:p>
           <a:p xmlns:a="http://schemas.openxmlformats.org/drawingml/2006/main">
@@ -1175,7 +1280,7 @@
           </a:p>
           <a:p xmlns:a="http://schemas.openxmlformats.org/drawingml/2006/main">
             <a:r>
-              <a:t>Это выборка задач SSDF, адаптированная к области проекта. Полная таблица применимости, действий, ролей и критериев находится в разделе два паспорта. Частичная применимость означает ограничения локального учебного продукта, а не выполненную сертификацию. ASVS является дополнительным источником для технических сценариев.</a:t>
+              <a:t>ISO/IEC 27034-1 рассмотрели из-за управления безопасностью приложений на уровне организации. В нашей паре нет отдельной организационной задачи, ради которой стоит брать его основой. IEC 62443-4-1 связан с промышленной автоматизацией, TaskFlow находится вне этой области. BSIMM описывает наблюдаемые практики организаций. Сравнение с ними сейчас не является целью проекта.</a:t>
             </a:r>
           </a:p>
           <a:p xmlns:a="http://schemas.openxmlformats.org/drawingml/2006/main">
@@ -1185,22 +1290,47 @@
           </a:p>
           <a:p xmlns:a="http://schemas.openxmlformats.org/drawingml/2006/main">
             <a:r>
+              <a:t>Для вопросов:</a:t>
+            </a:r>
+          </a:p>
+          <a:p xmlns:a="http://schemas.openxmlformats.org/drawingml/2006/main">
+            <a:r>
+              <a:t>ISO и IEC сопоставлены по назначению и области, а не по полному постатейному аудиту. Карточки стандартов не заменяют их полные тексты. На Л04 BSIMM сопоставляется с SAMM как описательная модель с предписывающей. Размер команды сам по себе не делает ISO/IEC 27034 неприменимым.</a:t>
+            </a:r>
+          </a:p>
+          <a:p xmlns:a="http://schemas.openxmlformats.org/drawingml/2006/main">
+            <a:r>
+              <a:t/>
+            </a:r>
+          </a:p>
+          <a:p xmlns:a="http://schemas.openxmlformats.org/drawingml/2006/main">
+            <a:r>
               <a:t>Источники:</a:t>
             </a:r>
           </a:p>
           <a:p xmlns:a="http://schemas.openxmlformats.org/drawingml/2006/main">
             <a:r>
-              <a:t>https://csrc.nist.gov/pubs/sp/800/218/final</a:t>
-            </a:r>
-          </a:p>
-          <a:p xmlns:a="http://schemas.openxmlformats.org/drawingml/2006/main">
-            <a:r>
-              <a:t>https://github.com/OWASP/ASVS/tree/v5.0.0</a:t>
-            </a:r>
-          </a:p>
-          <a:p xmlns:a="http://schemas.openxmlformats.org/drawingml/2006/main">
-            <a:r>
-              <a:t>https://github.com/rbeketov/rbpo-yavkaib/blob/main/project.md</a:t>
+              <a:t>https://www.iso.org/standard/44378.html</a:t>
+            </a:r>
+          </a:p>
+          <a:p xmlns:a="http://schemas.openxmlformats.org/drawingml/2006/main">
+            <a:r>
+              <a:t>https://webstore.iec.ch/en/publication/33615</a:t>
+            </a:r>
+          </a:p>
+          <a:p xmlns:a="http://schemas.openxmlformats.org/drawingml/2006/main">
+            <a:r>
+              <a:t>https://github.com/hse-rbpo-master-2026/course/blob/5ce5fdf4ba4bb32ac62d1b9c6728f3a6d8fa6884/lectures/L03.pdf</a:t>
+            </a:r>
+          </a:p>
+          <a:p xmlns:a="http://schemas.openxmlformats.org/drawingml/2006/main">
+            <a:r>
+              <a:t>https://github.com/hse-rbpo-master-2026/course/blob/5ce5fdf4ba4bb32ac62d1b9c6728f3a6d8fa6884/lectures/L04.pdf</a:t>
+            </a:r>
+          </a:p>
+          <a:p xmlns:a="http://schemas.openxmlformats.org/drawingml/2006/main">
+            <a:r>
+              <a:t>https://github.com/rbeketov/rbpo-yavkaib/blob/main/docs/methodology-options.md</a:t>
             </a:r>
           </a:p>
         </p:txBody>
@@ -1275,7 +1405,22 @@
           </a:p>
           <a:p xmlns:a="http://schemas.openxmlformats.org/drawingml/2006/main">
             <a:r>
-              <a:t>Использовали Codex для автоматизации подготовки текстов, кода, тестов и оформления, а также для вариантов методологии и плана. Выбор TaskFlow и варианта A сделан участником команды. Ответственность за решения и их объяснение остаётся у участников. Проверки средствами Codex сохранены отдельно и не выдаются за независимое человеческое review. Источники — публичный курс и учебный проект, данные для приложения синтетические. Подробности в разделе двенадцать паспорта.</a:t>
+              <a:t>Использовали Codex для подготовки текста, кода, тестов и слайдов, а также для предложений по методологии и плану. Выбор продукта и варианта A сделал участник команды. Ответственность за решения остаётся у участников. Проверки с помощью ИИ не выдаём за независимую проверку человеком.</a:t>
+            </a:r>
+          </a:p>
+          <a:p xmlns:a="http://schemas.openxmlformats.org/drawingml/2006/main">
+            <a:r>
+              <a:t/>
+            </a:r>
+          </a:p>
+          <a:p xmlns:a="http://schemas.openxmlformats.org/drawingml/2006/main">
+            <a:r>
+              <a:t>Для вопросов:</a:t>
+            </a:r>
+          </a:p>
+          <a:p xmlns:a="http://schemas.openxmlformats.org/drawingml/2006/main">
+            <a:r>
+              <a:t>Подробное раскрытие применения ИИ находится в §12 паспорта. Изображение обложки сгенерировано OpenAI ImageGen. Проверка партнёром и совместное решение о выпуске на слайде описывают целевой порядок работы, а не утверждение о уже завершённых действиях.</a:t>
             </a:r>
           </a:p>
           <a:p xmlns:a="http://schemas.openxmlformats.org/drawingml/2006/main">
@@ -1363,7 +1508,7 @@
   </p:cSld>
   <p:clrMap bg1="lt1" tx1="dk1" bg2="lt2" tx2="dk2" accent1="accent1" accent2="accent2" accent3="accent3" accent4="accent4" accent5="accent5" accent6="accent6" hlink="hlink" folHlink="folHlink"/>
   <p:sldLayoutIdLst>
-    <p:sldLayoutId xmlns:r="http://schemas.openxmlformats.org/officeDocument/2006/relationships" id="2147483649" r:id="R105b5748b7dd45be"/>
+    <p:sldLayoutId xmlns:r="http://schemas.openxmlformats.org/officeDocument/2006/relationships" id="2147483649" r:id="R6e5b5d390bfd49d7"/>
   </p:sldLayoutIdLst>
   <p:txStyles>
     <p:titleStyle>
@@ -1911,14 +2056,14 @@
       </p:grpSpPr>
       <p:pic>
         <p:nvPicPr>
-          <p:cNvPr id="7" name=""/>
+          <p:cNvPr id="8" name=""/>
           <p:cNvPicPr>
             <a:picLocks xmlns:a="http://schemas.openxmlformats.org/drawingml/2006/main" noChangeAspect="1"/>
           </p:cNvPicPr>
           <p:nvPr/>
         </p:nvPicPr>
         <p:blipFill>
-          <a:blip xmlns:r="http://schemas.openxmlformats.org/officeDocument/2006/relationships" xmlns:a="http://schemas.openxmlformats.org/drawingml/2006/main" r:embed="R5b8ee9f25b5449b2"/>
+          <a:blip xmlns:r="http://schemas.openxmlformats.org/officeDocument/2006/relationships" xmlns:a="http://schemas.openxmlformats.org/drawingml/2006/main" r:embed="R45c287352e9a4218"/>
           <a:srcRect xmlns:a="http://schemas.openxmlformats.org/drawingml/2006/main" l="0" t="27" r="0" b="27"/>
           <a:stretch xmlns:a="http://schemas.openxmlformats.org/drawingml/2006/main">
             <a:fillRect l="0" t="0" r="0" b="0"/>
@@ -1968,6 +2113,7 @@
           <a:lstStyle xmlns:a="http://schemas.openxmlformats.org/drawingml/2006/main"/>
           <a:p xmlns:a="http://schemas.openxmlformats.org/drawingml/2006/main">
             <a:pPr>
+              <a:buNone/>
               <a:defRPr sz="1425" b="1">
                 <a:solidFill>
                   <a:srgbClr val="A9DBCB"/>
@@ -2025,6 +2171,7 @@
           <a:lstStyle xmlns:a="http://schemas.openxmlformats.org/drawingml/2006/main"/>
           <a:p xmlns:a="http://schemas.openxmlformats.org/drawingml/2006/main">
             <a:pPr>
+              <a:buNone/>
               <a:defRPr sz="5700" b="1">
                 <a:solidFill>
                   <a:srgbClr val="FFFFFF"/>
@@ -2082,6 +2229,7 @@
           <a:lstStyle xmlns:a="http://schemas.openxmlformats.org/drawingml/2006/main"/>
           <a:p xmlns:a="http://schemas.openxmlformats.org/drawingml/2006/main">
             <a:pPr>
+              <a:buNone/>
               <a:defRPr sz="2850" b="0">
                 <a:solidFill>
                   <a:srgbClr val="F2F5F0"/>
@@ -2100,34 +2248,12 @@
                 <a:ea typeface="Helvetica Neue"/>
                 <a:cs typeface="Helvetica Neue"/>
               </a:rPr>
-              <a:t>Концепция безопасной</a:t>
-            </a:r>
-          </a:p>
-          <a:p xmlns:a="http://schemas.openxmlformats.org/drawingml/2006/main">
-            <a:pPr>
-              <a:defRPr sz="2850" b="0">
-                <a:solidFill>
-                  <a:srgbClr val="F2F5F0"/>
-                </a:solidFill>
-                <a:latin typeface="Helvetica Neue"/>
-                <a:ea typeface="Helvetica Neue"/>
-                <a:cs typeface="Helvetica Neue"/>
-              </a:defRPr>
-            </a:pPr>
-            <a:r>
-              <a:rPr sz="2850" b="0">
-                <a:solidFill>
-                  <a:srgbClr val="F2F5F0"/>
-                </a:solidFill>
-                <a:latin typeface="Helvetica Neue"/>
-                <a:ea typeface="Helvetica Neue"/>
-                <a:cs typeface="Helvetica Neue"/>
-              </a:rPr>
-              <a:t>разработки локального</a:t>
-            </a:r>
-          </a:p>
-          <a:p xmlns:a="http://schemas.openxmlformats.org/drawingml/2006/main">
-            <a:pPr>
+              <a:t>Безопасная разработка</a:t>
+            </a:r>
+          </a:p>
+          <a:p xmlns:a="http://schemas.openxmlformats.org/drawingml/2006/main">
+            <a:pPr>
+              <a:buNone/>
               <a:defRPr sz="2850" b="0">
                 <a:solidFill>
                   <a:srgbClr val="F2F5F0"/>
@@ -2185,6 +2311,7 @@
           <a:lstStyle xmlns:a="http://schemas.openxmlformats.org/drawingml/2006/main"/>
           <a:p xmlns:a="http://schemas.openxmlformats.org/drawingml/2006/main">
             <a:pPr>
+              <a:buNone/>
               <a:defRPr sz="1875" b="0">
                 <a:solidFill>
                   <a:srgbClr val="E0ECE7"/>
@@ -2208,6 +2335,7 @@
           </a:p>
           <a:p xmlns:a="http://schemas.openxmlformats.org/drawingml/2006/main">
             <a:pPr>
+              <a:buNone/>
               <a:defRPr sz="1875" b="0">
                 <a:solidFill>
                   <a:srgbClr val="E0ECE7"/>
@@ -2265,6 +2393,7 @@
           <a:lstStyle xmlns:a="http://schemas.openxmlformats.org/drawingml/2006/main"/>
           <a:p xmlns:a="http://schemas.openxmlformats.org/drawingml/2006/main">
             <a:pPr>
+              <a:buNone/>
               <a:defRPr sz="1350" b="0">
                 <a:solidFill>
                   <a:srgbClr val="A9DBCB"/>
@@ -2351,6 +2480,7 @@
           <a:lstStyle xmlns:a="http://schemas.openxmlformats.org/drawingml/2006/main"/>
           <a:p xmlns:a="http://schemas.openxmlformats.org/drawingml/2006/main">
             <a:pPr>
+              <a:buNone/>
               <a:defRPr sz="1350" b="1">
                 <a:solidFill>
                   <a:srgbClr val="26756C"/>
@@ -2408,6 +2538,7 @@
           <a:lstStyle xmlns:a="http://schemas.openxmlformats.org/drawingml/2006/main"/>
           <a:p xmlns:a="http://schemas.openxmlformats.org/drawingml/2006/main">
             <a:pPr>
+              <a:buNone/>
               <a:defRPr sz="3300" b="1">
                 <a:solidFill>
                   <a:srgbClr val="102A30"/>
@@ -2426,7 +2557,7 @@
                 <a:ea typeface="Helvetica Neue"/>
                 <a:cs typeface="Helvetica Neue"/>
               </a:rPr>
-              <a:t>Продукт и границы</a:t>
+              <a:t>TaskFlow и три роли</a:t>
             </a:r>
           </a:p>
         </p:txBody>
@@ -2465,6 +2596,7 @@
           <a:lstStyle xmlns:a="http://schemas.openxmlformats.org/drawingml/2006/main"/>
           <a:p xmlns:a="http://schemas.openxmlformats.org/drawingml/2006/main">
             <a:pPr>
+              <a:buNone/>
               <a:defRPr sz="1350" b="0">
                 <a:solidFill>
                   <a:srgbClr val="59686B"/>
@@ -2522,6 +2654,7 @@
           <a:lstStyle xmlns:a="http://schemas.openxmlformats.org/drawingml/2006/main"/>
           <a:p xmlns:a="http://schemas.openxmlformats.org/drawingml/2006/main">
             <a:pPr>
+              <a:buNone/>
               <a:defRPr sz="1800" b="1">
                 <a:solidFill>
                   <a:srgbClr val="26756C"/>
@@ -2547,14 +2680,14 @@
       </p:sp>
       <p:pic>
         <p:nvPicPr>
-          <p:cNvPr id="18" name=""/>
+          <p:cNvPr id="20" name=""/>
           <p:cNvPicPr>
             <a:picLocks xmlns:a="http://schemas.openxmlformats.org/drawingml/2006/main" noChangeAspect="1"/>
           </p:cNvPicPr>
           <p:nvPr/>
         </p:nvPicPr>
         <p:blipFill>
-          <a:blip xmlns:r="http://schemas.openxmlformats.org/officeDocument/2006/relationships" xmlns:a="http://schemas.openxmlformats.org/drawingml/2006/main" r:embed="Rb148d344015d472c"/>
+          <a:blip xmlns:r="http://schemas.openxmlformats.org/officeDocument/2006/relationships" xmlns:a="http://schemas.openxmlformats.org/drawingml/2006/main" r:embed="R00259ca12bd84432"/>
           <a:stretch xmlns:a="http://schemas.openxmlformats.org/drawingml/2006/main"/>
         </p:blipFill>
         <p:spPr>
@@ -2601,6 +2734,7 @@
           <a:lstStyle xmlns:a="http://schemas.openxmlformats.org/drawingml/2006/main"/>
           <a:p xmlns:a="http://schemas.openxmlformats.org/drawingml/2006/main">
             <a:pPr>
+              <a:buNone/>
               <a:defRPr sz="2100" b="1">
                 <a:solidFill>
                   <a:srgbClr val="26756C"/>
@@ -2658,6 +2792,7 @@
           <a:lstStyle xmlns:a="http://schemas.openxmlformats.org/drawingml/2006/main"/>
           <a:p xmlns:a="http://schemas.openxmlformats.org/drawingml/2006/main">
             <a:pPr>
+              <a:buNone/>
               <a:defRPr sz="1950" b="0">
                 <a:solidFill>
                   <a:srgbClr val="102A30"/>
@@ -2715,6 +2850,7 @@
           <a:lstStyle xmlns:a="http://schemas.openxmlformats.org/drawingml/2006/main"/>
           <a:p xmlns:a="http://schemas.openxmlformats.org/drawingml/2006/main">
             <a:pPr>
+              <a:buNone/>
               <a:defRPr sz="2100" b="1">
                 <a:solidFill>
                   <a:srgbClr val="26756C"/>
@@ -2772,6 +2908,7 @@
           <a:lstStyle xmlns:a="http://schemas.openxmlformats.org/drawingml/2006/main"/>
           <a:p xmlns:a="http://schemas.openxmlformats.org/drawingml/2006/main">
             <a:pPr>
+              <a:buNone/>
               <a:defRPr sz="1950" b="0">
                 <a:solidFill>
                   <a:srgbClr val="102A30"/>
@@ -2829,6 +2966,7 @@
           <a:lstStyle xmlns:a="http://schemas.openxmlformats.org/drawingml/2006/main"/>
           <a:p xmlns:a="http://schemas.openxmlformats.org/drawingml/2006/main">
             <a:pPr>
+              <a:buNone/>
               <a:defRPr sz="2100" b="1">
                 <a:solidFill>
                   <a:srgbClr val="26756C"/>
@@ -2886,6 +3024,7 @@
           <a:lstStyle xmlns:a="http://schemas.openxmlformats.org/drawingml/2006/main"/>
           <a:p xmlns:a="http://schemas.openxmlformats.org/drawingml/2006/main">
             <a:pPr>
+              <a:buNone/>
               <a:defRPr sz="1950" b="0">
                 <a:solidFill>
                   <a:srgbClr val="102A30"/>
@@ -2943,6 +3082,7 @@
           <a:lstStyle xmlns:a="http://schemas.openxmlformats.org/drawingml/2006/main"/>
           <a:p xmlns:a="http://schemas.openxmlformats.org/drawingml/2006/main">
             <a:pPr>
+              <a:buNone/>
               <a:defRPr sz="1725" b="0">
                 <a:solidFill>
                   <a:srgbClr val="59686B"/>
@@ -2966,6 +3106,7 @@
           </a:p>
           <a:p xmlns:a="http://schemas.openxmlformats.org/drawingml/2006/main">
             <a:pPr>
+              <a:buNone/>
               <a:defRPr sz="1725" b="0">
                 <a:solidFill>
                   <a:srgbClr val="59686B"/>
@@ -2984,7 +3125,7 @@
                 <a:ea typeface="Helvetica Neue"/>
                 <a:cs typeface="Helvetica Neue"/>
               </a:rPr>
-              <a:t>localhost, синтетические данные</a:t>
+              <a:t>Локально, учебные данные</a:t>
             </a:r>
           </a:p>
         </p:txBody>
@@ -3023,6 +3164,7 @@
           <a:lstStyle xmlns:a="http://schemas.openxmlformats.org/drawingml/2006/main"/>
           <a:p xmlns:a="http://schemas.openxmlformats.org/drawingml/2006/main">
             <a:pPr>
+              <a:buNone/>
               <a:defRPr sz="1725" b="0">
                 <a:solidFill>
                   <a:srgbClr val="59686B"/>
@@ -3109,6 +3251,7 @@
           <a:lstStyle xmlns:a="http://schemas.openxmlformats.org/drawingml/2006/main"/>
           <a:p xmlns:a="http://schemas.openxmlformats.org/drawingml/2006/main">
             <a:pPr>
+              <a:buNone/>
               <a:defRPr sz="1350" b="1">
                 <a:solidFill>
                   <a:srgbClr val="26756C"/>
@@ -3166,6 +3309,7 @@
           <a:lstStyle xmlns:a="http://schemas.openxmlformats.org/drawingml/2006/main"/>
           <a:p xmlns:a="http://schemas.openxmlformats.org/drawingml/2006/main">
             <a:pPr>
+              <a:buNone/>
               <a:defRPr sz="3300" b="1">
                 <a:solidFill>
                   <a:srgbClr val="102A30"/>
@@ -3223,6 +3367,7 @@
           <a:lstStyle xmlns:a="http://schemas.openxmlformats.org/drawingml/2006/main"/>
           <a:p xmlns:a="http://schemas.openxmlformats.org/drawingml/2006/main">
             <a:pPr>
+              <a:buNone/>
               <a:defRPr sz="1350" b="0">
                 <a:solidFill>
                   <a:srgbClr val="59686B"/>
@@ -3280,6 +3425,7 @@
           <a:lstStyle xmlns:a="http://schemas.openxmlformats.org/drawingml/2006/main"/>
           <a:p xmlns:a="http://schemas.openxmlformats.org/drawingml/2006/main">
             <a:pPr>
+              <a:buNone/>
               <a:defRPr sz="1800" b="1">
                 <a:solidFill>
                   <a:srgbClr val="26756C"/>
@@ -3305,10 +3451,10 @@
       </p:sp>
       <p:sp>
         <p:nvSpPr>
-          <p:cNvPr id="5" name="">
+          <p:cNvPr id="9" name="">
             <a:extLst xmlns:a="http://schemas.openxmlformats.org/drawingml/2006/main">
               <a:ext uri="{FF2B5EF4-FFF2-40B4-BE49-F238E27FC236}">
-                <a16:creationId xmlns:a16="http://schemas.microsoft.com/office/drawing/2014/main" id="{ACE9C80F-CB2E-4C90-9CAF-DDE05F6EA728}"/>
+                <a16:creationId xmlns:a16="http://schemas.microsoft.com/office/drawing/2014/main" id="{91E82C49-F9B7-4AB0-A775-E3C5577B16CD}"/>
               </a:ext>
             </a:extLst>
           </p:cNvPr>
@@ -3319,8 +3465,8 @@
         </p:nvSpPr>
         <p:spPr>
           <a:xfrm xmlns:a="http://schemas.openxmlformats.org/drawingml/2006/main">
-            <a:off x="609600" y="1809750"/>
-            <a:ext cx="10972800" cy="723900"/>
+            <a:off x="609600" y="1952625"/>
+            <a:ext cx="5095875" cy="495300"/>
           </a:xfrm>
           <a:prstGeom xmlns:a="http://schemas.openxmlformats.org/drawingml/2006/main" prst="rect">
             <a:avLst/>
@@ -3337,7 +3483,7 @@
           <a:lstStyle xmlns:a="http://schemas.openxmlformats.org/drawingml/2006/main"/>
           <a:p xmlns:a="http://schemas.openxmlformats.org/drawingml/2006/main">
             <a:pPr>
-              <a:defRPr sz="2250" b="1">
+              <a:defRPr sz="2850" b="1">
                 <a:solidFill>
                   <a:srgbClr val="26756C"/>
                 </a:solidFill>
@@ -3347,7 +3493,7 @@
               </a:defRPr>
             </a:pPr>
             <a:r>
-              <a:rPr sz="2250" b="1">
+              <a:rPr sz="2850" b="1">
                 <a:solidFill>
                   <a:srgbClr val="26756C"/>
                 </a:solidFill>
@@ -3355,360 +3501,17 @@
                 <a:ea typeface="Helvetica Neue"/>
                 <a:cs typeface="Helvetica Neue"/>
               </a:rPr>
-              <a:t>SSDF 1.1 задаёт процесс. ASVS 5.0.0 уточняет свойства веб-приложения.</a:t>
-            </a:r>
-          </a:p>
-        </p:txBody>
-      </p:sp>
-      <p:graphicFrame>
-        <p:nvGraphicFramePr>
-          <p:cNvPr id="13" name=""/>
-          <p:cNvGraphicFramePr/>
-          <p:nvPr/>
-        </p:nvGraphicFramePr>
-        <p:xfrm>
-          <a:off xmlns:a="http://schemas.openxmlformats.org/drawingml/2006/main" x="609600" y="2790825"/>
-          <a:ext xmlns:a="http://schemas.openxmlformats.org/drawingml/2006/main" cx="10972800" cy="2552700"/>
-        </p:xfrm>
-        <a:graphic xmlns:a="http://schemas.openxmlformats.org/drawingml/2006/main">
-          <a:graphicData uri="http://schemas.openxmlformats.org/drawingml/2006/table">
-            <a:tbl>
-              <a:tblPr/>
-              <a:tblGrid>
-                <a:gridCol w="2781300"/>
-                <a:gridCol w="4819650"/>
-                <a:gridCol w="3371850"/>
-              </a:tblGrid>
-              <a:tr h="638175">
-                <a:tc>
-                  <a:txBody>
-                    <a:bodyPr>
-                      <a:noAutofit/>
-                    </a:bodyPr>
-                    <a:lstStyle/>
-                    <a:p>
-                      <a:r>
-                        <a:rPr sz="1875" b="1">
-                          <a:solidFill>
-                            <a:srgbClr val="FFFFFF"/>
-                          </a:solidFill>
-                          <a:latin typeface="Helvetica Neue"/>
-                          <a:ea typeface="Helvetica Neue"/>
-                          <a:cs typeface="Helvetica Neue"/>
-                        </a:rPr>
-                        <a:t>Основа</a:t>
-                      </a:r>
-                    </a:p>
-                  </a:txBody>
-                  <a:tcPr marL="91440" marR="91440" marT="45720" marB="45720">
-                    <a:solidFill>
-                      <a:srgbClr val="102A30"/>
-                    </a:solidFill>
-                  </a:tcPr>
-                </a:tc>
-                <a:tc>
-                  <a:txBody>
-                    <a:bodyPr>
-                      <a:noAutofit/>
-                    </a:bodyPr>
-                    <a:lstStyle/>
-                    <a:p>
-                      <a:r>
-                        <a:rPr sz="1875" b="1">
-                          <a:solidFill>
-                            <a:srgbClr val="FFFFFF"/>
-                          </a:solidFill>
-                          <a:latin typeface="Helvetica Neue"/>
-                          <a:ea typeface="Helvetica Neue"/>
-                          <a:cs typeface="Helvetica Neue"/>
-                        </a:rPr>
-                        <a:t>Польза для TaskFlow</a:t>
-                      </a:r>
-                    </a:p>
-                  </a:txBody>
-                  <a:tcPr marL="91440" marR="91440" marT="45720" marB="45720">
-                    <a:solidFill>
-                      <a:srgbClr val="102A30"/>
-                    </a:solidFill>
-                  </a:tcPr>
-                </a:tc>
-                <a:tc>
-                  <a:txBody>
-                    <a:bodyPr>
-                      <a:noAutofit/>
-                    </a:bodyPr>
-                    <a:lstStyle/>
-                    <a:p>
-                      <a:r>
-                        <a:rPr sz="1875" b="1">
-                          <a:solidFill>
-                            <a:srgbClr val="FFFFFF"/>
-                          </a:solidFill>
-                          <a:latin typeface="Helvetica Neue"/>
-                          <a:ea typeface="Helvetica Neue"/>
-                          <a:cs typeface="Helvetica Neue"/>
-                        </a:rPr>
-                        <a:t>Решение</a:t>
-                      </a:r>
-                    </a:p>
-                  </a:txBody>
-                  <a:tcPr marL="91440" marR="91440" marT="45720" marB="45720">
-                    <a:solidFill>
-                      <a:srgbClr val="102A30"/>
-                    </a:solidFill>
-                  </a:tcPr>
-                </a:tc>
-              </a:tr>
-              <a:tr h="638175">
-                <a:tc>
-                  <a:txBody>
-                    <a:bodyPr>
-                      <a:noAutofit/>
-                    </a:bodyPr>
-                    <a:lstStyle/>
-                    <a:p>
-                      <a:r>
-                        <a:rPr sz="1875" b="0">
-                          <a:solidFill>
-                            <a:srgbClr val="102A30"/>
-                          </a:solidFill>
-                          <a:latin typeface="Helvetica Neue"/>
-                          <a:ea typeface="Helvetica Neue"/>
-                          <a:cs typeface="Helvetica Neue"/>
-                        </a:rPr>
-                        <a:t>NIST SSDF 1.1</a:t>
-                      </a:r>
-                    </a:p>
-                  </a:txBody>
-                  <a:tcPr marL="91440" marR="91440" marT="45720" marB="45720">
-                    <a:solidFill>
-                      <a:srgbClr val="FFFFFF"/>
-                    </a:solidFill>
-                  </a:tcPr>
-                </a:tc>
-                <a:tc>
-                  <a:txBody>
-                    <a:bodyPr>
-                      <a:noAutofit/>
-                    </a:bodyPr>
-                    <a:lstStyle/>
-                    <a:p>
-                      <a:r>
-                        <a:rPr sz="1875" b="0">
-                          <a:solidFill>
-                            <a:srgbClr val="102A30"/>
-                          </a:solidFill>
-                          <a:latin typeface="Helvetica Neue"/>
-                          <a:ea typeface="Helvetica Neue"/>
-                          <a:cs typeface="Helvetica Neue"/>
-                        </a:rPr>
-                        <a:t>Требования, review, тесты, выпуск</a:t>
-                      </a:r>
-                    </a:p>
-                  </a:txBody>
-                  <a:tcPr marL="91440" marR="91440" marT="45720" marB="45720">
-                    <a:solidFill>
-                      <a:srgbClr val="FFFFFF"/>
-                    </a:solidFill>
-                  </a:tcPr>
-                </a:tc>
-                <a:tc>
-                  <a:txBody>
-                    <a:bodyPr>
-                      <a:noAutofit/>
-                    </a:bodyPr>
-                    <a:lstStyle/>
-                    <a:p>
-                      <a:r>
-                        <a:rPr sz="1875" b="0">
-                          <a:solidFill>
-                            <a:srgbClr val="102A30"/>
-                          </a:solidFill>
-                          <a:latin typeface="Helvetica Neue"/>
-                          <a:ea typeface="Helvetica Neue"/>
-                          <a:cs typeface="Helvetica Neue"/>
-                        </a:rPr>
-                        <a:t>Основная рамка</a:t>
-                      </a:r>
-                    </a:p>
-                  </a:txBody>
-                  <a:tcPr marL="91440" marR="91440" marT="45720" marB="45720">
-                    <a:solidFill>
-                      <a:srgbClr val="FFFFFF"/>
-                    </a:solidFill>
-                  </a:tcPr>
-                </a:tc>
-              </a:tr>
-              <a:tr h="638175">
-                <a:tc>
-                  <a:txBody>
-                    <a:bodyPr>
-                      <a:noAutofit/>
-                    </a:bodyPr>
-                    <a:lstStyle/>
-                    <a:p>
-                      <a:r>
-                        <a:rPr sz="1875" b="0">
-                          <a:solidFill>
-                            <a:srgbClr val="102A30"/>
-                          </a:solidFill>
-                          <a:latin typeface="Helvetica Neue"/>
-                          <a:ea typeface="Helvetica Neue"/>
-                          <a:cs typeface="Helvetica Neue"/>
-                        </a:rPr>
-                        <a:t>OWASP SAMM 2</a:t>
-                      </a:r>
-                    </a:p>
-                  </a:txBody>
-                  <a:tcPr marL="91440" marR="91440" marT="45720" marB="45720">
-                    <a:solidFill>
-                      <a:srgbClr val="F7F6F1"/>
-                    </a:solidFill>
-                  </a:tcPr>
-                </a:tc>
-                <a:tc>
-                  <a:txBody>
-                    <a:bodyPr>
-                      <a:noAutofit/>
-                    </a:bodyPr>
-                    <a:lstStyle/>
-                    <a:p>
-                      <a:r>
-                        <a:rPr sz="1875" b="0">
-                          <a:solidFill>
-                            <a:srgbClr val="102A30"/>
-                          </a:solidFill>
-                          <a:latin typeface="Helvetica Neue"/>
-                          <a:ea typeface="Helvetica Neue"/>
-                          <a:cs typeface="Helvetica Neue"/>
-                        </a:rPr>
-                        <a:t>Оценка устойчивости практик</a:t>
-                      </a:r>
-                    </a:p>
-                  </a:txBody>
-                  <a:tcPr marL="91440" marR="91440" marT="45720" marB="45720">
-                    <a:solidFill>
-                      <a:srgbClr val="F7F6F1"/>
-                    </a:solidFill>
-                  </a:tcPr>
-                </a:tc>
-                <a:tc>
-                  <a:txBody>
-                    <a:bodyPr>
-                      <a:noAutofit/>
-                    </a:bodyPr>
-                    <a:lstStyle/>
-                    <a:p>
-                      <a:r>
-                        <a:rPr sz="1875" b="0">
-                          <a:solidFill>
-                            <a:srgbClr val="102A30"/>
-                          </a:solidFill>
-                          <a:latin typeface="Helvetica Neue"/>
-                          <a:ea typeface="Helvetica Neue"/>
-                          <a:cs typeface="Helvetica Neue"/>
-                        </a:rPr>
-                        <a:t>Мало истории для оценки</a:t>
-                      </a:r>
-                    </a:p>
-                  </a:txBody>
-                  <a:tcPr marL="91440" marR="91440" marT="45720" marB="45720">
-                    <a:solidFill>
-                      <a:srgbClr val="F7F6F1"/>
-                    </a:solidFill>
-                  </a:tcPr>
-                </a:tc>
-              </a:tr>
-              <a:tr h="638175">
-                <a:tc>
-                  <a:txBody>
-                    <a:bodyPr>
-                      <a:noAutofit/>
-                    </a:bodyPr>
-                    <a:lstStyle/>
-                    <a:p>
-                      <a:r>
-                        <a:rPr sz="1875" b="0">
-                          <a:solidFill>
-                            <a:srgbClr val="102A30"/>
-                          </a:solidFill>
-                          <a:latin typeface="Helvetica Neue"/>
-                          <a:ea typeface="Helvetica Neue"/>
-                          <a:cs typeface="Helvetica Neue"/>
-                        </a:rPr>
-                        <a:t>ГОСТ Р 56939-2024</a:t>
-                      </a:r>
-                    </a:p>
-                  </a:txBody>
-                  <a:tcPr marL="91440" marR="91440" marT="45720" marB="45720">
-                    <a:solidFill>
-                      <a:srgbClr val="FFFFFF"/>
-                    </a:solidFill>
-                  </a:tcPr>
-                </a:tc>
-                <a:tc>
-                  <a:txBody>
-                    <a:bodyPr>
-                      <a:noAutofit/>
-                    </a:bodyPr>
-                    <a:lstStyle/>
-                    <a:p>
-                      <a:r>
-                        <a:rPr sz="1875" b="0">
-                          <a:solidFill>
-                            <a:srgbClr val="102A30"/>
-                          </a:solidFill>
-                          <a:latin typeface="Helvetica Neue"/>
-                          <a:ea typeface="Helvetica Neue"/>
-                          <a:cs typeface="Helvetica Neue"/>
-                        </a:rPr>
-                        <a:t>Требования к работам разработки</a:t>
-                      </a:r>
-                    </a:p>
-                  </a:txBody>
-                  <a:tcPr marL="91440" marR="91440" marT="45720" marB="45720">
-                    <a:solidFill>
-                      <a:srgbClr val="FFFFFF"/>
-                    </a:solidFill>
-                  </a:tcPr>
-                </a:tc>
-                <a:tc>
-                  <a:txBody>
-                    <a:bodyPr>
-                      <a:noAutofit/>
-                    </a:bodyPr>
-                    <a:lstStyle/>
-                    <a:p>
-                      <a:r>
-                        <a:rPr sz="1875" b="0">
-                          <a:solidFill>
-                            <a:srgbClr val="102A30"/>
-                          </a:solidFill>
-                          <a:latin typeface="Helvetica Neue"/>
-                          <a:ea typeface="Helvetica Neue"/>
-                          <a:cs typeface="Helvetica Neue"/>
-                        </a:rPr>
-                        <a:t>Применимая альтернатива</a:t>
-                      </a:r>
-                    </a:p>
-                  </a:txBody>
-                  <a:tcPr marL="91440" marR="91440" marT="45720" marB="45720">
-                    <a:solidFill>
-                      <a:srgbClr val="FFFFFF"/>
-                    </a:solidFill>
-                  </a:tcPr>
-                </a:tc>
-              </a:tr>
-            </a:tbl>
-          </a:graphicData>
-        </a:graphic>
-      </p:graphicFrame>
-      <p:sp>
-        <p:nvSpPr>
-          <p:cNvPr id="7" name="">
+              <a:t>SSDF 1.1</a:t>
+            </a:r>
+          </a:p>
+        </p:txBody>
+      </p:sp>
+      <p:sp>
+        <p:nvSpPr>
+          <p:cNvPr id="10" name="">
             <a:extLst xmlns:a="http://schemas.openxmlformats.org/drawingml/2006/main">
               <a:ext uri="{FF2B5EF4-FFF2-40B4-BE49-F238E27FC236}">
-                <a16:creationId xmlns:a16="http://schemas.microsoft.com/office/drawing/2014/main" id="{E84E6F0E-8655-43FF-974B-6E4533BEC21F}"/>
+                <a16:creationId xmlns:a16="http://schemas.microsoft.com/office/drawing/2014/main" id="{CFE112CA-F979-42F0-98F4-79CB90858A78}"/>
               </a:ext>
             </a:extLst>
           </p:cNvPr>
@@ -3719,8 +3522,8 @@
         </p:nvSpPr>
         <p:spPr>
           <a:xfrm xmlns:a="http://schemas.openxmlformats.org/drawingml/2006/main">
-            <a:off x="609600" y="5572125"/>
-            <a:ext cx="10972800" cy="647700"/>
+            <a:off x="609600" y="2600325"/>
+            <a:ext cx="5143500" cy="762000"/>
           </a:xfrm>
           <a:prstGeom xmlns:a="http://schemas.openxmlformats.org/drawingml/2006/main" prst="rect">
             <a:avLst/>
@@ -3737,48 +3540,458 @@
           <a:lstStyle xmlns:a="http://schemas.openxmlformats.org/drawingml/2006/main"/>
           <a:p xmlns:a="http://schemas.openxmlformats.org/drawingml/2006/main">
             <a:pPr>
-              <a:defRPr sz="1875" b="0">
-                <a:solidFill>
-                  <a:srgbClr val="102A30"/>
-                </a:solidFill>
-                <a:latin typeface="Helvetica Neue"/>
-                <a:ea typeface="Helvetica Neue"/>
-                <a:cs typeface="Helvetica Neue"/>
-              </a:defRPr>
-            </a:pPr>
-            <a:r>
-              <a:rPr sz="1875" b="0">
-                <a:solidFill>
-                  <a:srgbClr val="102A30"/>
-                </a:solidFill>
-                <a:latin typeface="Helvetica Neue"/>
-                <a:ea typeface="Helvetica Neue"/>
-                <a:cs typeface="Helvetica Neue"/>
-              </a:rPr>
-              <a:t>Семь правил для двух участников и открытый первоисточник.</a:t>
-            </a:r>
-          </a:p>
-          <a:p xmlns:a="http://schemas.openxmlformats.org/drawingml/2006/main">
-            <a:pPr>
-              <a:defRPr sz="1875" b="0">
-                <a:solidFill>
-                  <a:srgbClr val="102A30"/>
-                </a:solidFill>
-                <a:latin typeface="Helvetica Neue"/>
-                <a:ea typeface="Helvetica Neue"/>
-                <a:cs typeface="Helvetica Neue"/>
-              </a:defRPr>
-            </a:pPr>
-            <a:r>
-              <a:rPr sz="1875" b="0">
-                <a:solidFill>
-                  <a:srgbClr val="102A30"/>
-                </a:solidFill>
-                <a:latin typeface="Helvetica Neue"/>
-                <a:ea typeface="Helvetica Neue"/>
-                <a:cs typeface="Helvetica Neue"/>
-              </a:rPr>
-              <a:t>ASVS дополняет технические проверки доступа, сессий и ввода.</a:t>
+              <a:defRPr sz="2400" b="1">
+                <a:solidFill>
+                  <a:srgbClr val="102A30"/>
+                </a:solidFill>
+                <a:latin typeface="Helvetica Neue"/>
+                <a:ea typeface="Helvetica Neue"/>
+                <a:cs typeface="Helvetica Neue"/>
+              </a:defRPr>
+            </a:pPr>
+            <a:r>
+              <a:rPr sz="2400" b="1">
+                <a:solidFill>
+                  <a:srgbClr val="102A30"/>
+                </a:solidFill>
+                <a:latin typeface="Helvetica Neue"/>
+                <a:ea typeface="Helvetica Neue"/>
+                <a:cs typeface="Helvetica Neue"/>
+              </a:rPr>
+              <a:t>Как организуем разработку</a:t>
+            </a:r>
+          </a:p>
+        </p:txBody>
+      </p:sp>
+      <p:sp>
+        <p:nvSpPr>
+          <p:cNvPr id="11" name="">
+            <a:extLst xmlns:a="http://schemas.openxmlformats.org/drawingml/2006/main">
+              <a:ext uri="{FF2B5EF4-FFF2-40B4-BE49-F238E27FC236}">
+                <a16:creationId xmlns:a16="http://schemas.microsoft.com/office/drawing/2014/main" id="{EC210CF2-132F-4AD7-8627-43A481324872}"/>
+              </a:ext>
+            </a:extLst>
+          </p:cNvPr>
+          <p:cNvSpPr>
+            <a:spLocks xmlns:a="http://schemas.openxmlformats.org/drawingml/2006/main" noGrp="1"/>
+          </p:cNvSpPr>
+          <p:nvPr/>
+        </p:nvSpPr>
+        <p:spPr>
+          <a:xfrm xmlns:a="http://schemas.openxmlformats.org/drawingml/2006/main">
+            <a:off x="609600" y="3448050"/>
+            <a:ext cx="5162550" cy="1857375"/>
+          </a:xfrm>
+          <a:prstGeom xmlns:a="http://schemas.openxmlformats.org/drawingml/2006/main" prst="rect">
+            <a:avLst/>
+          </a:prstGeom>
+          <a:noFill xmlns:a="http://schemas.openxmlformats.org/drawingml/2006/main"/>
+          <a:ln xmlns:a="http://schemas.openxmlformats.org/drawingml/2006/main" w="0">
+            <a:noFill/>
+          </a:ln>
+        </p:spPr>
+        <p:txBody>
+          <a:bodyPr xmlns:a="http://schemas.openxmlformats.org/drawingml/2006/main">
+            <a:noAutofit/>
+          </a:bodyPr>
+          <a:lstStyle xmlns:a="http://schemas.openxmlformats.org/drawingml/2006/main"/>
+          <a:p xmlns:a="http://schemas.openxmlformats.org/drawingml/2006/main">
+            <a:pPr>
+              <a:defRPr sz="2100" b="0">
+                <a:solidFill>
+                  <a:srgbClr val="102A30"/>
+                </a:solidFill>
+                <a:latin typeface="Helvetica Neue"/>
+                <a:ea typeface="Helvetica Neue"/>
+                <a:cs typeface="Helvetica Neue"/>
+              </a:defRPr>
+            </a:pPr>
+            <a:r>
+              <a:rPr sz="2100" b="0">
+                <a:solidFill>
+                  <a:srgbClr val="102A30"/>
+                </a:solidFill>
+                <a:latin typeface="Helvetica Neue"/>
+                <a:ea typeface="Helvetica Neue"/>
+                <a:cs typeface="Helvetica Neue"/>
+              </a:rPr>
+              <a:t>Охватывает работу от требований</a:t>
+            </a:r>
+          </a:p>
+          <a:p xmlns:a="http://schemas.openxmlformats.org/drawingml/2006/main">
+            <a:pPr>
+              <a:defRPr sz="2100" b="0">
+                <a:solidFill>
+                  <a:srgbClr val="102A30"/>
+                </a:solidFill>
+                <a:latin typeface="Helvetica Neue"/>
+                <a:ea typeface="Helvetica Neue"/>
+                <a:cs typeface="Helvetica Neue"/>
+              </a:defRPr>
+            </a:pPr>
+            <a:r>
+              <a:rPr sz="2100" b="0">
+                <a:solidFill>
+                  <a:srgbClr val="102A30"/>
+                </a:solidFill>
+                <a:latin typeface="Helvetica Neue"/>
+                <a:ea typeface="Helvetica Neue"/>
+                <a:cs typeface="Helvetica Neue"/>
+              </a:rPr>
+              <a:t>до выпуска и исправлений.</a:t>
+            </a:r>
+          </a:p>
+          <a:p xmlns:a="http://schemas.openxmlformats.org/drawingml/2006/main">
+            <a:r>
+              <a:t/>
+            </a:r>
+          </a:p>
+          <a:p xmlns:a="http://schemas.openxmlformats.org/drawingml/2006/main">
+            <a:pPr>
+              <a:defRPr sz="2100" b="0">
+                <a:solidFill>
+                  <a:srgbClr val="102A30"/>
+                </a:solidFill>
+                <a:latin typeface="Helvetica Neue"/>
+                <a:ea typeface="Helvetica Neue"/>
+                <a:cs typeface="Helvetica Neue"/>
+              </a:defRPr>
+            </a:pPr>
+            <a:r>
+              <a:rPr sz="2100" b="0">
+                <a:solidFill>
+                  <a:srgbClr val="102A30"/>
+                </a:solidFill>
+                <a:latin typeface="Helvetica Neue"/>
+                <a:ea typeface="Helvetica Neue"/>
+                <a:cs typeface="Helvetica Neue"/>
+              </a:rPr>
+              <a:t>Выбрали 7 правил для двух человек.</a:t>
+            </a:r>
+          </a:p>
+          <a:p xmlns:a="http://schemas.openxmlformats.org/drawingml/2006/main">
+            <a:pPr>
+              <a:defRPr sz="2100" b="0">
+                <a:solidFill>
+                  <a:srgbClr val="102A30"/>
+                </a:solidFill>
+                <a:latin typeface="Helvetica Neue"/>
+                <a:ea typeface="Helvetica Neue"/>
+                <a:cs typeface="Helvetica Neue"/>
+              </a:defRPr>
+            </a:pPr>
+            <a:r>
+              <a:rPr sz="2100" b="0">
+                <a:solidFill>
+                  <a:srgbClr val="102A30"/>
+                </a:solidFill>
+                <a:latin typeface="Helvetica Neue"/>
+                <a:ea typeface="Helvetica Neue"/>
+                <a:cs typeface="Helvetica Neue"/>
+              </a:rPr>
+              <a:t>Полный текст доступен открыто.</a:t>
+            </a:r>
+          </a:p>
+        </p:txBody>
+      </p:sp>
+      <p:sp>
+        <p:nvSpPr>
+          <p:cNvPr id="12" name="">
+            <a:extLst xmlns:a="http://schemas.openxmlformats.org/drawingml/2006/main">
+              <a:ext uri="{FF2B5EF4-FFF2-40B4-BE49-F238E27FC236}">
+                <a16:creationId xmlns:a16="http://schemas.microsoft.com/office/drawing/2014/main" id="{F31D05F6-E9E3-4F14-8A81-6C09014D2DF4}"/>
+              </a:ext>
+            </a:extLst>
+          </p:cNvPr>
+          <p:cNvSpPr>
+            <a:spLocks xmlns:a="http://schemas.openxmlformats.org/drawingml/2006/main" noGrp="1"/>
+          </p:cNvSpPr>
+          <p:nvPr/>
+        </p:nvSpPr>
+        <p:spPr>
+          <a:xfrm xmlns:a="http://schemas.openxmlformats.org/drawingml/2006/main">
+            <a:off x="6324600" y="1952625"/>
+            <a:ext cx="5238750" cy="495300"/>
+          </a:xfrm>
+          <a:prstGeom xmlns:a="http://schemas.openxmlformats.org/drawingml/2006/main" prst="rect">
+            <a:avLst/>
+          </a:prstGeom>
+          <a:noFill xmlns:a="http://schemas.openxmlformats.org/drawingml/2006/main"/>
+          <a:ln xmlns:a="http://schemas.openxmlformats.org/drawingml/2006/main" w="0">
+            <a:noFill/>
+          </a:ln>
+        </p:spPr>
+        <p:txBody>
+          <a:bodyPr xmlns:a="http://schemas.openxmlformats.org/drawingml/2006/main">
+            <a:noAutofit/>
+          </a:bodyPr>
+          <a:lstStyle xmlns:a="http://schemas.openxmlformats.org/drawingml/2006/main"/>
+          <a:p xmlns:a="http://schemas.openxmlformats.org/drawingml/2006/main">
+            <a:pPr>
+              <a:defRPr sz="2850" b="1">
+                <a:solidFill>
+                  <a:srgbClr val="26756C"/>
+                </a:solidFill>
+                <a:latin typeface="Helvetica Neue"/>
+                <a:ea typeface="Helvetica Neue"/>
+                <a:cs typeface="Helvetica Neue"/>
+              </a:defRPr>
+            </a:pPr>
+            <a:r>
+              <a:rPr sz="2850" b="1">
+                <a:solidFill>
+                  <a:srgbClr val="26756C"/>
+                </a:solidFill>
+                <a:latin typeface="Helvetica Neue"/>
+                <a:ea typeface="Helvetica Neue"/>
+                <a:cs typeface="Helvetica Neue"/>
+              </a:rPr>
+              <a:t>ASVS 5.0.0</a:t>
+            </a:r>
+          </a:p>
+        </p:txBody>
+      </p:sp>
+      <p:sp>
+        <p:nvSpPr>
+          <p:cNvPr id="13" name="">
+            <a:extLst xmlns:a="http://schemas.openxmlformats.org/drawingml/2006/main">
+              <a:ext uri="{FF2B5EF4-FFF2-40B4-BE49-F238E27FC236}">
+                <a16:creationId xmlns:a16="http://schemas.microsoft.com/office/drawing/2014/main" id="{6BE650CD-1C1C-495E-9968-F63818679045}"/>
+              </a:ext>
+            </a:extLst>
+          </p:cNvPr>
+          <p:cNvSpPr>
+            <a:spLocks xmlns:a="http://schemas.openxmlformats.org/drawingml/2006/main" noGrp="1"/>
+          </p:cNvSpPr>
+          <p:nvPr/>
+        </p:nvSpPr>
+        <p:spPr>
+          <a:xfrm xmlns:a="http://schemas.openxmlformats.org/drawingml/2006/main">
+            <a:off x="6324600" y="2600325"/>
+            <a:ext cx="5238750" cy="762000"/>
+          </a:xfrm>
+          <a:prstGeom xmlns:a="http://schemas.openxmlformats.org/drawingml/2006/main" prst="rect">
+            <a:avLst/>
+          </a:prstGeom>
+          <a:noFill xmlns:a="http://schemas.openxmlformats.org/drawingml/2006/main"/>
+          <a:ln xmlns:a="http://schemas.openxmlformats.org/drawingml/2006/main" w="0">
+            <a:noFill/>
+          </a:ln>
+        </p:spPr>
+        <p:txBody>
+          <a:bodyPr xmlns:a="http://schemas.openxmlformats.org/drawingml/2006/main">
+            <a:noAutofit/>
+          </a:bodyPr>
+          <a:lstStyle xmlns:a="http://schemas.openxmlformats.org/drawingml/2006/main"/>
+          <a:p xmlns:a="http://schemas.openxmlformats.org/drawingml/2006/main">
+            <a:pPr>
+              <a:defRPr sz="2400" b="1">
+                <a:solidFill>
+                  <a:srgbClr val="102A30"/>
+                </a:solidFill>
+                <a:latin typeface="Helvetica Neue"/>
+                <a:ea typeface="Helvetica Neue"/>
+                <a:cs typeface="Helvetica Neue"/>
+              </a:defRPr>
+            </a:pPr>
+            <a:r>
+              <a:rPr sz="2400" b="1">
+                <a:solidFill>
+                  <a:srgbClr val="102A30"/>
+                </a:solidFill>
+                <a:latin typeface="Helvetica Neue"/>
+                <a:ea typeface="Helvetica Neue"/>
+                <a:cs typeface="Helvetica Neue"/>
+              </a:rPr>
+              <a:t>Что проверяем в приложении</a:t>
+            </a:r>
+          </a:p>
+        </p:txBody>
+      </p:sp>
+      <p:sp>
+        <p:nvSpPr>
+          <p:cNvPr id="14" name="">
+            <a:extLst xmlns:a="http://schemas.openxmlformats.org/drawingml/2006/main">
+              <a:ext uri="{FF2B5EF4-FFF2-40B4-BE49-F238E27FC236}">
+                <a16:creationId xmlns:a16="http://schemas.microsoft.com/office/drawing/2014/main" id="{C8A611CC-FA83-44E1-BDCD-7921A27C1606}"/>
+              </a:ext>
+            </a:extLst>
+          </p:cNvPr>
+          <p:cNvSpPr>
+            <a:spLocks xmlns:a="http://schemas.openxmlformats.org/drawingml/2006/main" noGrp="1"/>
+          </p:cNvSpPr>
+          <p:nvPr/>
+        </p:nvSpPr>
+        <p:spPr>
+          <a:xfrm xmlns:a="http://schemas.openxmlformats.org/drawingml/2006/main">
+            <a:off x="6324600" y="3448050"/>
+            <a:ext cx="5238750" cy="1857375"/>
+          </a:xfrm>
+          <a:prstGeom xmlns:a="http://schemas.openxmlformats.org/drawingml/2006/main" prst="rect">
+            <a:avLst/>
+          </a:prstGeom>
+          <a:noFill xmlns:a="http://schemas.openxmlformats.org/drawingml/2006/main"/>
+          <a:ln xmlns:a="http://schemas.openxmlformats.org/drawingml/2006/main" w="0">
+            <a:noFill/>
+          </a:ln>
+        </p:spPr>
+        <p:txBody>
+          <a:bodyPr xmlns:a="http://schemas.openxmlformats.org/drawingml/2006/main">
+            <a:noAutofit/>
+          </a:bodyPr>
+          <a:lstStyle xmlns:a="http://schemas.openxmlformats.org/drawingml/2006/main"/>
+          <a:p xmlns:a="http://schemas.openxmlformats.org/drawingml/2006/main">
+            <a:pPr>
+              <a:defRPr sz="2100" b="0">
+                <a:solidFill>
+                  <a:srgbClr val="102A30"/>
+                </a:solidFill>
+                <a:latin typeface="Helvetica Neue"/>
+                <a:ea typeface="Helvetica Neue"/>
+                <a:cs typeface="Helvetica Neue"/>
+              </a:defRPr>
+            </a:pPr>
+            <a:r>
+              <a:rPr sz="2100" b="0">
+                <a:solidFill>
+                  <a:srgbClr val="102A30"/>
+                </a:solidFill>
+                <a:latin typeface="Helvetica Neue"/>
+                <a:ea typeface="Helvetica Neue"/>
+                <a:cs typeface="Helvetica Neue"/>
+              </a:rPr>
+              <a:t>Даёт конкретные требования</a:t>
+            </a:r>
+          </a:p>
+          <a:p xmlns:a="http://schemas.openxmlformats.org/drawingml/2006/main">
+            <a:pPr>
+              <a:defRPr sz="2100" b="0">
+                <a:solidFill>
+                  <a:srgbClr val="102A30"/>
+                </a:solidFill>
+                <a:latin typeface="Helvetica Neue"/>
+                <a:ea typeface="Helvetica Neue"/>
+                <a:cs typeface="Helvetica Neue"/>
+              </a:defRPr>
+            </a:pPr>
+            <a:r>
+              <a:rPr sz="2100" b="0">
+                <a:solidFill>
+                  <a:srgbClr val="102A30"/>
+                </a:solidFill>
+                <a:latin typeface="Helvetica Neue"/>
+                <a:ea typeface="Helvetica Neue"/>
+                <a:cs typeface="Helvetica Neue"/>
+              </a:rPr>
+              <a:t>к безопасности веб-приложений.</a:t>
+            </a:r>
+          </a:p>
+          <a:p xmlns:a="http://schemas.openxmlformats.org/drawingml/2006/main">
+            <a:r>
+              <a:t/>
+            </a:r>
+          </a:p>
+          <a:p xmlns:a="http://schemas.openxmlformats.org/drawingml/2006/main">
+            <a:pPr>
+              <a:defRPr sz="2100" b="0">
+                <a:solidFill>
+                  <a:srgbClr val="102A30"/>
+                </a:solidFill>
+                <a:latin typeface="Helvetica Neue"/>
+                <a:ea typeface="Helvetica Neue"/>
+                <a:cs typeface="Helvetica Neue"/>
+              </a:defRPr>
+            </a:pPr>
+            <a:r>
+              <a:rPr sz="2100" b="0">
+                <a:solidFill>
+                  <a:srgbClr val="102A30"/>
+                </a:solidFill>
+                <a:latin typeface="Helvetica Neue"/>
+                <a:ea typeface="Helvetica Neue"/>
+                <a:cs typeface="Helvetica Neue"/>
+              </a:rPr>
+              <a:t>Уточняет проверки прав доступа,</a:t>
+            </a:r>
+          </a:p>
+          <a:p xmlns:a="http://schemas.openxmlformats.org/drawingml/2006/main">
+            <a:pPr>
+              <a:defRPr sz="2100" b="0">
+                <a:solidFill>
+                  <a:srgbClr val="102A30"/>
+                </a:solidFill>
+                <a:latin typeface="Helvetica Neue"/>
+                <a:ea typeface="Helvetica Neue"/>
+                <a:cs typeface="Helvetica Neue"/>
+              </a:defRPr>
+            </a:pPr>
+            <a:r>
+              <a:rPr sz="2100" b="0">
+                <a:solidFill>
+                  <a:srgbClr val="102A30"/>
+                </a:solidFill>
+                <a:latin typeface="Helvetica Neue"/>
+                <a:ea typeface="Helvetica Neue"/>
+                <a:cs typeface="Helvetica Neue"/>
+              </a:rPr>
+              <a:t>входа и обработки текста.</a:t>
+            </a:r>
+          </a:p>
+        </p:txBody>
+      </p:sp>
+      <p:sp>
+        <p:nvSpPr>
+          <p:cNvPr id="15" name="">
+            <a:extLst xmlns:a="http://schemas.openxmlformats.org/drawingml/2006/main">
+              <a:ext uri="{FF2B5EF4-FFF2-40B4-BE49-F238E27FC236}">
+                <a16:creationId xmlns:a16="http://schemas.microsoft.com/office/drawing/2014/main" id="{6CF7E8AF-0587-4A51-A141-FF6EAE8A5F21}"/>
+              </a:ext>
+            </a:extLst>
+          </p:cNvPr>
+          <p:cNvSpPr>
+            <a:spLocks xmlns:a="http://schemas.openxmlformats.org/drawingml/2006/main" noGrp="1"/>
+          </p:cNvSpPr>
+          <p:nvPr/>
+        </p:nvSpPr>
+        <p:spPr>
+          <a:xfrm xmlns:a="http://schemas.openxmlformats.org/drawingml/2006/main">
+            <a:off x="609600" y="5629275"/>
+            <a:ext cx="10972800" cy="628650"/>
+          </a:xfrm>
+          <a:prstGeom xmlns:a="http://schemas.openxmlformats.org/drawingml/2006/main" prst="rect">
+            <a:avLst/>
+          </a:prstGeom>
+          <a:noFill xmlns:a="http://schemas.openxmlformats.org/drawingml/2006/main"/>
+          <a:ln xmlns:a="http://schemas.openxmlformats.org/drawingml/2006/main" w="0">
+            <a:noFill/>
+          </a:ln>
+        </p:spPr>
+        <p:txBody>
+          <a:bodyPr xmlns:a="http://schemas.openxmlformats.org/drawingml/2006/main">
+            <a:noAutofit/>
+          </a:bodyPr>
+          <a:lstStyle xmlns:a="http://schemas.openxmlformats.org/drawingml/2006/main"/>
+          <a:p xmlns:a="http://schemas.openxmlformats.org/drawingml/2006/main">
+            <a:pPr>
+              <a:defRPr sz="2100" b="1">
+                <a:solidFill>
+                  <a:srgbClr val="26756C"/>
+                </a:solidFill>
+                <a:latin typeface="Helvetica Neue"/>
+                <a:ea typeface="Helvetica Neue"/>
+                <a:cs typeface="Helvetica Neue"/>
+              </a:defRPr>
+            </a:pPr>
+            <a:r>
+              <a:rPr sz="2100" b="1">
+                <a:solidFill>
+                  <a:srgbClr val="26756C"/>
+                </a:solidFill>
+                <a:latin typeface="Helvetica Neue"/>
+                <a:ea typeface="Helvetica Neue"/>
+                <a:cs typeface="Helvetica Neue"/>
+              </a:rPr>
+              <a:t>SSDF задаёт порядок работы. ASVS уточняет технические требования.</a:t>
             </a:r>
           </a:p>
         </p:txBody>
@@ -3846,6 +4059,7 @@
           <a:lstStyle xmlns:a="http://schemas.openxmlformats.org/drawingml/2006/main"/>
           <a:p xmlns:a="http://schemas.openxmlformats.org/drawingml/2006/main">
             <a:pPr>
+              <a:buNone/>
               <a:defRPr sz="1350" b="1">
                 <a:solidFill>
                   <a:srgbClr val="26756C"/>
@@ -3903,6 +4117,7 @@
           <a:lstStyle xmlns:a="http://schemas.openxmlformats.org/drawingml/2006/main"/>
           <a:p xmlns:a="http://schemas.openxmlformats.org/drawingml/2006/main">
             <a:pPr>
+              <a:buNone/>
               <a:defRPr sz="3300" b="1">
                 <a:solidFill>
                   <a:srgbClr val="102A30"/>
@@ -3921,7 +4136,7 @@
                 <a:ea typeface="Helvetica Neue"/>
                 <a:cs typeface="Helvetica Neue"/>
               </a:rPr>
-              <a:t>Одно правило в действии</a:t>
+              <a:t>Почему не выбрали SAMM и ГОСТ</a:t>
             </a:r>
           </a:p>
         </p:txBody>
@@ -3960,6 +4175,7 @@
           <a:lstStyle xmlns:a="http://schemas.openxmlformats.org/drawingml/2006/main"/>
           <a:p xmlns:a="http://schemas.openxmlformats.org/drawingml/2006/main">
             <a:pPr>
+              <a:buNone/>
               <a:defRPr sz="1350" b="0">
                 <a:solidFill>
                   <a:srgbClr val="59686B"/>
@@ -4017,6 +4233,7 @@
           <a:lstStyle xmlns:a="http://schemas.openxmlformats.org/drawingml/2006/main"/>
           <a:p xmlns:a="http://schemas.openxmlformats.org/drawingml/2006/main">
             <a:pPr>
+              <a:buNone/>
               <a:defRPr sz="1800" b="1">
                 <a:solidFill>
                   <a:srgbClr val="26756C"/>
@@ -4036,86 +4253,30 @@
                 <a:cs typeface="Helvetica Neue"/>
               </a:rPr>
               <a:t>04</a:t>
-            </a:r>
-          </a:p>
-        </p:txBody>
-      </p:sp>
-      <p:sp>
-        <p:nvSpPr>
-          <p:cNvPr id="5" name="">
-            <a:extLst xmlns:a="http://schemas.openxmlformats.org/drawingml/2006/main">
-              <a:ext uri="{FF2B5EF4-FFF2-40B4-BE49-F238E27FC236}">
-                <a16:creationId xmlns:a16="http://schemas.microsoft.com/office/drawing/2014/main" id="{2EBFEF88-8900-49AA-857B-B98B094AFE0B}"/>
-              </a:ext>
-            </a:extLst>
-          </p:cNvPr>
-          <p:cNvSpPr>
-            <a:spLocks xmlns:a="http://schemas.openxmlformats.org/drawingml/2006/main" noGrp="1"/>
-          </p:cNvSpPr>
-          <p:nvPr/>
-        </p:nvSpPr>
-        <p:spPr>
-          <a:xfrm xmlns:a="http://schemas.openxmlformats.org/drawingml/2006/main">
-            <a:off x="609600" y="1809750"/>
-            <a:ext cx="10972800" cy="447675"/>
-          </a:xfrm>
-          <a:prstGeom xmlns:a="http://schemas.openxmlformats.org/drawingml/2006/main" prst="rect">
-            <a:avLst/>
-          </a:prstGeom>
-          <a:noFill xmlns:a="http://schemas.openxmlformats.org/drawingml/2006/main"/>
-          <a:ln xmlns:a="http://schemas.openxmlformats.org/drawingml/2006/main" w="0">
-            <a:noFill/>
-          </a:ln>
-        </p:spPr>
-        <p:txBody>
-          <a:bodyPr xmlns:a="http://schemas.openxmlformats.org/drawingml/2006/main">
-            <a:noAutofit/>
-          </a:bodyPr>
-          <a:lstStyle xmlns:a="http://schemas.openxmlformats.org/drawingml/2006/main"/>
-          <a:p xmlns:a="http://schemas.openxmlformats.org/drawingml/2006/main">
-            <a:pPr>
-              <a:defRPr sz="2250" b="1">
-                <a:solidFill>
-                  <a:srgbClr val="26756C"/>
-                </a:solidFill>
-                <a:latin typeface="Helvetica Neue"/>
-                <a:ea typeface="Helvetica Neue"/>
-                <a:cs typeface="Helvetica Neue"/>
-              </a:defRPr>
-            </a:pPr>
-            <a:r>
-              <a:rPr sz="2250" b="1">
-                <a:solidFill>
-                  <a:srgbClr val="26756C"/>
-                </a:solidFill>
-                <a:latin typeface="Helvetica Neue"/>
-                <a:ea typeface="Helvetica Neue"/>
-                <a:cs typeface="Helvetica Neue"/>
-              </a:rPr>
-              <a:t>PW.8.1–8.2: проверка работающего кода</a:t>
             </a:r>
           </a:p>
         </p:txBody>
       </p:sp>
       <p:graphicFrame>
         <p:nvGraphicFramePr>
-          <p:cNvPr id="13" name=""/>
+          <p:cNvPr id="15" name=""/>
           <p:cNvGraphicFramePr/>
           <p:nvPr/>
         </p:nvGraphicFramePr>
         <p:xfrm>
-          <a:off xmlns:a="http://schemas.openxmlformats.org/drawingml/2006/main" x="609600" y="2476500"/>
-          <a:ext xmlns:a="http://schemas.openxmlformats.org/drawingml/2006/main" cx="10972800" cy="3171825"/>
+          <a:off xmlns:a="http://schemas.openxmlformats.org/drawingml/2006/main" x="609600" y="2047875"/>
+          <a:ext xmlns:a="http://schemas.openxmlformats.org/drawingml/2006/main" cx="10972800" cy="3143250"/>
         </p:xfrm>
         <a:graphic xmlns:a="http://schemas.openxmlformats.org/drawingml/2006/main">
           <a:graphicData uri="http://schemas.openxmlformats.org/drawingml/2006/table">
             <a:tbl>
               <a:tblPr/>
               <a:tblGrid>
-                <a:gridCol w="2667000"/>
-                <a:gridCol w="8305800"/>
+                <a:gridCol w="2333625"/>
+                <a:gridCol w="3495675"/>
+                <a:gridCol w="5143500"/>
               </a:tblGrid>
-              <a:tr h="528638">
+              <a:tr h="571500">
                 <a:tc>
                   <a:txBody>
                     <a:bodyPr>
@@ -4124,7 +4285,7 @@
                     <a:lstStyle/>
                     <a:p>
                       <a:r>
-                        <a:rPr sz="1875" b="1">
+                        <a:rPr sz="1950" b="1">
                           <a:solidFill>
                             <a:srgbClr val="FFFFFF"/>
                           </a:solidFill>
@@ -4132,7 +4293,7 @@
                           <a:ea typeface="Helvetica Neue"/>
                           <a:cs typeface="Helvetica Neue"/>
                         </a:rPr>
-                        <a:t>Шаг</a:t>
+                        <a:t>Источник</a:t>
                       </a:r>
                     </a:p>
                   </a:txBody>
@@ -4150,7 +4311,7 @@
                     <a:lstStyle/>
                     <a:p>
                       <a:r>
-                        <a:rPr sz="1875" b="1">
+                        <a:rPr sz="1950" b="1">
                           <a:solidFill>
                             <a:srgbClr val="FFFFFF"/>
                           </a:solidFill>
@@ -4158,7 +4319,33 @@
                           <a:ea typeface="Helvetica Neue"/>
                           <a:cs typeface="Helvetica Neue"/>
                         </a:rPr>
-                        <a:t>Пример для прав доступа</a:t>
+                        <a:t>Зачем рассмотрели</a:t>
+                      </a:r>
+                    </a:p>
+                  </a:txBody>
+                  <a:tcPr marL="91440" marR="91440" marT="45720" marB="45720">
+                    <a:solidFill>
+                      <a:srgbClr val="102A30"/>
+                    </a:solidFill>
+                  </a:tcPr>
+                </a:tc>
+                <a:tc>
+                  <a:txBody>
+                    <a:bodyPr>
+                      <a:noAutofit/>
+                    </a:bodyPr>
+                    <a:lstStyle/>
+                    <a:p>
+                      <a:r>
+                        <a:rPr sz="1950" b="1">
+                          <a:solidFill>
+                            <a:srgbClr val="FFFFFF"/>
+                          </a:solidFill>
+                          <a:latin typeface="Helvetica Neue"/>
+                          <a:ea typeface="Helvetica Neue"/>
+                          <a:cs typeface="Helvetica Neue"/>
+                        </a:rPr>
+                        <a:t>Почему не взяли за основу</a:t>
                       </a:r>
                     </a:p>
                   </a:txBody>
@@ -4169,7 +4356,7 @@
                   </a:tcPr>
                 </a:tc>
               </a:tr>
-              <a:tr h="528638">
+              <a:tr h="1285875">
                 <a:tc>
                   <a:txBody>
                     <a:bodyPr>
@@ -4178,7 +4365,7 @@
                     <a:lstStyle/>
                     <a:p>
                       <a:r>
-                        <a:rPr sz="1875" b="0">
+                        <a:rPr sz="1950" b="0">
                           <a:solidFill>
                             <a:srgbClr val="102A30"/>
                           </a:solidFill>
@@ -4186,7 +4373,7 @@
                           <a:ea typeface="Helvetica Neue"/>
                           <a:cs typeface="Helvetica Neue"/>
                         </a:rPr>
-                        <a:t>Требование</a:t>
+                        <a:t>OWASP SAMM 2</a:t>
                       </a:r>
                     </a:p>
                   </a:txBody>
@@ -4204,7 +4391,7 @@
                     <a:lstStyle/>
                     <a:p>
                       <a:r>
-                        <a:rPr sz="1875" b="0">
+                        <a:rPr sz="1950" b="0">
                           <a:solidFill>
                             <a:srgbClr val="102A30"/>
                           </a:solidFill>
@@ -4212,7 +4399,85 @@
                           <a:ea typeface="Helvetica Neue"/>
                           <a:cs typeface="Helvetica Neue"/>
                         </a:rPr>
-                        <a:t>Наблюдатель не изменяет задачу</a:t>
+                        <a:t>Помогает оценивать</a:t>
+                      </a:r>
+                    </a:p>
+                    <a:p>
+                      <a:r>
+                        <a:rPr sz="1950" b="0">
+                          <a:solidFill>
+                            <a:srgbClr val="102A30"/>
+                          </a:solidFill>
+                          <a:latin typeface="Helvetica Neue"/>
+                          <a:ea typeface="Helvetica Neue"/>
+                          <a:cs typeface="Helvetica Neue"/>
+                        </a:rPr>
+                        <a:t>и улучшать практики</a:t>
+                      </a:r>
+                    </a:p>
+                    <a:p>
+                      <a:r>
+                        <a:rPr sz="1950" b="0">
+                          <a:solidFill>
+                            <a:srgbClr val="102A30"/>
+                          </a:solidFill>
+                          <a:latin typeface="Helvetica Neue"/>
+                          <a:ea typeface="Helvetica Neue"/>
+                          <a:cs typeface="Helvetica Neue"/>
+                        </a:rPr>
+                        <a:t>команды</a:t>
+                      </a:r>
+                    </a:p>
+                  </a:txBody>
+                  <a:tcPr marL="91440" marR="91440" marT="45720" marB="45720">
+                    <a:solidFill>
+                      <a:srgbClr val="FFFFFF"/>
+                    </a:solidFill>
+                  </a:tcPr>
+                </a:tc>
+                <a:tc>
+                  <a:txBody>
+                    <a:bodyPr>
+                      <a:noAutofit/>
+                    </a:bodyPr>
+                    <a:lstStyle/>
+                    <a:p>
+                      <a:r>
+                        <a:rPr sz="1950" b="0">
+                          <a:solidFill>
+                            <a:srgbClr val="102A30"/>
+                          </a:solidFill>
+                          <a:latin typeface="Helvetica Neue"/>
+                          <a:ea typeface="Helvetica Neue"/>
+                          <a:cs typeface="Helvetica Neue"/>
+                        </a:rPr>
+                        <a:t>Проект только начат. Мало истории</a:t>
+                      </a:r>
+                    </a:p>
+                    <a:p>
+                      <a:r>
+                        <a:rPr sz="1950" b="0">
+                          <a:solidFill>
+                            <a:srgbClr val="102A30"/>
+                          </a:solidFill>
+                          <a:latin typeface="Helvetica Neue"/>
+                          <a:ea typeface="Helvetica Neue"/>
+                          <a:cs typeface="Helvetica Neue"/>
+                        </a:rPr>
+                        <a:t>для оценки устойчивости практик.</a:t>
+                      </a:r>
+                    </a:p>
+                    <a:p>
+                      <a:r>
+                        <a:rPr sz="1950" b="0">
+                          <a:solidFill>
+                            <a:srgbClr val="102A30"/>
+                          </a:solidFill>
+                          <a:latin typeface="Helvetica Neue"/>
+                          <a:ea typeface="Helvetica Neue"/>
+                          <a:cs typeface="Helvetica Neue"/>
+                        </a:rPr>
+                        <a:t>Сначала устанавливаем правила.</a:t>
                       </a:r>
                     </a:p>
                   </a:txBody>
@@ -4223,7 +4488,7 @@
                   </a:tcPr>
                 </a:tc>
               </a:tr>
-              <a:tr h="528638">
+              <a:tr h="1285875">
                 <a:tc>
                   <a:txBody>
                     <a:bodyPr>
@@ -4232,7 +4497,7 @@
                     <a:lstStyle/>
                     <a:p>
                       <a:r>
-                        <a:rPr sz="1875" b="0">
+                        <a:rPr sz="1950" b="0">
                           <a:solidFill>
                             <a:srgbClr val="102A30"/>
                           </a:solidFill>
@@ -4240,7 +4505,20 @@
                           <a:ea typeface="Helvetica Neue"/>
                           <a:cs typeface="Helvetica Neue"/>
                         </a:rPr>
-                        <a:t>Действие Романа</a:t>
+                        <a:t>ГОСТ Р</a:t>
+                      </a:r>
+                    </a:p>
+                    <a:p>
+                      <a:r>
+                        <a:rPr sz="1950" b="0">
+                          <a:solidFill>
+                            <a:srgbClr val="102A30"/>
+                          </a:solidFill>
+                          <a:latin typeface="Helvetica Neue"/>
+                          <a:ea typeface="Helvetica Neue"/>
+                          <a:cs typeface="Helvetica Neue"/>
+                        </a:rPr>
+                        <a:t>56939-2024</a:t>
                       </a:r>
                     </a:p>
                   </a:txBody>
@@ -4258,7 +4536,7 @@
                     <a:lstStyle/>
                     <a:p>
                       <a:r>
-                        <a:rPr sz="1875" b="0">
+                        <a:rPr sz="1950" b="0">
                           <a:solidFill>
                             <a:srgbClr val="102A30"/>
                           </a:solidFill>
@@ -4266,27 +4544,12 @@
                           <a:ea typeface="Helvetica Neue"/>
                           <a:cs typeface="Helvetica Neue"/>
                         </a:rPr>
-                        <a:t>POST от viewer и такой же POST от editor</a:t>
+                        <a:t>Задаёт требования</a:t>
                       </a:r>
                     </a:p>
-                  </a:txBody>
-                  <a:tcPr marL="91440" marR="91440" marT="45720" marB="45720">
-                    <a:solidFill>
-                      <a:srgbClr val="F7F6F1"/>
-                    </a:solidFill>
-                  </a:tcPr>
-                </a:tc>
-              </a:tr>
-              <a:tr h="528638">
-                <a:tc>
-                  <a:txBody>
-                    <a:bodyPr>
-                      <a:noAutofit/>
-                    </a:bodyPr>
-                    <a:lstStyle/>
                     <a:p>
                       <a:r>
-                        <a:rPr sz="1875" b="0">
+                        <a:rPr sz="1950" b="0">
                           <a:solidFill>
                             <a:srgbClr val="102A30"/>
                           </a:solidFill>
@@ -4294,25 +4557,12 @@
                           <a:ea typeface="Helvetica Neue"/>
                           <a:cs typeface="Helvetica Neue"/>
                         </a:rPr>
-                        <a:t>Результат</a:t>
+                        <a:t>к работам безопасной</a:t>
                       </a:r>
                     </a:p>
-                  </a:txBody>
-                  <a:tcPr marL="91440" marR="91440" marT="45720" marB="45720">
-                    <a:solidFill>
-                      <a:srgbClr val="FFFFFF"/>
-                    </a:solidFill>
-                  </a:tcPr>
-                </a:tc>
-                <a:tc>
-                  <a:txBody>
-                    <a:bodyPr>
-                      <a:noAutofit/>
-                    </a:bodyPr>
-                    <a:lstStyle/>
                     <a:p>
                       <a:r>
-                        <a:rPr sz="1875" b="0">
+                        <a:rPr sz="1950" b="0">
                           <a:solidFill>
                             <a:srgbClr val="102A30"/>
                           </a:solidFill>
@@ -4320,35 +4570,7 @@
                           <a:ea typeface="Helvetica Neue"/>
                           <a:cs typeface="Helvetica Neue"/>
                         </a:rPr>
-                        <a:t>Viewer: отказ, БД без изменений. Editor: запись</a:t>
-                      </a:r>
-                    </a:p>
-                  </a:txBody>
-                  <a:tcPr marL="91440" marR="91440" marT="45720" marB="45720">
-                    <a:solidFill>
-                      <a:srgbClr val="FFFFFF"/>
-                    </a:solidFill>
-                  </a:tcPr>
-                </a:tc>
-              </a:tr>
-              <a:tr h="528638">
-                <a:tc>
-                  <a:txBody>
-                    <a:bodyPr>
-                      <a:noAutofit/>
-                    </a:bodyPr>
-                    <a:lstStyle/>
-                    <a:p>
-                      <a:r>
-                        <a:rPr sz="1875" b="0">
-                          <a:solidFill>
-                            <a:srgbClr val="102A30"/>
-                          </a:solidFill>
-                          <a:latin typeface="Helvetica Neue"/>
-                          <a:ea typeface="Helvetica Neue"/>
-                          <a:cs typeface="Helvetica Neue"/>
-                        </a:rPr>
-                        <a:t>Проверка Ярослава</a:t>
+                        <a:t>разработки</a:t>
                       </a:r>
                     </a:p>
                   </a:txBody>
@@ -4366,7 +4588,7 @@
                     <a:lstStyle/>
                     <a:p>
                       <a:r>
-                        <a:rPr sz="1875" b="0">
+                        <a:rPr sz="1950" b="0">
                           <a:solidFill>
                             <a:srgbClr val="102A30"/>
                           </a:solidFill>
@@ -4374,7 +4596,33 @@
                           <a:ea typeface="Helvetica Neue"/>
                           <a:cs typeface="Helvetica Neue"/>
                         </a:rPr>
-                        <a:t>Самостоятельно повторить запрет и прочитать код</a:t>
+                        <a:t>В задании нет требования брать ГОСТ.</a:t>
+                      </a:r>
+                    </a:p>
+                    <a:p>
+                      <a:r>
+                        <a:rPr sz="1950" b="0">
+                          <a:solidFill>
+                            <a:srgbClr val="102A30"/>
+                          </a:solidFill>
+                          <a:latin typeface="Helvetica Neue"/>
+                          <a:ea typeface="Helvetica Neue"/>
+                          <a:cs typeface="Helvetica Neue"/>
+                        </a:rPr>
+                        <a:t>Для нашей области достаточно SSDF,</a:t>
+                      </a:r>
+                    </a:p>
+                    <a:p>
+                      <a:r>
+                        <a:rPr sz="1950" b="0">
+                          <a:solidFill>
+                            <a:srgbClr val="102A30"/>
+                          </a:solidFill>
+                          <a:latin typeface="Helvetica Neue"/>
+                          <a:ea typeface="Helvetica Neue"/>
+                          <a:cs typeface="Helvetica Neue"/>
+                        </a:rPr>
+                        <a:t>полный текст которого открыт.</a:t>
                       </a:r>
                     </a:p>
                   </a:txBody>
@@ -4385,70 +4633,16 @@
                   </a:tcPr>
                 </a:tc>
               </a:tr>
-              <a:tr h="528638">
-                <a:tc>
-                  <a:txBody>
-                    <a:bodyPr>
-                      <a:noAutofit/>
-                    </a:bodyPr>
-                    <a:lstStyle/>
-                    <a:p>
-                      <a:r>
-                        <a:rPr sz="1875" b="0">
-                          <a:solidFill>
-                            <a:srgbClr val="102A30"/>
-                          </a:solidFill>
-                          <a:latin typeface="Helvetica Neue"/>
-                          <a:ea typeface="Helvetica Neue"/>
-                          <a:cs typeface="Helvetica Neue"/>
-                        </a:rPr>
-                        <a:t>Решение</a:t>
-                      </a:r>
-                    </a:p>
-                  </a:txBody>
-                  <a:tcPr marL="91440" marR="91440" marT="45720" marB="45720">
-                    <a:solidFill>
-                      <a:srgbClr val="FFFFFF"/>
-                    </a:solidFill>
-                  </a:tcPr>
-                </a:tc>
-                <a:tc>
-                  <a:txBody>
-                    <a:bodyPr>
-                      <a:noAutofit/>
-                    </a:bodyPr>
-                    <a:lstStyle/>
-                    <a:p>
-                      <a:r>
-                        <a:rPr sz="1875" b="0">
-                          <a:solidFill>
-                            <a:srgbClr val="102A30"/>
-                          </a:solidFill>
-                          <a:latin typeface="Helvetica Neue"/>
-                          <a:ea typeface="Helvetica Neue"/>
-                          <a:cs typeface="Helvetica Neue"/>
-                        </a:rPr>
-                        <a:t>Несовпадение с требованием блокирует merge</a:t>
-                      </a:r>
-                    </a:p>
-                  </a:txBody>
-                  <a:tcPr marL="91440" marR="91440" marT="45720" marB="45720">
-                    <a:solidFill>
-                      <a:srgbClr val="FFFFFF"/>
-                    </a:solidFill>
-                  </a:tcPr>
-                </a:tc>
-              </a:tr>
             </a:tbl>
           </a:graphicData>
         </a:graphic>
       </p:graphicFrame>
       <p:sp>
         <p:nvSpPr>
-          <p:cNvPr id="7" name="">
+          <p:cNvPr id="10" name="">
             <a:extLst xmlns:a="http://schemas.openxmlformats.org/drawingml/2006/main">
               <a:ext uri="{FF2B5EF4-FFF2-40B4-BE49-F238E27FC236}">
-                <a16:creationId xmlns:a16="http://schemas.microsoft.com/office/drawing/2014/main" id="{A3883D5E-1612-4E94-8323-4D4E117E15C5}"/>
+                <a16:creationId xmlns:a16="http://schemas.microsoft.com/office/drawing/2014/main" id="{0F1252E7-C4FB-417C-9CC7-9E7D2F833BF8}"/>
               </a:ext>
             </a:extLst>
           </p:cNvPr>
@@ -4459,8 +4653,8 @@
         </p:nvSpPr>
         <p:spPr>
           <a:xfrm xmlns:a="http://schemas.openxmlformats.org/drawingml/2006/main">
-            <a:off x="609600" y="5876925"/>
-            <a:ext cx="10972800" cy="381000"/>
+            <a:off x="609600" y="5457825"/>
+            <a:ext cx="10972800" cy="733425"/>
           </a:xfrm>
           <a:prstGeom xmlns:a="http://schemas.openxmlformats.org/drawingml/2006/main" prst="rect">
             <a:avLst/>
@@ -4477,25 +4671,25 @@
           <a:lstStyle xmlns:a="http://schemas.openxmlformats.org/drawingml/2006/main"/>
           <a:p xmlns:a="http://schemas.openxmlformats.org/drawingml/2006/main">
             <a:pPr>
-              <a:defRPr sz="1875" b="0">
-                <a:solidFill>
-                  <a:srgbClr val="102A30"/>
-                </a:solidFill>
-                <a:latin typeface="Helvetica Neue"/>
-                <a:ea typeface="Helvetica Neue"/>
-                <a:cs typeface="Helvetica Neue"/>
-              </a:defRPr>
-            </a:pPr>
-            <a:r>
-              <a:rPr sz="1875" b="0">
-                <a:solidFill>
-                  <a:srgbClr val="102A30"/>
-                </a:solidFill>
-                <a:latin typeface="Helvetica Neue"/>
-                <a:ea typeface="Helvetica Neue"/>
-                <a:cs typeface="Helvetica Neue"/>
-              </a:rPr>
-              <a:t>Сохраняем commit, условия, команду, фактический результат и review.</a:t>
+              <a:defRPr sz="2100" b="1">
+                <a:solidFill>
+                  <a:srgbClr val="26756C"/>
+                </a:solidFill>
+                <a:latin typeface="Helvetica Neue"/>
+                <a:ea typeface="Helvetica Neue"/>
+                <a:cs typeface="Helvetica Neue"/>
+              </a:defRPr>
+            </a:pPr>
+            <a:r>
+              <a:rPr sz="2100" b="1">
+                <a:solidFill>
+                  <a:srgbClr val="26756C"/>
+                </a:solidFill>
+                <a:latin typeface="Helvetica Neue"/>
+                <a:ea typeface="Helvetica Neue"/>
+                <a:cs typeface="Helvetica Neue"/>
+              </a:rPr>
+              <a:t>Оба подхода применимы. Выбор зависит от цели проекта и требований.</a:t>
             </a:r>
           </a:p>
         </p:txBody>
@@ -4563,6 +4757,7 @@
           <a:lstStyle xmlns:a="http://schemas.openxmlformats.org/drawingml/2006/main"/>
           <a:p xmlns:a="http://schemas.openxmlformats.org/drawingml/2006/main">
             <a:pPr>
+              <a:buNone/>
               <a:defRPr sz="1350" b="1">
                 <a:solidFill>
                   <a:srgbClr val="26756C"/>
@@ -4620,6 +4815,7 @@
           <a:lstStyle xmlns:a="http://schemas.openxmlformats.org/drawingml/2006/main"/>
           <a:p xmlns:a="http://schemas.openxmlformats.org/drawingml/2006/main">
             <a:pPr>
+              <a:buNone/>
               <a:defRPr sz="3300" b="1">
                 <a:solidFill>
                   <a:srgbClr val="102A30"/>
@@ -4638,7 +4834,7 @@
                 <a:ea typeface="Helvetica Neue"/>
                 <a:cs typeface="Helvetica Neue"/>
               </a:rPr>
-              <a:t>Текущее состояние и существенный разрыв</a:t>
+              <a:t>Что уже есть и чего не хватает</a:t>
             </a:r>
           </a:p>
         </p:txBody>
@@ -4677,6 +4873,7 @@
           <a:lstStyle xmlns:a="http://schemas.openxmlformats.org/drawingml/2006/main"/>
           <a:p xmlns:a="http://schemas.openxmlformats.org/drawingml/2006/main">
             <a:pPr>
+              <a:buNone/>
               <a:defRPr sz="1350" b="0">
                 <a:solidFill>
                   <a:srgbClr val="59686B"/>
@@ -4734,6 +4931,7 @@
           <a:lstStyle xmlns:a="http://schemas.openxmlformats.org/drawingml/2006/main"/>
           <a:p xmlns:a="http://schemas.openxmlformats.org/drawingml/2006/main">
             <a:pPr>
+              <a:buNone/>
               <a:defRPr sz="1800" b="1">
                 <a:solidFill>
                   <a:srgbClr val="26756C"/>
@@ -4759,10 +4957,10 @@
       </p:sp>
       <p:sp>
         <p:nvSpPr>
-          <p:cNvPr id="5" name="">
+          <p:cNvPr id="12" name="">
             <a:extLst xmlns:a="http://schemas.openxmlformats.org/drawingml/2006/main">
               <a:ext uri="{FF2B5EF4-FFF2-40B4-BE49-F238E27FC236}">
-                <a16:creationId xmlns:a16="http://schemas.microsoft.com/office/drawing/2014/main" id="{6948F4B4-8575-46C0-A782-EEE17DEB4A3E}"/>
+                <a16:creationId xmlns:a16="http://schemas.microsoft.com/office/drawing/2014/main" id="{0C045A3E-C67B-4BBE-B374-55C62D799643}"/>
               </a:ext>
             </a:extLst>
           </p:cNvPr>
@@ -4773,8 +4971,8 @@
         </p:nvSpPr>
         <p:spPr>
           <a:xfrm xmlns:a="http://schemas.openxmlformats.org/drawingml/2006/main">
-            <a:off x="609600" y="1971675"/>
-            <a:ext cx="4238625" cy="781050"/>
+            <a:off x="609600" y="2028825"/>
+            <a:ext cx="5095875" cy="762000"/>
           </a:xfrm>
           <a:prstGeom xmlns:a="http://schemas.openxmlformats.org/drawingml/2006/main" prst="rect">
             <a:avLst/>
@@ -4791,7 +4989,7 @@
           <a:lstStyle xmlns:a="http://schemas.openxmlformats.org/drawingml/2006/main"/>
           <a:p xmlns:a="http://schemas.openxmlformats.org/drawingml/2006/main">
             <a:pPr>
-              <a:defRPr sz="4950" b="1">
+              <a:defRPr sz="3600" b="1">
                 <a:solidFill>
                   <a:srgbClr val="26756C"/>
                 </a:solidFill>
@@ -4801,7 +4999,7 @@
               </a:defRPr>
             </a:pPr>
             <a:r>
-              <a:rPr sz="4950" b="1">
+              <a:rPr sz="3600" b="1">
                 <a:solidFill>
                   <a:srgbClr val="26756C"/>
                 </a:solidFill>
@@ -4809,17 +5007,17 @@
                 <a:ea typeface="Helvetica Neue"/>
                 <a:cs typeface="Helvetica Neue"/>
               </a:rPr>
-              <a:t>27 тестов</a:t>
-            </a:r>
-          </a:p>
-        </p:txBody>
-      </p:sp>
-      <p:sp>
-        <p:nvSpPr>
-          <p:cNvPr id="6" name="">
+              <a:t>27 тестов прошли</a:t>
+            </a:r>
+          </a:p>
+        </p:txBody>
+      </p:sp>
+      <p:sp>
+        <p:nvSpPr>
+          <p:cNvPr id="13" name="">
             <a:extLst xmlns:a="http://schemas.openxmlformats.org/drawingml/2006/main">
               <a:ext uri="{FF2B5EF4-FFF2-40B4-BE49-F238E27FC236}">
-                <a16:creationId xmlns:a16="http://schemas.microsoft.com/office/drawing/2014/main" id="{DB0DD727-F875-4A96-84D8-36442A5F0E18}"/>
+                <a16:creationId xmlns:a16="http://schemas.microsoft.com/office/drawing/2014/main" id="{99F8A746-BEBB-4ED2-BFDF-F310063523A6}"/>
               </a:ext>
             </a:extLst>
           </p:cNvPr>
@@ -4830,8 +5028,8 @@
         </p:nvSpPr>
         <p:spPr>
           <a:xfrm xmlns:a="http://schemas.openxmlformats.org/drawingml/2006/main">
-            <a:off x="609600" y="3028950"/>
-            <a:ext cx="4381500" cy="1266825"/>
+            <a:off x="609600" y="3057525"/>
+            <a:ext cx="4857750" cy="1657350"/>
           </a:xfrm>
           <a:prstGeom xmlns:a="http://schemas.openxmlformats.org/drawingml/2006/main" prst="rect">
             <a:avLst/>
@@ -4866,7 +5064,7 @@
                 <a:ea typeface="Helvetica Neue"/>
                 <a:cs typeface="Helvetica Neue"/>
               </a:rPr>
-              <a:t>5 инженерных проверок прошли.</a:t>
+              <a:t>Результаты и версия кода</a:t>
             </a:r>
           </a:p>
           <a:p xmlns:a="http://schemas.openxmlformats.org/drawingml/2006/main">
@@ -4889,7 +5087,12 @@
                 <a:ea typeface="Helvetica Neue"/>
                 <a:cs typeface="Helvetica Neue"/>
               </a:rPr>
-              <a:t>Версии и хеши кода сохранены.</a:t>
+              <a:t>сохранены в репозитории.</a:t>
+            </a:r>
+          </a:p>
+          <a:p xmlns:a="http://schemas.openxmlformats.org/drawingml/2006/main">
+            <a:r>
+              <a:t/>
             </a:r>
           </a:p>
           <a:p xmlns:a="http://schemas.openxmlformats.org/drawingml/2006/main">
@@ -4912,17 +5115,17 @@
                 <a:ea typeface="Helvetica Neue"/>
                 <a:cs typeface="Helvetica Neue"/>
               </a:rPr>
-              <a:t>Есть успешные запуски CI.</a:t>
-            </a:r>
-          </a:p>
-        </p:txBody>
-      </p:sp>
-      <p:sp>
-        <p:nvSpPr>
-          <p:cNvPr id="7" name="">
+              <a:t>Срез проверки: 04.10.2026</a:t>
+            </a:r>
+          </a:p>
+        </p:txBody>
+      </p:sp>
+      <p:sp>
+        <p:nvSpPr>
+          <p:cNvPr id="14" name="">
             <a:extLst xmlns:a="http://schemas.openxmlformats.org/drawingml/2006/main">
               <a:ext uri="{FF2B5EF4-FFF2-40B4-BE49-F238E27FC236}">
-                <a16:creationId xmlns:a16="http://schemas.microsoft.com/office/drawing/2014/main" id="{8BDD8E09-772E-46B6-BBD2-1A5FC025A657}"/>
+                <a16:creationId xmlns:a16="http://schemas.microsoft.com/office/drawing/2014/main" id="{452308AF-18C7-4A31-BE20-1C5DD28A1318}"/>
               </a:ext>
             </a:extLst>
           </p:cNvPr>
@@ -4933,8 +5136,8 @@
         </p:nvSpPr>
         <p:spPr>
           <a:xfrm xmlns:a="http://schemas.openxmlformats.org/drawingml/2006/main">
-            <a:off x="5562600" y="2076450"/>
-            <a:ext cx="5981700" cy="800100"/>
+            <a:off x="6191250" y="2009775"/>
+            <a:ext cx="5410200" cy="952500"/>
           </a:xfrm>
           <a:prstGeom xmlns:a="http://schemas.openxmlformats.org/drawingml/2006/main" prst="rect">
             <a:avLst/>
@@ -4969,17 +5172,40 @@
                 <a:ea typeface="Helvetica Neue"/>
                 <a:cs typeface="Helvetica Neue"/>
               </a:rPr>
-              <a:t>G1: нет независимого review</a:t>
-            </a:r>
-          </a:p>
-        </p:txBody>
-      </p:sp>
-      <p:sp>
-        <p:nvSpPr>
-          <p:cNvPr id="8" name="">
+              <a:t>Нет сохранённой</a:t>
+            </a:r>
+          </a:p>
+          <a:p xmlns:a="http://schemas.openxmlformats.org/drawingml/2006/main">
+            <a:pPr>
+              <a:defRPr sz="2700" b="1">
+                <a:solidFill>
+                  <a:srgbClr val="102A30"/>
+                </a:solidFill>
+                <a:latin typeface="Helvetica Neue"/>
+                <a:ea typeface="Helvetica Neue"/>
+                <a:cs typeface="Helvetica Neue"/>
+              </a:defRPr>
+            </a:pPr>
+            <a:r>
+              <a:rPr sz="2700" b="1">
+                <a:solidFill>
+                  <a:srgbClr val="102A30"/>
+                </a:solidFill>
+                <a:latin typeface="Helvetica Neue"/>
+                <a:ea typeface="Helvetica Neue"/>
+                <a:cs typeface="Helvetica Neue"/>
+              </a:rPr>
+              <a:t>проверки партнёром</a:t>
+            </a:r>
+          </a:p>
+        </p:txBody>
+      </p:sp>
+      <p:sp>
+        <p:nvSpPr>
+          <p:cNvPr id="15" name="">
             <a:extLst xmlns:a="http://schemas.openxmlformats.org/drawingml/2006/main">
               <a:ext uri="{FF2B5EF4-FFF2-40B4-BE49-F238E27FC236}">
-                <a16:creationId xmlns:a16="http://schemas.microsoft.com/office/drawing/2014/main" id="{58FA0FA6-B78F-406A-B1B3-7D5645F89CCE}"/>
+                <a16:creationId xmlns:a16="http://schemas.microsoft.com/office/drawing/2014/main" id="{D9C2119C-3533-4180-9019-ACC86707BC3C}"/>
               </a:ext>
             </a:extLst>
           </p:cNvPr>
@@ -4990,8 +5216,8 @@
         </p:nvSpPr>
         <p:spPr>
           <a:xfrm xmlns:a="http://schemas.openxmlformats.org/drawingml/2006/main">
-            <a:off x="5562600" y="3143250"/>
-            <a:ext cx="5981700" cy="1447800"/>
+            <a:off x="6191250" y="3162300"/>
+            <a:ext cx="5381625" cy="1714500"/>
           </a:xfrm>
           <a:prstGeom xmlns:a="http://schemas.openxmlformats.org/drawingml/2006/main" prst="rect">
             <a:avLst/>
@@ -5026,7 +5252,7 @@
                 <a:ea typeface="Helvetica Neue"/>
                 <a:cs typeface="Helvetica Neue"/>
               </a:rPr>
-              <a:t>Код и тесты могут повторять</a:t>
+              <a:t>Код и тест могут повторять</a:t>
             </a:r>
           </a:p>
           <a:p xmlns:a="http://schemas.openxmlformats.org/drawingml/2006/main">
@@ -5053,6 +5279,11 @@
             </a:r>
           </a:p>
           <a:p xmlns:a="http://schemas.openxmlformats.org/drawingml/2006/main">
+            <a:r>
+              <a:t/>
+            </a:r>
+          </a:p>
+          <a:p xmlns:a="http://schemas.openxmlformats.org/drawingml/2006/main">
             <a:pPr>
               <a:defRPr sz="2100" b="0">
                 <a:solidFill>
@@ -5072,7 +5303,7 @@
                 <a:ea typeface="Helvetica Neue"/>
                 <a:cs typeface="Helvetica Neue"/>
               </a:rPr>
-              <a:t>В исследованной истории нет PR</a:t>
+              <a:t>Нужно независимо проверить</a:t>
             </a:r>
           </a:p>
           <a:p xmlns:a="http://schemas.openxmlformats.org/drawingml/2006/main">
@@ -5095,17 +5326,17 @@
                 <a:ea typeface="Helvetica Neue"/>
                 <a:cs typeface="Helvetica Neue"/>
               </a:rPr>
-              <a:t>с проверкой вторым участником.</a:t>
-            </a:r>
-          </a:p>
-        </p:txBody>
-      </p:sp>
-      <p:sp>
-        <p:nvSpPr>
-          <p:cNvPr id="9" name="">
+              <a:t>права пользователей.</a:t>
+            </a:r>
+          </a:p>
+        </p:txBody>
+      </p:sp>
+      <p:sp>
+        <p:nvSpPr>
+          <p:cNvPr id="16" name="">
             <a:extLst xmlns:a="http://schemas.openxmlformats.org/drawingml/2006/main">
               <a:ext uri="{FF2B5EF4-FFF2-40B4-BE49-F238E27FC236}">
-                <a16:creationId xmlns:a16="http://schemas.microsoft.com/office/drawing/2014/main" id="{7D052799-A702-4358-A173-6C648B14F291}"/>
+                <a16:creationId xmlns:a16="http://schemas.microsoft.com/office/drawing/2014/main" id="{2D232191-E767-431C-9E30-B38E784F1AE3}"/>
               </a:ext>
             </a:extLst>
           </p:cNvPr>
@@ -5116,8 +5347,8 @@
         </p:nvSpPr>
         <p:spPr>
           <a:xfrm xmlns:a="http://schemas.openxmlformats.org/drawingml/2006/main">
-            <a:off x="609600" y="5133975"/>
-            <a:ext cx="10972800" cy="619125"/>
+            <a:off x="609600" y="5276850"/>
+            <a:ext cx="10972800" cy="600075"/>
           </a:xfrm>
           <a:prstGeom xmlns:a="http://schemas.openxmlformats.org/drawingml/2006/main" prst="rect">
             <a:avLst/>
@@ -5152,17 +5383,17 @@
                 <a:ea typeface="Helvetica Neue"/>
                 <a:cs typeface="Helvetica Neue"/>
               </a:rPr>
-              <a:t>Приоритет: проверка прав партнёром перед включением изменений.</a:t>
-            </a:r>
-          </a:p>
-        </p:txBody>
-      </p:sp>
-      <p:sp>
-        <p:nvSpPr>
-          <p:cNvPr id="10" name="">
+              <a:t>Первый шаг: каждый проверяет важный результат другого.</a:t>
+            </a:r>
+          </a:p>
+        </p:txBody>
+      </p:sp>
+      <p:sp>
+        <p:nvSpPr>
+          <p:cNvPr id="17" name="">
             <a:extLst xmlns:a="http://schemas.openxmlformats.org/drawingml/2006/main">
               <a:ext uri="{FF2B5EF4-FFF2-40B4-BE49-F238E27FC236}">
-                <a16:creationId xmlns:a16="http://schemas.microsoft.com/office/drawing/2014/main" id="{1EF29582-37BA-49FC-BB78-C6D14D9B395C}"/>
+                <a16:creationId xmlns:a16="http://schemas.microsoft.com/office/drawing/2014/main" id="{7AD3F8C9-BE81-437B-BFDF-F86277668C61}"/>
               </a:ext>
             </a:extLst>
           </p:cNvPr>
@@ -5173,8 +5404,8 @@
         </p:nvSpPr>
         <p:spPr>
           <a:xfrm xmlns:a="http://schemas.openxmlformats.org/drawingml/2006/main">
-            <a:off x="609600" y="5886450"/>
-            <a:ext cx="10972800" cy="381000"/>
+            <a:off x="609600" y="5953125"/>
+            <a:ext cx="10972800" cy="333375"/>
           </a:xfrm>
           <a:prstGeom xmlns:a="http://schemas.openxmlformats.org/drawingml/2006/main" prst="rect">
             <a:avLst/>
@@ -5209,7 +5440,7 @@
                 <a:ea typeface="Helvetica Neue"/>
                 <a:cs typeface="Helvetica Neue"/>
               </a:rPr>
-              <a:t>G2: анализ CVE зависимостей. G3: независимый запуск из архива.</a:t>
+              <a:t>Также в плане: проверка библиотек и установка из архива.</a:t>
             </a:r>
           </a:p>
         </p:txBody>
@@ -5277,6 +5508,7 @@
           <a:lstStyle xmlns:a="http://schemas.openxmlformats.org/drawingml/2006/main"/>
           <a:p xmlns:a="http://schemas.openxmlformats.org/drawingml/2006/main">
             <a:pPr>
+              <a:buNone/>
               <a:defRPr sz="1350" b="1">
                 <a:solidFill>
                   <a:srgbClr val="26756C"/>
@@ -5334,6 +5566,7 @@
           <a:lstStyle xmlns:a="http://schemas.openxmlformats.org/drawingml/2006/main"/>
           <a:p xmlns:a="http://schemas.openxmlformats.org/drawingml/2006/main">
             <a:pPr>
+              <a:buNone/>
               <a:defRPr sz="3300" b="1">
                 <a:solidFill>
                   <a:srgbClr val="102A30"/>
@@ -5352,7 +5585,7 @@
                 <a:ea typeface="Helvetica Neue"/>
                 <a:cs typeface="Helvetica Neue"/>
               </a:rPr>
-              <a:t>Контрольные точки и ответственность</a:t>
+              <a:t>Как проверяем изменения</a:t>
             </a:r>
           </a:p>
         </p:txBody>
@@ -5391,6 +5624,7 @@
           <a:lstStyle xmlns:a="http://schemas.openxmlformats.org/drawingml/2006/main"/>
           <a:p xmlns:a="http://schemas.openxmlformats.org/drawingml/2006/main">
             <a:pPr>
+              <a:buNone/>
               <a:defRPr sz="1350" b="0">
                 <a:solidFill>
                   <a:srgbClr val="59686B"/>
@@ -5448,6 +5682,7 @@
           <a:lstStyle xmlns:a="http://schemas.openxmlformats.org/drawingml/2006/main"/>
           <a:p xmlns:a="http://schemas.openxmlformats.org/drawingml/2006/main">
             <a:pPr>
+              <a:buNone/>
               <a:defRPr sz="1800" b="1">
                 <a:solidFill>
                   <a:srgbClr val="26756C"/>
@@ -5473,10 +5708,10 @@
       </p:sp>
       <p:sp>
         <p:nvSpPr>
-          <p:cNvPr id="5" name="">
+          <p:cNvPr id="12" name="">
             <a:extLst xmlns:a="http://schemas.openxmlformats.org/drawingml/2006/main">
               <a:ext uri="{FF2B5EF4-FFF2-40B4-BE49-F238E27FC236}">
-                <a16:creationId xmlns:a16="http://schemas.microsoft.com/office/drawing/2014/main" id="{C72402D9-A02D-479A-B420-BE8D791756FE}"/>
+                <a16:creationId xmlns:a16="http://schemas.microsoft.com/office/drawing/2014/main" id="{76AA19FD-CB8B-4010-A65D-F881CC0AF7E4}"/>
               </a:ext>
             </a:extLst>
           </p:cNvPr>
@@ -5487,8 +5722,8 @@
         </p:nvSpPr>
         <p:spPr>
           <a:xfrm xmlns:a="http://schemas.openxmlformats.org/drawingml/2006/main">
-            <a:off x="609600" y="1981200"/>
-            <a:ext cx="5095875" cy="485775"/>
+            <a:off x="609600" y="2009775"/>
+            <a:ext cx="5048250" cy="485775"/>
           </a:xfrm>
           <a:prstGeom xmlns:a="http://schemas.openxmlformats.org/drawingml/2006/main" prst="rect">
             <a:avLst/>
@@ -5523,17 +5758,17 @@
                 <a:ea typeface="Helvetica Neue"/>
                 <a:cs typeface="Helvetica Neue"/>
               </a:rPr>
-              <a:t>Включение изменения</a:t>
-            </a:r>
-          </a:p>
-        </p:txBody>
-      </p:sp>
-      <p:sp>
-        <p:nvSpPr>
-          <p:cNvPr id="6" name="">
+              <a:t>Порядок работы</a:t>
+            </a:r>
+          </a:p>
+        </p:txBody>
+      </p:sp>
+      <p:sp>
+        <p:nvSpPr>
+          <p:cNvPr id="13" name="">
             <a:extLst xmlns:a="http://schemas.openxmlformats.org/drawingml/2006/main">
               <a:ext uri="{FF2B5EF4-FFF2-40B4-BE49-F238E27FC236}">
-                <a16:creationId xmlns:a16="http://schemas.microsoft.com/office/drawing/2014/main" id="{85516324-16D2-406D-BFE4-239E5DAF2B66}"/>
+                <a16:creationId xmlns:a16="http://schemas.microsoft.com/office/drawing/2014/main" id="{E23F74E6-030A-48DB-9B21-EE4AD77241E4}"/>
               </a:ext>
             </a:extLst>
           </p:cNvPr>
@@ -5544,8 +5779,8 @@
         </p:nvSpPr>
         <p:spPr>
           <a:xfrm xmlns:a="http://schemas.openxmlformats.org/drawingml/2006/main">
-            <a:off x="609600" y="2638425"/>
-            <a:ext cx="5038725" cy="2276475"/>
+            <a:off x="609600" y="2724150"/>
+            <a:ext cx="5381625" cy="2209800"/>
           </a:xfrm>
           <a:prstGeom xmlns:a="http://schemas.openxmlformats.org/drawingml/2006/main" prst="rect">
             <a:avLst/>
@@ -5580,7 +5815,7 @@
                 <a:ea typeface="Helvetica Neue"/>
                 <a:cs typeface="Helvetica Neue"/>
               </a:rPr>
-              <a:t>Автор: ветка, изменение, тесты.</a:t>
+              <a:t>1. Автор описывает нужное поведение.</a:t>
             </a:r>
           </a:p>
           <a:p xmlns:a="http://schemas.openxmlformats.org/drawingml/2006/main">
@@ -5603,7 +5838,7 @@
                 <a:ea typeface="Helvetica Neue"/>
                 <a:cs typeface="Helvetica Neue"/>
               </a:rPr>
-              <a:t>Партнёр: чтение кода и повтор</a:t>
+              <a:t>2. Меняет код и запускает тесты.</a:t>
             </a:r>
           </a:p>
           <a:p xmlns:a="http://schemas.openxmlformats.org/drawingml/2006/main">
@@ -5626,12 +5861,7 @@
                 <a:ea typeface="Helvetica Neue"/>
                 <a:cs typeface="Helvetica Neue"/>
               </a:rPr>
-              <a:t>существенного сценария.</a:t>
-            </a:r>
-          </a:p>
-          <a:p xmlns:a="http://schemas.openxmlformats.org/drawingml/2006/main">
-            <a:r>
-              <a:t/>
+              <a:t>3. Партнёр читает код и повторяет</a:t>
             </a:r>
           </a:p>
           <a:p xmlns:a="http://schemas.openxmlformats.org/drawingml/2006/main">
@@ -5654,7 +5884,7 @@
                 <a:ea typeface="Helvetica Neue"/>
                 <a:cs typeface="Helvetica Neue"/>
               </a:rPr>
-              <a:t>Основание: CI для commit</a:t>
+              <a:t>    важную проверку.</a:t>
             </a:r>
           </a:p>
           <a:p xmlns:a="http://schemas.openxmlformats.org/drawingml/2006/main">
@@ -5677,17 +5907,17 @@
                 <a:ea typeface="Helvetica Neue"/>
                 <a:cs typeface="Helvetica Neue"/>
               </a:rPr>
-              <a:t>и сохранённое review.</a:t>
-            </a:r>
-          </a:p>
-        </p:txBody>
-      </p:sp>
-      <p:sp>
-        <p:nvSpPr>
-          <p:cNvPr id="7" name="">
+              <a:t>4. Сохраняем результат для версии.</a:t>
+            </a:r>
+          </a:p>
+        </p:txBody>
+      </p:sp>
+      <p:sp>
+        <p:nvSpPr>
+          <p:cNvPr id="14" name="">
             <a:extLst xmlns:a="http://schemas.openxmlformats.org/drawingml/2006/main">
               <a:ext uri="{FF2B5EF4-FFF2-40B4-BE49-F238E27FC236}">
-                <a16:creationId xmlns:a16="http://schemas.microsoft.com/office/drawing/2014/main" id="{AE3396E6-D76B-4509-BF47-24CD09FF8FDD}"/>
+                <a16:creationId xmlns:a16="http://schemas.microsoft.com/office/drawing/2014/main" id="{529B33DD-76D7-4B46-A4AA-1C6AE0591145}"/>
               </a:ext>
             </a:extLst>
           </p:cNvPr>
@@ -5698,8 +5928,8 @@
         </p:nvSpPr>
         <p:spPr>
           <a:xfrm xmlns:a="http://schemas.openxmlformats.org/drawingml/2006/main">
-            <a:off x="6324600" y="1981200"/>
-            <a:ext cx="5238750" cy="485775"/>
+            <a:off x="6419850" y="2009775"/>
+            <a:ext cx="5143500" cy="485775"/>
           </a:xfrm>
           <a:prstGeom xmlns:a="http://schemas.openxmlformats.org/drawingml/2006/main" prst="rect">
             <a:avLst/>
@@ -5734,17 +5964,17 @@
                 <a:ea typeface="Helvetica Neue"/>
                 <a:cs typeface="Helvetica Neue"/>
               </a:rPr>
-              <a:t>Продуктовый выпуск</a:t>
-            </a:r>
-          </a:p>
-        </p:txBody>
-      </p:sp>
-      <p:sp>
-        <p:nvSpPr>
-          <p:cNvPr id="8" name="">
+              <a:t>Пример: наблюдатель</a:t>
+            </a:r>
+          </a:p>
+        </p:txBody>
+      </p:sp>
+      <p:sp>
+        <p:nvSpPr>
+          <p:cNvPr id="15" name="">
             <a:extLst xmlns:a="http://schemas.openxmlformats.org/drawingml/2006/main">
               <a:ext uri="{FF2B5EF4-FFF2-40B4-BE49-F238E27FC236}">
-                <a16:creationId xmlns:a16="http://schemas.microsoft.com/office/drawing/2014/main" id="{B5F8EF49-D7BD-4A62-9B1D-EC1E3D0AF08C}"/>
+                <a16:creationId xmlns:a16="http://schemas.microsoft.com/office/drawing/2014/main" id="{F10CB677-5CD1-430F-BE1C-23CA6155F44C}"/>
               </a:ext>
             </a:extLst>
           </p:cNvPr>
@@ -5755,8 +5985,8 @@
         </p:nvSpPr>
         <p:spPr>
           <a:xfrm xmlns:a="http://schemas.openxmlformats.org/drawingml/2006/main">
-            <a:off x="6324600" y="2638425"/>
-            <a:ext cx="5238750" cy="2276475"/>
+            <a:off x="6419850" y="2724150"/>
+            <a:ext cx="5143500" cy="2095500"/>
           </a:xfrm>
           <a:prstGeom xmlns:a="http://schemas.openxmlformats.org/drawingml/2006/main" prst="rect">
             <a:avLst/>
@@ -5791,7 +6021,7 @@
                 <a:ea typeface="Helvetica Neue"/>
                 <a:cs typeface="Helvetica Neue"/>
               </a:rPr>
-              <a:t>Роман: зависимости и комплект.</a:t>
+              <a:t>Пробуем изменить задачу</a:t>
             </a:r>
           </a:p>
           <a:p xmlns:a="http://schemas.openxmlformats.org/drawingml/2006/main">
@@ -5814,7 +6044,12 @@
                 <a:ea typeface="Helvetica Neue"/>
                 <a:cs typeface="Helvetica Neue"/>
               </a:rPr>
-              <a:t>Ярослав: установка из архива.</a:t>
+              <a:t>прямым запросом к серверу.</a:t>
+            </a:r>
+          </a:p>
+          <a:p xmlns:a="http://schemas.openxmlformats.org/drawingml/2006/main">
+            <a:r>
+              <a:t/>
             </a:r>
           </a:p>
           <a:p xmlns:a="http://schemas.openxmlformats.org/drawingml/2006/main">
@@ -5837,12 +6072,7 @@
                 <a:ea typeface="Helvetica Neue"/>
                 <a:cs typeface="Helvetica Neue"/>
               </a:rPr>
-              <a:t>Оба: решение по результатам.</a:t>
-            </a:r>
-          </a:p>
-          <a:p xmlns:a="http://schemas.openxmlformats.org/drawingml/2006/main">
-            <a:r>
-              <a:t/>
+              <a:t>Ожидаем отказ.</a:t>
             </a:r>
           </a:p>
           <a:p xmlns:a="http://schemas.openxmlformats.org/drawingml/2006/main">
@@ -5865,40 +6095,17 @@
                 <a:ea typeface="Helvetica Neue"/>
                 <a:cs typeface="Helvetica Neue"/>
               </a:rPr>
-              <a:t>Основание: отчёты, триаж,</a:t>
-            </a:r>
-          </a:p>
-          <a:p xmlns:a="http://schemas.openxmlformats.org/drawingml/2006/main">
-            <a:pPr>
-              <a:defRPr sz="2100" b="0">
-                <a:solidFill>
-                  <a:srgbClr val="102A30"/>
-                </a:solidFill>
-                <a:latin typeface="Helvetica Neue"/>
-                <a:ea typeface="Helvetica Neue"/>
-                <a:cs typeface="Helvetica Neue"/>
-              </a:defRPr>
-            </a:pPr>
-            <a:r>
-              <a:rPr sz="2100" b="0">
-                <a:solidFill>
-                  <a:srgbClr val="102A30"/>
-                </a:solidFill>
-                <a:latin typeface="Helvetica Neue"/>
-                <a:ea typeface="Helvetica Neue"/>
-                <a:cs typeface="Helvetica Neue"/>
-              </a:rPr>
-              <a:t>commit, тег и SHA-256.</a:t>
-            </a:r>
-          </a:p>
-        </p:txBody>
-      </p:sp>
-      <p:sp>
-        <p:nvSpPr>
-          <p:cNvPr id="9" name="">
+              <a:t>Данные остаются прежними.</a:t>
+            </a:r>
+          </a:p>
+        </p:txBody>
+      </p:sp>
+      <p:sp>
+        <p:nvSpPr>
+          <p:cNvPr id="16" name="">
             <a:extLst xmlns:a="http://schemas.openxmlformats.org/drawingml/2006/main">
               <a:ext uri="{FF2B5EF4-FFF2-40B4-BE49-F238E27FC236}">
-                <a16:creationId xmlns:a16="http://schemas.microsoft.com/office/drawing/2014/main" id="{0E2F82F7-3D2E-4DFE-B106-2BE97AD6EF3A}"/>
+                <a16:creationId xmlns:a16="http://schemas.microsoft.com/office/drawing/2014/main" id="{F46AC114-CF0D-4E8C-A63F-A9FEA51CE709}"/>
               </a:ext>
             </a:extLst>
           </p:cNvPr>
@@ -5909,8 +6116,8 @@
         </p:nvSpPr>
         <p:spPr>
           <a:xfrm xmlns:a="http://schemas.openxmlformats.org/drawingml/2006/main">
-            <a:off x="609600" y="5334000"/>
-            <a:ext cx="10972800" cy="571500"/>
+            <a:off x="609600" y="5286375"/>
+            <a:ext cx="10972800" cy="600075"/>
           </a:xfrm>
           <a:prstGeom xmlns:a="http://schemas.openxmlformats.org/drawingml/2006/main" prst="rect">
             <a:avLst/>
@@ -5929,7 +6136,7 @@
             <a:pPr>
               <a:defRPr sz="2175" b="1">
                 <a:solidFill>
-                  <a:srgbClr val="102A30"/>
+                  <a:srgbClr val="26756C"/>
                 </a:solidFill>
                 <a:latin typeface="Helvetica Neue"/>
                 <a:ea typeface="Helvetica Neue"/>
@@ -5939,23 +6146,23 @@
             <a:r>
               <a:rPr sz="2175" b="1">
                 <a:solidFill>
-                  <a:srgbClr val="102A30"/>
-                </a:solidFill>
-                <a:latin typeface="Helvetica Neue"/>
-                <a:ea typeface="Helvetica Neue"/>
-                <a:cs typeface="Helvetica Neue"/>
-              </a:rPr>
-              <a:t>Без проверяющего или при нарушении прав откладываем переход.</a:t>
-            </a:r>
-          </a:p>
-        </p:txBody>
-      </p:sp>
-      <p:sp>
-        <p:nvSpPr>
-          <p:cNvPr id="10" name="">
+                  <a:srgbClr val="26756C"/>
+                </a:solidFill>
+                <a:latin typeface="Helvetica Neue"/>
+                <a:ea typeface="Helvetica Neue"/>
+                <a:cs typeface="Helvetica Neue"/>
+              </a:rPr>
+              <a:t>При нарушении прав или без проверки партнёра изменение ждёт.</a:t>
+            </a:r>
+          </a:p>
+        </p:txBody>
+      </p:sp>
+      <p:sp>
+        <p:nvSpPr>
+          <p:cNvPr id="17" name="">
             <a:extLst xmlns:a="http://schemas.openxmlformats.org/drawingml/2006/main">
               <a:ext uri="{FF2B5EF4-FFF2-40B4-BE49-F238E27FC236}">
-                <a16:creationId xmlns:a16="http://schemas.microsoft.com/office/drawing/2014/main" id="{F0533CA4-DD94-47F6-8BA5-4BF9CA847AE2}"/>
+                <a16:creationId xmlns:a16="http://schemas.microsoft.com/office/drawing/2014/main" id="{3421A573-B973-44F3-AE0F-0E0657EEA533}"/>
               </a:ext>
             </a:extLst>
           </p:cNvPr>
@@ -5966,8 +6173,8 @@
         </p:nvSpPr>
         <p:spPr>
           <a:xfrm xmlns:a="http://schemas.openxmlformats.org/drawingml/2006/main">
-            <a:off x="609600" y="5886450"/>
-            <a:ext cx="10972800" cy="333375"/>
+            <a:off x="609600" y="5943600"/>
+            <a:ext cx="10972800" cy="352425"/>
           </a:xfrm>
           <a:prstGeom xmlns:a="http://schemas.openxmlformats.org/drawingml/2006/main" prst="rect">
             <a:avLst/>
@@ -6002,7 +6209,7 @@
                 <a:ea typeface="Helvetica Neue"/>
                 <a:cs typeface="Helvetica Neue"/>
               </a:rPr>
-              <a:t>Некритическое исключение: карточка, срок до 7 дней и согласие обоих.</a:t>
+              <a:t>Перед выпуском: запуск из архива и общее решение по отчётам.</a:t>
             </a:r>
           </a:p>
         </p:txBody>
@@ -6070,6 +6277,7 @@
           <a:lstStyle xmlns:a="http://schemas.openxmlformats.org/drawingml/2006/main"/>
           <a:p xmlns:a="http://schemas.openxmlformats.org/drawingml/2006/main">
             <a:pPr>
+              <a:buNone/>
               <a:defRPr sz="1350" b="1">
                 <a:solidFill>
                   <a:srgbClr val="26756C"/>
@@ -6127,6 +6335,7 @@
           <a:lstStyle xmlns:a="http://schemas.openxmlformats.org/drawingml/2006/main"/>
           <a:p xmlns:a="http://schemas.openxmlformats.org/drawingml/2006/main">
             <a:pPr>
+              <a:buNone/>
               <a:defRPr sz="3300" b="1">
                 <a:solidFill>
                   <a:srgbClr val="102A30"/>
@@ -6145,7 +6354,7 @@
                 <a:ea typeface="Helvetica Neue"/>
                 <a:cs typeface="Helvetica Neue"/>
               </a:rPr>
-              <a:t>План проверок Романа и Ярослава</a:t>
+              <a:t>Что делает каждый участник</a:t>
             </a:r>
           </a:p>
         </p:txBody>
@@ -6184,6 +6393,7 @@
           <a:lstStyle xmlns:a="http://schemas.openxmlformats.org/drawingml/2006/main"/>
           <a:p xmlns:a="http://schemas.openxmlformats.org/drawingml/2006/main">
             <a:pPr>
+              <a:buNone/>
               <a:defRPr sz="1350" b="0">
                 <a:solidFill>
                   <a:srgbClr val="59686B"/>
@@ -6241,6 +6451,7 @@
           <a:lstStyle xmlns:a="http://schemas.openxmlformats.org/drawingml/2006/main"/>
           <a:p xmlns:a="http://schemas.openxmlformats.org/drawingml/2006/main">
             <a:pPr>
+              <a:buNone/>
               <a:defRPr sz="1800" b="1">
                 <a:solidFill>
                   <a:srgbClr val="26756C"/>
@@ -6264,368 +6475,12 @@
           </a:p>
         </p:txBody>
       </p:sp>
-      <p:graphicFrame>
-        <p:nvGraphicFramePr>
-          <p:cNvPr id="12" name=""/>
-          <p:cNvGraphicFramePr/>
-          <p:nvPr/>
-        </p:nvGraphicFramePr>
-        <p:xfrm>
-          <a:off xmlns:a="http://schemas.openxmlformats.org/drawingml/2006/main" x="609600" y="2057400"/>
-          <a:ext xmlns:a="http://schemas.openxmlformats.org/drawingml/2006/main" cx="10972800" cy="2990850"/>
-        </p:xfrm>
-        <a:graphic xmlns:a="http://schemas.openxmlformats.org/drawingml/2006/main">
-          <a:graphicData uri="http://schemas.openxmlformats.org/drawingml/2006/table">
-            <a:tbl>
-              <a:tblPr/>
-              <a:tblGrid>
-                <a:gridCol w="3524250"/>
-                <a:gridCol w="2190750"/>
-                <a:gridCol w="5257800"/>
-              </a:tblGrid>
-              <a:tr h="747713">
-                <a:tc>
-                  <a:txBody>
-                    <a:bodyPr>
-                      <a:noAutofit/>
-                    </a:bodyPr>
-                    <a:lstStyle/>
-                    <a:p>
-                      <a:r>
-                        <a:rPr sz="1950" b="1">
-                          <a:solidFill>
-                            <a:srgbClr val="FFFFFF"/>
-                          </a:solidFill>
-                          <a:latin typeface="Helvetica Neue"/>
-                          <a:ea typeface="Helvetica Neue"/>
-                          <a:cs typeface="Helvetica Neue"/>
-                        </a:rPr>
-                        <a:t>Метод</a:t>
-                      </a:r>
-                    </a:p>
-                  </a:txBody>
-                  <a:tcPr marL="91440" marR="91440" marT="45720" marB="45720">
-                    <a:solidFill>
-                      <a:srgbClr val="102A30"/>
-                    </a:solidFill>
-                  </a:tcPr>
-                </a:tc>
-                <a:tc>
-                  <a:txBody>
-                    <a:bodyPr>
-                      <a:noAutofit/>
-                    </a:bodyPr>
-                    <a:lstStyle/>
-                    <a:p>
-                      <a:r>
-                        <a:rPr sz="1950" b="1">
-                          <a:solidFill>
-                            <a:srgbClr val="FFFFFF"/>
-                          </a:solidFill>
-                          <a:latin typeface="Helvetica Neue"/>
-                          <a:ea typeface="Helvetica Neue"/>
-                          <a:cs typeface="Helvetica Neue"/>
-                        </a:rPr>
-                        <a:t>Исполнитель</a:t>
-                      </a:r>
-                    </a:p>
-                  </a:txBody>
-                  <a:tcPr marL="91440" marR="91440" marT="45720" marB="45720">
-                    <a:solidFill>
-                      <a:srgbClr val="102A30"/>
-                    </a:solidFill>
-                  </a:tcPr>
-                </a:tc>
-                <a:tc>
-                  <a:txBody>
-                    <a:bodyPr>
-                      <a:noAutofit/>
-                    </a:bodyPr>
-                    <a:lstStyle/>
-                    <a:p>
-                      <a:r>
-                        <a:rPr sz="1950" b="1">
-                          <a:solidFill>
-                            <a:srgbClr val="FFFFFF"/>
-                          </a:solidFill>
-                          <a:latin typeface="Helvetica Neue"/>
-                          <a:ea typeface="Helvetica Neue"/>
-                          <a:cs typeface="Helvetica Neue"/>
-                        </a:rPr>
-                        <a:t>Проверяющий и свидетельство</a:t>
-                      </a:r>
-                    </a:p>
-                  </a:txBody>
-                  <a:tcPr marL="91440" marR="91440" marT="45720" marB="45720">
-                    <a:solidFill>
-                      <a:srgbClr val="102A30"/>
-                    </a:solidFill>
-                  </a:tcPr>
-                </a:tc>
-              </a:tr>
-              <a:tr h="747713">
-                <a:tc>
-                  <a:txBody>
-                    <a:bodyPr>
-                      <a:noAutofit/>
-                    </a:bodyPr>
-                    <a:lstStyle/>
-                    <a:p>
-                      <a:r>
-                        <a:rPr sz="1950" b="0">
-                          <a:solidFill>
-                            <a:srgbClr val="102A30"/>
-                          </a:solidFill>
-                          <a:latin typeface="Helvetica Neue"/>
-                          <a:ea typeface="Helvetica Neue"/>
-                          <a:cs typeface="Helvetica Neue"/>
-                        </a:rPr>
-                        <a:t>М1: права и изоляция</a:t>
-                      </a:r>
-                    </a:p>
-                  </a:txBody>
-                  <a:tcPr marL="91440" marR="91440" marT="45720" marB="45720">
-                    <a:solidFill>
-                      <a:srgbClr val="FFFFFF"/>
-                    </a:solidFill>
-                  </a:tcPr>
-                </a:tc>
-                <a:tc>
-                  <a:txBody>
-                    <a:bodyPr>
-                      <a:noAutofit/>
-                    </a:bodyPr>
-                    <a:lstStyle/>
-                    <a:p>
-                      <a:r>
-                        <a:rPr sz="1950" b="0">
-                          <a:solidFill>
-                            <a:srgbClr val="102A30"/>
-                          </a:solidFill>
-                          <a:latin typeface="Helvetica Neue"/>
-                          <a:ea typeface="Helvetica Neue"/>
-                          <a:cs typeface="Helvetica Neue"/>
-                        </a:rPr>
-                        <a:t>Роман</a:t>
-                      </a:r>
-                    </a:p>
-                  </a:txBody>
-                  <a:tcPr marL="91440" marR="91440" marT="45720" marB="45720">
-                    <a:solidFill>
-                      <a:srgbClr val="FFFFFF"/>
-                    </a:solidFill>
-                  </a:tcPr>
-                </a:tc>
-                <a:tc>
-                  <a:txBody>
-                    <a:bodyPr>
-                      <a:noAutofit/>
-                    </a:bodyPr>
-                    <a:lstStyle/>
-                    <a:p>
-                      <a:r>
-                        <a:rPr sz="1950" b="0">
-                          <a:solidFill>
-                            <a:srgbClr val="102A30"/>
-                          </a:solidFill>
-                          <a:latin typeface="Helvetica Neue"/>
-                          <a:ea typeface="Helvetica Neue"/>
-                          <a:cs typeface="Helvetica Neue"/>
-                        </a:rPr>
-                        <a:t>Ярослав: повтор запрета, матрица и review</a:t>
-                      </a:r>
-                    </a:p>
-                  </a:txBody>
-                  <a:tcPr marL="91440" marR="91440" marT="45720" marB="45720">
-                    <a:solidFill>
-                      <a:srgbClr val="FFFFFF"/>
-                    </a:solidFill>
-                  </a:tcPr>
-                </a:tc>
-              </a:tr>
-              <a:tr h="747713">
-                <a:tc>
-                  <a:txBody>
-                    <a:bodyPr>
-                      <a:noAutofit/>
-                    </a:bodyPr>
-                    <a:lstStyle/>
-                    <a:p>
-                      <a:r>
-                        <a:rPr sz="1950" b="0">
-                          <a:solidFill>
-                            <a:srgbClr val="102A30"/>
-                          </a:solidFill>
-                          <a:latin typeface="Helvetica Neue"/>
-                          <a:ea typeface="Helvetica Neue"/>
-                          <a:cs typeface="Helvetica Neue"/>
-                        </a:rPr>
-                        <a:t>М2: ввод и CSRF</a:t>
-                      </a:r>
-                    </a:p>
-                  </a:txBody>
-                  <a:tcPr marL="91440" marR="91440" marT="45720" marB="45720">
-                    <a:solidFill>
-                      <a:srgbClr val="F7F6F1"/>
-                    </a:solidFill>
-                  </a:tcPr>
-                </a:tc>
-                <a:tc>
-                  <a:txBody>
-                    <a:bodyPr>
-                      <a:noAutofit/>
-                    </a:bodyPr>
-                    <a:lstStyle/>
-                    <a:p>
-                      <a:r>
-                        <a:rPr sz="1950" b="0">
-                          <a:solidFill>
-                            <a:srgbClr val="102A30"/>
-                          </a:solidFill>
-                          <a:latin typeface="Helvetica Neue"/>
-                          <a:ea typeface="Helvetica Neue"/>
-                          <a:cs typeface="Helvetica Neue"/>
-                        </a:rPr>
-                        <a:t>Ярослав</a:t>
-                      </a:r>
-                    </a:p>
-                  </a:txBody>
-                  <a:tcPr marL="91440" marR="91440" marT="45720" marB="45720">
-                    <a:solidFill>
-                      <a:srgbClr val="F7F6F1"/>
-                    </a:solidFill>
-                  </a:tcPr>
-                </a:tc>
-                <a:tc>
-                  <a:txBody>
-                    <a:bodyPr>
-                      <a:noAutofit/>
-                    </a:bodyPr>
-                    <a:lstStyle/>
-                    <a:p>
-                      <a:r>
-                        <a:rPr sz="1950" b="0">
-                          <a:solidFill>
-                            <a:srgbClr val="102A30"/>
-                          </a:solidFill>
-                          <a:latin typeface="Helvetica Neue"/>
-                          <a:ea typeface="Helvetica Neue"/>
-                          <a:cs typeface="Helvetica Neue"/>
-                        </a:rPr>
-                        <a:t>Роман: POST и экранирование, отчёт и review</a:t>
-                      </a:r>
-                    </a:p>
-                  </a:txBody>
-                  <a:tcPr marL="91440" marR="91440" marT="45720" marB="45720">
-                    <a:solidFill>
-                      <a:srgbClr val="F7F6F1"/>
-                    </a:solidFill>
-                  </a:tcPr>
-                </a:tc>
-              </a:tr>
-              <a:tr h="747713">
-                <a:tc>
-                  <a:txBody>
-                    <a:bodyPr>
-                      <a:noAutofit/>
-                    </a:bodyPr>
-                    <a:lstStyle/>
-                    <a:p>
-                      <a:r>
-                        <a:rPr sz="1950" b="0">
-                          <a:solidFill>
-                            <a:srgbClr val="102A30"/>
-                          </a:solidFill>
-                          <a:latin typeface="Helvetica Neue"/>
-                          <a:ea typeface="Helvetica Neue"/>
-                          <a:cs typeface="Helvetica Neue"/>
-                        </a:rPr>
-                        <a:t>М3: зависимости</a:t>
-                      </a:r>
-                    </a:p>
-                    <a:p>
-                      <a:r>
-                        <a:rPr sz="1950" b="0">
-                          <a:solidFill>
-                            <a:srgbClr val="102A30"/>
-                          </a:solidFill>
-                          <a:latin typeface="Helvetica Neue"/>
-                          <a:ea typeface="Helvetica Neue"/>
-                          <a:cs typeface="Helvetica Neue"/>
-                        </a:rPr>
-                        <a:t>и воспроизводимость</a:t>
-                      </a:r>
-                    </a:p>
-                  </a:txBody>
-                  <a:tcPr marL="91440" marR="91440" marT="45720" marB="45720">
-                    <a:solidFill>
-                      <a:srgbClr val="FFFFFF"/>
-                    </a:solidFill>
-                  </a:tcPr>
-                </a:tc>
-                <a:tc>
-                  <a:txBody>
-                    <a:bodyPr>
-                      <a:noAutofit/>
-                    </a:bodyPr>
-                    <a:lstStyle/>
-                    <a:p>
-                      <a:r>
-                        <a:rPr sz="1950" b="0">
-                          <a:solidFill>
-                            <a:srgbClr val="102A30"/>
-                          </a:solidFill>
-                          <a:latin typeface="Helvetica Neue"/>
-                          <a:ea typeface="Helvetica Neue"/>
-                          <a:cs typeface="Helvetica Neue"/>
-                        </a:rPr>
-                        <a:t>Роман</a:t>
-                      </a:r>
-                    </a:p>
-                  </a:txBody>
-                  <a:tcPr marL="91440" marR="91440" marT="45720" marB="45720">
-                    <a:solidFill>
-                      <a:srgbClr val="FFFFFF"/>
-                    </a:solidFill>
-                  </a:tcPr>
-                </a:tc>
-                <a:tc>
-                  <a:txBody>
-                    <a:bodyPr>
-                      <a:noAutofit/>
-                    </a:bodyPr>
-                    <a:lstStyle/>
-                    <a:p>
-                      <a:r>
-                        <a:rPr sz="1950" b="0">
-                          <a:solidFill>
-                            <a:srgbClr val="102A30"/>
-                          </a:solidFill>
-                          <a:latin typeface="Helvetica Neue"/>
-                          <a:ea typeface="Helvetica Neue"/>
-                          <a:cs typeface="Helvetica Neue"/>
-                        </a:rPr>
-                        <a:t>Ярослав: чистая установка, аудит и триаж</a:t>
-                      </a:r>
-                    </a:p>
-                  </a:txBody>
-                  <a:tcPr marL="91440" marR="91440" marT="45720" marB="45720">
-                    <a:solidFill>
-                      <a:srgbClr val="FFFFFF"/>
-                    </a:solidFill>
-                  </a:tcPr>
-                </a:tc>
-              </a:tr>
-            </a:tbl>
-          </a:graphicData>
-        </a:graphic>
-      </p:graphicFrame>
-      <p:sp>
-        <p:nvSpPr>
-          <p:cNvPr id="6" name="">
+      <p:sp>
+        <p:nvSpPr>
+          <p:cNvPr id="9" name="">
             <a:extLst xmlns:a="http://schemas.openxmlformats.org/drawingml/2006/main">
               <a:ext uri="{FF2B5EF4-FFF2-40B4-BE49-F238E27FC236}">
-                <a16:creationId xmlns:a16="http://schemas.microsoft.com/office/drawing/2014/main" id="{D52DE8F3-9552-45CC-8F1D-EBB679041ECA}"/>
+                <a16:creationId xmlns:a16="http://schemas.microsoft.com/office/drawing/2014/main" id="{608E8E3E-A544-4FE5-B1A3-EDCDF8F83F72}"/>
               </a:ext>
             </a:extLst>
           </p:cNvPr>
@@ -6636,8 +6491,8 @@
         </p:nvSpPr>
         <p:spPr>
           <a:xfrm xmlns:a="http://schemas.openxmlformats.org/drawingml/2006/main">
-            <a:off x="609600" y="5334000"/>
-            <a:ext cx="10972800" cy="685800"/>
+            <a:off x="609600" y="2009775"/>
+            <a:ext cx="5095875" cy="485775"/>
           </a:xfrm>
           <a:prstGeom xmlns:a="http://schemas.openxmlformats.org/drawingml/2006/main" prst="rect">
             <a:avLst/>
@@ -6654,7 +6509,7 @@
           <a:lstStyle xmlns:a="http://schemas.openxmlformats.org/drawingml/2006/main"/>
           <a:p xmlns:a="http://schemas.openxmlformats.org/drawingml/2006/main">
             <a:pPr>
-              <a:defRPr sz="2250" b="1">
+              <a:defRPr sz="2550" b="1">
                 <a:solidFill>
                   <a:srgbClr val="26756C"/>
                 </a:solidFill>
@@ -6664,7 +6519,7 @@
               </a:defRPr>
             </a:pPr>
             <a:r>
-              <a:rPr sz="2250" b="1">
+              <a:rPr sz="2550" b="1">
                 <a:solidFill>
                   <a:srgbClr val="26756C"/>
                 </a:solidFill>
@@ -6672,17 +6527,17 @@
                 <a:ea typeface="Helvetica Neue"/>
                 <a:cs typeface="Helvetica Neue"/>
               </a:rPr>
-              <a:t>Сначала личные отчёты и PR, затем взаимная проверка и созвон.</a:t>
-            </a:r>
-          </a:p>
-        </p:txBody>
-      </p:sp>
-      <p:sp>
-        <p:nvSpPr>
-          <p:cNvPr id="7" name="">
+              <a:t>Роман / Issue #1</a:t>
+            </a:r>
+          </a:p>
+        </p:txBody>
+      </p:sp>
+      <p:sp>
+        <p:nvSpPr>
+          <p:cNvPr id="10" name="">
             <a:extLst xmlns:a="http://schemas.openxmlformats.org/drawingml/2006/main">
               <a:ext uri="{FF2B5EF4-FFF2-40B4-BE49-F238E27FC236}">
-                <a16:creationId xmlns:a16="http://schemas.microsoft.com/office/drawing/2014/main" id="{7E60ADA1-6CB0-4EA4-8C94-0D3A52A8F577}"/>
+                <a16:creationId xmlns:a16="http://schemas.microsoft.com/office/drawing/2014/main" id="{7A336C38-F9AF-4585-A5A1-A87103A5E579}"/>
               </a:ext>
             </a:extLst>
           </p:cNvPr>
@@ -6693,8 +6548,8 @@
         </p:nvSpPr>
         <p:spPr>
           <a:xfrm xmlns:a="http://schemas.openxmlformats.org/drawingml/2006/main">
-            <a:off x="609600" y="5943600"/>
-            <a:ext cx="10972800" cy="333375"/>
+            <a:off x="609600" y="2724150"/>
+            <a:ext cx="5143500" cy="2000250"/>
           </a:xfrm>
           <a:prstGeom xmlns:a="http://schemas.openxmlformats.org/drawingml/2006/main" prst="rect">
             <a:avLst/>
@@ -6711,6 +6566,382 @@
           <a:lstStyle xmlns:a="http://schemas.openxmlformats.org/drawingml/2006/main"/>
           <a:p xmlns:a="http://schemas.openxmlformats.org/drawingml/2006/main">
             <a:pPr>
+              <a:defRPr sz="2100" b="0">
+                <a:solidFill>
+                  <a:srgbClr val="102A30"/>
+                </a:solidFill>
+                <a:latin typeface="Helvetica Neue"/>
+                <a:ea typeface="Helvetica Neue"/>
+                <a:cs typeface="Helvetica Neue"/>
+              </a:defRPr>
+            </a:pPr>
+            <a:r>
+              <a:rPr sz="2100" b="0">
+                <a:solidFill>
+                  <a:srgbClr val="102A30"/>
+                </a:solidFill>
+                <a:latin typeface="Helvetica Neue"/>
+                <a:ea typeface="Helvetica Neue"/>
+                <a:cs typeface="Helvetica Neue"/>
+              </a:rPr>
+              <a:t>Проверяет права трёх ролей</a:t>
+            </a:r>
+          </a:p>
+          <a:p xmlns:a="http://schemas.openxmlformats.org/drawingml/2006/main">
+            <a:pPr>
+              <a:defRPr sz="2100" b="0">
+                <a:solidFill>
+                  <a:srgbClr val="102A30"/>
+                </a:solidFill>
+                <a:latin typeface="Helvetica Neue"/>
+                <a:ea typeface="Helvetica Neue"/>
+                <a:cs typeface="Helvetica Neue"/>
+              </a:defRPr>
+            </a:pPr>
+            <a:r>
+              <a:rPr sz="2100" b="0">
+                <a:solidFill>
+                  <a:srgbClr val="102A30"/>
+                </a:solidFill>
+                <a:latin typeface="Helvetica Neue"/>
+                <a:ea typeface="Helvetica Neue"/>
+                <a:cs typeface="Helvetica Neue"/>
+              </a:rPr>
+              <a:t>и изоляцию проектов.</a:t>
+            </a:r>
+          </a:p>
+          <a:p xmlns:a="http://schemas.openxmlformats.org/drawingml/2006/main">
+            <a:r>
+              <a:t/>
+            </a:r>
+          </a:p>
+          <a:p xmlns:a="http://schemas.openxmlformats.org/drawingml/2006/main">
+            <a:pPr>
+              <a:defRPr sz="2100" b="0">
+                <a:solidFill>
+                  <a:srgbClr val="102A30"/>
+                </a:solidFill>
+                <a:latin typeface="Helvetica Neue"/>
+                <a:ea typeface="Helvetica Neue"/>
+                <a:cs typeface="Helvetica Neue"/>
+              </a:defRPr>
+            </a:pPr>
+            <a:r>
+              <a:rPr sz="2100" b="0">
+                <a:solidFill>
+                  <a:srgbClr val="102A30"/>
+                </a:solidFill>
+                <a:latin typeface="Helvetica Neue"/>
+                <a:ea typeface="Helvetica Neue"/>
+                <a:cs typeface="Helvetica Neue"/>
+              </a:rPr>
+              <a:t>Проверяет библиотеки</a:t>
+            </a:r>
+          </a:p>
+          <a:p xmlns:a="http://schemas.openxmlformats.org/drawingml/2006/main">
+            <a:pPr>
+              <a:defRPr sz="2100" b="0">
+                <a:solidFill>
+                  <a:srgbClr val="102A30"/>
+                </a:solidFill>
+                <a:latin typeface="Helvetica Neue"/>
+                <a:ea typeface="Helvetica Neue"/>
+                <a:cs typeface="Helvetica Neue"/>
+              </a:defRPr>
+            </a:pPr>
+            <a:r>
+              <a:rPr sz="2100" b="0">
+                <a:solidFill>
+                  <a:srgbClr val="102A30"/>
+                </a:solidFill>
+                <a:latin typeface="Helvetica Neue"/>
+                <a:ea typeface="Helvetica Neue"/>
+                <a:cs typeface="Helvetica Neue"/>
+              </a:rPr>
+              <a:t>и настройки приложения.</a:t>
+            </a:r>
+          </a:p>
+        </p:txBody>
+      </p:sp>
+      <p:sp>
+        <p:nvSpPr>
+          <p:cNvPr id="11" name="">
+            <a:extLst xmlns:a="http://schemas.openxmlformats.org/drawingml/2006/main">
+              <a:ext uri="{FF2B5EF4-FFF2-40B4-BE49-F238E27FC236}">
+                <a16:creationId xmlns:a16="http://schemas.microsoft.com/office/drawing/2014/main" id="{EE97B6B7-67DC-48C3-8CA4-54B161BB877F}"/>
+              </a:ext>
+            </a:extLst>
+          </p:cNvPr>
+          <p:cNvSpPr>
+            <a:spLocks xmlns:a="http://schemas.openxmlformats.org/drawingml/2006/main" noGrp="1"/>
+          </p:cNvSpPr>
+          <p:nvPr/>
+        </p:nvSpPr>
+        <p:spPr>
+          <a:xfrm xmlns:a="http://schemas.openxmlformats.org/drawingml/2006/main">
+            <a:off x="6419850" y="2009775"/>
+            <a:ext cx="5143500" cy="485775"/>
+          </a:xfrm>
+          <a:prstGeom xmlns:a="http://schemas.openxmlformats.org/drawingml/2006/main" prst="rect">
+            <a:avLst/>
+          </a:prstGeom>
+          <a:noFill xmlns:a="http://schemas.openxmlformats.org/drawingml/2006/main"/>
+          <a:ln xmlns:a="http://schemas.openxmlformats.org/drawingml/2006/main" w="0">
+            <a:noFill/>
+          </a:ln>
+        </p:spPr>
+        <p:txBody>
+          <a:bodyPr xmlns:a="http://schemas.openxmlformats.org/drawingml/2006/main">
+            <a:noAutofit/>
+          </a:bodyPr>
+          <a:lstStyle xmlns:a="http://schemas.openxmlformats.org/drawingml/2006/main"/>
+          <a:p xmlns:a="http://schemas.openxmlformats.org/drawingml/2006/main">
+            <a:pPr>
+              <a:defRPr sz="2550" b="1">
+                <a:solidFill>
+                  <a:srgbClr val="26756C"/>
+                </a:solidFill>
+                <a:latin typeface="Helvetica Neue"/>
+                <a:ea typeface="Helvetica Neue"/>
+                <a:cs typeface="Helvetica Neue"/>
+              </a:defRPr>
+            </a:pPr>
+            <a:r>
+              <a:rPr sz="2550" b="1">
+                <a:solidFill>
+                  <a:srgbClr val="26756C"/>
+                </a:solidFill>
+                <a:latin typeface="Helvetica Neue"/>
+                <a:ea typeface="Helvetica Neue"/>
+                <a:cs typeface="Helvetica Neue"/>
+              </a:rPr>
+              <a:t>Ярослав / Issue #2</a:t>
+            </a:r>
+          </a:p>
+        </p:txBody>
+      </p:sp>
+      <p:sp>
+        <p:nvSpPr>
+          <p:cNvPr id="12" name="">
+            <a:extLst xmlns:a="http://schemas.openxmlformats.org/drawingml/2006/main">
+              <a:ext uri="{FF2B5EF4-FFF2-40B4-BE49-F238E27FC236}">
+                <a16:creationId xmlns:a16="http://schemas.microsoft.com/office/drawing/2014/main" id="{6F935AD2-0E1C-4FBE-B97B-EC48D93685C2}"/>
+              </a:ext>
+            </a:extLst>
+          </p:cNvPr>
+          <p:cNvSpPr>
+            <a:spLocks xmlns:a="http://schemas.openxmlformats.org/drawingml/2006/main" noGrp="1"/>
+          </p:cNvSpPr>
+          <p:nvPr/>
+        </p:nvSpPr>
+        <p:spPr>
+          <a:xfrm xmlns:a="http://schemas.openxmlformats.org/drawingml/2006/main">
+            <a:off x="6419850" y="2724150"/>
+            <a:ext cx="5143500" cy="2000250"/>
+          </a:xfrm>
+          <a:prstGeom xmlns:a="http://schemas.openxmlformats.org/drawingml/2006/main" prst="rect">
+            <a:avLst/>
+          </a:prstGeom>
+          <a:noFill xmlns:a="http://schemas.openxmlformats.org/drawingml/2006/main"/>
+          <a:ln xmlns:a="http://schemas.openxmlformats.org/drawingml/2006/main" w="0">
+            <a:noFill/>
+          </a:ln>
+        </p:spPr>
+        <p:txBody>
+          <a:bodyPr xmlns:a="http://schemas.openxmlformats.org/drawingml/2006/main">
+            <a:noAutofit/>
+          </a:bodyPr>
+          <a:lstStyle xmlns:a="http://schemas.openxmlformats.org/drawingml/2006/main"/>
+          <a:p xmlns:a="http://schemas.openxmlformats.org/drawingml/2006/main">
+            <a:pPr>
+              <a:defRPr sz="2100" b="0">
+                <a:solidFill>
+                  <a:srgbClr val="102A30"/>
+                </a:solidFill>
+                <a:latin typeface="Helvetica Neue"/>
+                <a:ea typeface="Helvetica Neue"/>
+                <a:cs typeface="Helvetica Neue"/>
+              </a:defRPr>
+            </a:pPr>
+            <a:r>
+              <a:rPr sz="2100" b="0">
+                <a:solidFill>
+                  <a:srgbClr val="102A30"/>
+                </a:solidFill>
+                <a:latin typeface="Helvetica Neue"/>
+                <a:ea typeface="Helvetica Neue"/>
+                <a:cs typeface="Helvetica Neue"/>
+              </a:rPr>
+              <a:t>Проверяет ввод текста</a:t>
+            </a:r>
+          </a:p>
+          <a:p xmlns:a="http://schemas.openxmlformats.org/drawingml/2006/main">
+            <a:pPr>
+              <a:defRPr sz="2100" b="0">
+                <a:solidFill>
+                  <a:srgbClr val="102A30"/>
+                </a:solidFill>
+                <a:latin typeface="Helvetica Neue"/>
+                <a:ea typeface="Helvetica Neue"/>
+                <a:cs typeface="Helvetica Neue"/>
+              </a:defRPr>
+            </a:pPr>
+            <a:r>
+              <a:rPr sz="2100" b="0">
+                <a:solidFill>
+                  <a:srgbClr val="102A30"/>
+                </a:solidFill>
+                <a:latin typeface="Helvetica Neue"/>
+                <a:ea typeface="Helvetica Neue"/>
+                <a:cs typeface="Helvetica Neue"/>
+              </a:rPr>
+              <a:t>и защиту запросов от подделки.</a:t>
+            </a:r>
+          </a:p>
+          <a:p xmlns:a="http://schemas.openxmlformats.org/drawingml/2006/main">
+            <a:r>
+              <a:t/>
+            </a:r>
+          </a:p>
+          <a:p xmlns:a="http://schemas.openxmlformats.org/drawingml/2006/main">
+            <a:pPr>
+              <a:defRPr sz="2100" b="0">
+                <a:solidFill>
+                  <a:srgbClr val="102A30"/>
+                </a:solidFill>
+                <a:latin typeface="Helvetica Neue"/>
+                <a:ea typeface="Helvetica Neue"/>
+                <a:cs typeface="Helvetica Neue"/>
+              </a:defRPr>
+            </a:pPr>
+            <a:r>
+              <a:rPr sz="2100" b="0">
+                <a:solidFill>
+                  <a:srgbClr val="102A30"/>
+                </a:solidFill>
+                <a:latin typeface="Helvetica Neue"/>
+                <a:ea typeface="Helvetica Neue"/>
+                <a:cs typeface="Helvetica Neue"/>
+              </a:rPr>
+              <a:t>Повторяет установку</a:t>
+            </a:r>
+          </a:p>
+          <a:p xmlns:a="http://schemas.openxmlformats.org/drawingml/2006/main">
+            <a:pPr>
+              <a:defRPr sz="2100" b="0">
+                <a:solidFill>
+                  <a:srgbClr val="102A30"/>
+                </a:solidFill>
+                <a:latin typeface="Helvetica Neue"/>
+                <a:ea typeface="Helvetica Neue"/>
+                <a:cs typeface="Helvetica Neue"/>
+              </a:defRPr>
+            </a:pPr>
+            <a:r>
+              <a:rPr sz="2100" b="0">
+                <a:solidFill>
+                  <a:srgbClr val="102A30"/>
+                </a:solidFill>
+                <a:latin typeface="Helvetica Neue"/>
+                <a:ea typeface="Helvetica Neue"/>
+                <a:cs typeface="Helvetica Neue"/>
+              </a:rPr>
+              <a:t>из архива на чистом окружении.</a:t>
+            </a:r>
+          </a:p>
+        </p:txBody>
+      </p:sp>
+      <p:sp>
+        <p:nvSpPr>
+          <p:cNvPr id="13" name="">
+            <a:extLst xmlns:a="http://schemas.openxmlformats.org/drawingml/2006/main">
+              <a:ext uri="{FF2B5EF4-FFF2-40B4-BE49-F238E27FC236}">
+                <a16:creationId xmlns:a16="http://schemas.microsoft.com/office/drawing/2014/main" id="{A7E17ABD-3AA4-4B0B-B4F3-817BAB58B23C}"/>
+              </a:ext>
+            </a:extLst>
+          </p:cNvPr>
+          <p:cNvSpPr>
+            <a:spLocks xmlns:a="http://schemas.openxmlformats.org/drawingml/2006/main" noGrp="1"/>
+          </p:cNvSpPr>
+          <p:nvPr/>
+        </p:nvSpPr>
+        <p:spPr>
+          <a:xfrm xmlns:a="http://schemas.openxmlformats.org/drawingml/2006/main">
+            <a:off x="609600" y="5181600"/>
+            <a:ext cx="10972800" cy="628650"/>
+          </a:xfrm>
+          <a:prstGeom xmlns:a="http://schemas.openxmlformats.org/drawingml/2006/main" prst="rect">
+            <a:avLst/>
+          </a:prstGeom>
+          <a:noFill xmlns:a="http://schemas.openxmlformats.org/drawingml/2006/main"/>
+          <a:ln xmlns:a="http://schemas.openxmlformats.org/drawingml/2006/main" w="0">
+            <a:noFill/>
+          </a:ln>
+        </p:spPr>
+        <p:txBody>
+          <a:bodyPr xmlns:a="http://schemas.openxmlformats.org/drawingml/2006/main">
+            <a:noAutofit/>
+          </a:bodyPr>
+          <a:lstStyle xmlns:a="http://schemas.openxmlformats.org/drawingml/2006/main"/>
+          <a:p xmlns:a="http://schemas.openxmlformats.org/drawingml/2006/main">
+            <a:pPr>
+              <a:defRPr sz="2250" b="1">
+                <a:solidFill>
+                  <a:srgbClr val="26756C"/>
+                </a:solidFill>
+                <a:latin typeface="Helvetica Neue"/>
+                <a:ea typeface="Helvetica Neue"/>
+                <a:cs typeface="Helvetica Neue"/>
+              </a:defRPr>
+            </a:pPr>
+            <a:r>
+              <a:rPr sz="2250" b="1">
+                <a:solidFill>
+                  <a:srgbClr val="26756C"/>
+                </a:solidFill>
+                <a:latin typeface="Helvetica Neue"/>
+                <a:ea typeface="Helvetica Neue"/>
+                <a:cs typeface="Helvetica Neue"/>
+              </a:rPr>
+              <a:t>Каждый сохраняет отчёт и проверяет результат партнёра.</a:t>
+            </a:r>
+          </a:p>
+        </p:txBody>
+      </p:sp>
+      <p:sp>
+        <p:nvSpPr>
+          <p:cNvPr id="14" name="">
+            <a:extLst xmlns:a="http://schemas.openxmlformats.org/drawingml/2006/main">
+              <a:ext uri="{FF2B5EF4-FFF2-40B4-BE49-F238E27FC236}">
+                <a16:creationId xmlns:a16="http://schemas.microsoft.com/office/drawing/2014/main" id="{49267C2F-5D98-4E1B-86F5-A6365AC37E03}"/>
+              </a:ext>
+            </a:extLst>
+          </p:cNvPr>
+          <p:cNvSpPr>
+            <a:spLocks xmlns:a="http://schemas.openxmlformats.org/drawingml/2006/main" noGrp="1"/>
+          </p:cNvSpPr>
+          <p:nvPr/>
+        </p:nvSpPr>
+        <p:spPr>
+          <a:xfrm xmlns:a="http://schemas.openxmlformats.org/drawingml/2006/main">
+            <a:off x="609600" y="5915025"/>
+            <a:ext cx="10972800" cy="381000"/>
+          </a:xfrm>
+          <a:prstGeom xmlns:a="http://schemas.openxmlformats.org/drawingml/2006/main" prst="rect">
+            <a:avLst/>
+          </a:prstGeom>
+          <a:noFill xmlns:a="http://schemas.openxmlformats.org/drawingml/2006/main"/>
+          <a:ln xmlns:a="http://schemas.openxmlformats.org/drawingml/2006/main" w="0">
+            <a:noFill/>
+          </a:ln>
+        </p:spPr>
+        <p:txBody>
+          <a:bodyPr xmlns:a="http://schemas.openxmlformats.org/drawingml/2006/main">
+            <a:noAutofit/>
+          </a:bodyPr>
+          <a:lstStyle xmlns:a="http://schemas.openxmlformats.org/drawingml/2006/main"/>
+          <a:p xmlns:a="http://schemas.openxmlformats.org/drawingml/2006/main">
+            <a:pPr>
               <a:defRPr sz="1875" b="0">
                 <a:solidFill>
                   <a:srgbClr val="59686B"/>
@@ -6729,7 +6960,7 @@
                 <a:ea typeface="Helvetica Neue"/>
                 <a:cs typeface="Helvetica Neue"/>
               </a:rPr>
-              <a:t>Технический профиль ЭК1 уточняем после Л6–Л8.</a:t>
+              <a:t>После взаимной проверки созваниваемся и обсуждаем результаты.</a:t>
             </a:r>
           </a:p>
         </p:txBody>
@@ -6797,6 +7028,7 @@
           <a:lstStyle xmlns:a="http://schemas.openxmlformats.org/drawingml/2006/main"/>
           <a:p xmlns:a="http://schemas.openxmlformats.org/drawingml/2006/main">
             <a:pPr>
+              <a:buNone/>
               <a:defRPr sz="1350" b="1">
                 <a:solidFill>
                   <a:srgbClr val="26756C"/>
@@ -6854,6 +7086,7 @@
           <a:lstStyle xmlns:a="http://schemas.openxmlformats.org/drawingml/2006/main"/>
           <a:p xmlns:a="http://schemas.openxmlformats.org/drawingml/2006/main">
             <a:pPr>
+              <a:buNone/>
               <a:defRPr sz="3300" b="1">
                 <a:solidFill>
                   <a:srgbClr val="102A30"/>
@@ -6872,7 +7105,7 @@
                 <a:ea typeface="Helvetica Neue"/>
                 <a:cs typeface="Helvetica Neue"/>
               </a:rPr>
-              <a:t>Семь адаптированных правил SSDF</a:t>
+              <a:t>Другие источники из лекций</a:t>
             </a:r>
           </a:p>
         </p:txBody>
@@ -6911,6 +7144,7 @@
           <a:lstStyle xmlns:a="http://schemas.openxmlformats.org/drawingml/2006/main"/>
           <a:p xmlns:a="http://schemas.openxmlformats.org/drawingml/2006/main">
             <a:pPr>
+              <a:buNone/>
               <a:defRPr sz="1350" b="0">
                 <a:solidFill>
                   <a:srgbClr val="59686B"/>
@@ -6968,6 +7202,7 @@
           <a:lstStyle xmlns:a="http://schemas.openxmlformats.org/drawingml/2006/main"/>
           <a:p xmlns:a="http://schemas.openxmlformats.org/drawingml/2006/main">
             <a:pPr>
+              <a:buNone/>
               <a:defRPr sz="1800" b="1">
                 <a:solidFill>
                   <a:srgbClr val="26756C"/>
@@ -6993,23 +7228,24 @@
       </p:sp>
       <p:graphicFrame>
         <p:nvGraphicFramePr>
-          <p:cNvPr id="10" name=""/>
+          <p:cNvPr id="12" name=""/>
           <p:cNvGraphicFramePr/>
           <p:nvPr/>
         </p:nvGraphicFramePr>
         <p:xfrm>
-          <a:off xmlns:a="http://schemas.openxmlformats.org/drawingml/2006/main" x="609600" y="1990725"/>
-          <a:ext xmlns:a="http://schemas.openxmlformats.org/drawingml/2006/main" cx="10972800" cy="4105275"/>
+          <a:off xmlns:a="http://schemas.openxmlformats.org/drawingml/2006/main" x="609600" y="2028825"/>
+          <a:ext xmlns:a="http://schemas.openxmlformats.org/drawingml/2006/main" cx="10972800" cy="3857625"/>
         </p:xfrm>
         <a:graphic xmlns:a="http://schemas.openxmlformats.org/drawingml/2006/main">
           <a:graphicData uri="http://schemas.openxmlformats.org/drawingml/2006/table">
             <a:tbl>
               <a:tblPr/>
               <a:tblGrid>
-                <a:gridCol w="3333750"/>
-                <a:gridCol w="7639050"/>
+                <a:gridCol w="2190750"/>
+                <a:gridCol w="3810000"/>
+                <a:gridCol w="4972050"/>
               </a:tblGrid>
-              <a:tr h="513159">
+              <a:tr h="542925">
                 <a:tc>
                   <a:txBody>
                     <a:bodyPr>
@@ -7018,7 +7254,7 @@
                     <a:lstStyle/>
                     <a:p>
                       <a:r>
-                        <a:rPr sz="1800" b="1">
+                        <a:rPr sz="1875" b="1">
                           <a:solidFill>
                             <a:srgbClr val="FFFFFF"/>
                           </a:solidFill>
@@ -7026,7 +7262,7 @@
                           <a:ea typeface="Helvetica Neue"/>
                           <a:cs typeface="Helvetica Neue"/>
                         </a:rPr>
-                        <a:t>Положение SSDF 1.1</a:t>
+                        <a:t>Источник</a:t>
                       </a:r>
                     </a:p>
                   </a:txBody>
@@ -7044,7 +7280,7 @@
                     <a:lstStyle/>
                     <a:p>
                       <a:r>
-                        <a:rPr sz="1800" b="1">
+                        <a:rPr sz="1875" b="1">
                           <a:solidFill>
                             <a:srgbClr val="FFFFFF"/>
                           </a:solidFill>
@@ -7052,7 +7288,33 @@
                           <a:ea typeface="Helvetica Neue"/>
                           <a:cs typeface="Helvetica Neue"/>
                         </a:rPr>
-                        <a:t>Правило TaskFlow</a:t>
+                        <a:t>Зачем рассмотрели</a:t>
+                      </a:r>
+                    </a:p>
+                  </a:txBody>
+                  <a:tcPr marL="91440" marR="91440" marT="45720" marB="45720">
+                    <a:solidFill>
+                      <a:srgbClr val="102A30"/>
+                    </a:solidFill>
+                  </a:tcPr>
+                </a:tc>
+                <a:tc>
+                  <a:txBody>
+                    <a:bodyPr>
+                      <a:noAutofit/>
+                    </a:bodyPr>
+                    <a:lstStyle/>
+                    <a:p>
+                      <a:r>
+                        <a:rPr sz="1875" b="1">
+                          <a:solidFill>
+                            <a:srgbClr val="FFFFFF"/>
+                          </a:solidFill>
+                          <a:latin typeface="Helvetica Neue"/>
+                          <a:ea typeface="Helvetica Neue"/>
+                          <a:cs typeface="Helvetica Neue"/>
+                        </a:rPr>
+                        <a:t>Почему не взяли за основу</a:t>
                       </a:r>
                     </a:p>
                   </a:txBody>
@@ -7063,7 +7325,7 @@
                   </a:tcPr>
                 </a:tc>
               </a:tr>
-              <a:tr h="513159">
+              <a:tr h="1104900">
                 <a:tc>
                   <a:txBody>
                     <a:bodyPr>
@@ -7072,7 +7334,7 @@
                     <a:lstStyle/>
                     <a:p>
                       <a:r>
-                        <a:rPr sz="1800" b="0">
+                        <a:rPr sz="1875" b="0">
                           <a:solidFill>
                             <a:srgbClr val="102A30"/>
                           </a:solidFill>
@@ -7080,7 +7342,20 @@
                           <a:ea typeface="Helvetica Neue"/>
                           <a:cs typeface="Helvetica Neue"/>
                         </a:rPr>
-                        <a:t>PO.1.2</a:t>
+                        <a:t>ISO/IEC</a:t>
+                      </a:r>
+                    </a:p>
+                    <a:p>
+                      <a:r>
+                        <a:rPr sz="1875" b="0">
+                          <a:solidFill>
+                            <a:srgbClr val="102A30"/>
+                          </a:solidFill>
+                          <a:latin typeface="Helvetica Neue"/>
+                          <a:ea typeface="Helvetica Neue"/>
+                          <a:cs typeface="Helvetica Neue"/>
+                        </a:rPr>
+                        <a:t>27034-1</a:t>
                       </a:r>
                     </a:p>
                   </a:txBody>
@@ -7098,7 +7373,7 @@
                     <a:lstStyle/>
                     <a:p>
                       <a:r>
-                        <a:rPr sz="1800" b="0">
+                        <a:rPr sz="1875" b="0">
                           <a:solidFill>
                             <a:srgbClr val="102A30"/>
                           </a:solidFill>
@@ -7106,7 +7381,72 @@
                           <a:ea typeface="Helvetica Neue"/>
                           <a:cs typeface="Helvetica Neue"/>
                         </a:rPr>
-                        <a:t>Явные права и запрещённые сценарии</a:t>
+                        <a:t>Управление безопасностью</a:t>
+                      </a:r>
+                    </a:p>
+                    <a:p>
+                      <a:r>
+                        <a:rPr sz="1875" b="0">
+                          <a:solidFill>
+                            <a:srgbClr val="102A30"/>
+                          </a:solidFill>
+                          <a:latin typeface="Helvetica Neue"/>
+                          <a:ea typeface="Helvetica Neue"/>
+                          <a:cs typeface="Helvetica Neue"/>
+                        </a:rPr>
+                        <a:t>приложений в организации</a:t>
+                      </a:r>
+                    </a:p>
+                  </a:txBody>
+                  <a:tcPr marL="91440" marR="91440" marT="45720" marB="45720">
+                    <a:solidFill>
+                      <a:srgbClr val="FFFFFF"/>
+                    </a:solidFill>
+                  </a:tcPr>
+                </a:tc>
+                <a:tc>
+                  <a:txBody>
+                    <a:bodyPr>
+                      <a:noAutofit/>
+                    </a:bodyPr>
+                    <a:lstStyle/>
+                    <a:p>
+                      <a:r>
+                        <a:rPr sz="1875" b="0">
+                          <a:solidFill>
+                            <a:srgbClr val="102A30"/>
+                          </a:solidFill>
+                          <a:latin typeface="Helvetica Neue"/>
+                          <a:ea typeface="Helvetica Neue"/>
+                          <a:cs typeface="Helvetica Neue"/>
+                        </a:rPr>
+                        <a:t>В нашей паре нет отдельной</a:t>
+                      </a:r>
+                    </a:p>
+                    <a:p>
+                      <a:r>
+                        <a:rPr sz="1875" b="0">
+                          <a:solidFill>
+                            <a:srgbClr val="102A30"/>
+                          </a:solidFill>
+                          <a:latin typeface="Helvetica Neue"/>
+                          <a:ea typeface="Helvetica Neue"/>
+                          <a:cs typeface="Helvetica Neue"/>
+                        </a:rPr>
+                        <a:t>задачи управления безопасностью</a:t>
+                      </a:r>
+                    </a:p>
+                    <a:p>
+                      <a:r>
+                        <a:rPr sz="1875" b="0">
+                          <a:solidFill>
+                            <a:srgbClr val="102A30"/>
+                          </a:solidFill>
+                          <a:latin typeface="Helvetica Neue"/>
+                          <a:ea typeface="Helvetica Neue"/>
+                          <a:cs typeface="Helvetica Neue"/>
+                        </a:rPr>
+                        <a:t>на уровне организации.</a:t>
                       </a:r>
                     </a:p>
                   </a:txBody>
@@ -7117,7 +7457,7 @@
                   </a:tcPr>
                 </a:tc>
               </a:tr>
-              <a:tr h="513159">
+              <a:tr h="1104900">
                 <a:tc>
                   <a:txBody>
                     <a:bodyPr>
@@ -7126,7 +7466,7 @@
                     <a:lstStyle/>
                     <a:p>
                       <a:r>
-                        <a:rPr sz="1800" b="0">
+                        <a:rPr sz="1875" b="0">
                           <a:solidFill>
                             <a:srgbClr val="102A30"/>
                           </a:solidFill>
@@ -7134,7 +7474,20 @@
                           <a:ea typeface="Helvetica Neue"/>
                           <a:cs typeface="Helvetica Neue"/>
                         </a:rPr>
-                        <a:t>PO.2.1</a:t>
+                        <a:t>IEC</a:t>
+                      </a:r>
+                    </a:p>
+                    <a:p>
+                      <a:r>
+                        <a:rPr sz="1875" b="0">
+                          <a:solidFill>
+                            <a:srgbClr val="102A30"/>
+                          </a:solidFill>
+                          <a:latin typeface="Helvetica Neue"/>
+                          <a:ea typeface="Helvetica Neue"/>
+                          <a:cs typeface="Helvetica Neue"/>
+                        </a:rPr>
+                        <a:t>62443-4-1</a:t>
                       </a:r>
                     </a:p>
                   </a:txBody>
@@ -7152,7 +7505,7 @@
                     <a:lstStyle/>
                     <a:p>
                       <a:r>
-                        <a:rPr sz="1800" b="0">
+                        <a:rPr sz="1875" b="0">
                           <a:solidFill>
                             <a:srgbClr val="102A30"/>
                           </a:solidFill>
@@ -7160,7 +7513,59 @@
                           <a:ea typeface="Helvetica Neue"/>
                           <a:cs typeface="Helvetica Neue"/>
                         </a:rPr>
-                        <a:t>Разные автор и проверяющий</a:t>
+                        <a:t>Безопасная разработка</a:t>
+                      </a:r>
+                    </a:p>
+                    <a:p>
+                      <a:r>
+                        <a:rPr sz="1875" b="0">
+                          <a:solidFill>
+                            <a:srgbClr val="102A30"/>
+                          </a:solidFill>
+                          <a:latin typeface="Helvetica Neue"/>
+                          <a:ea typeface="Helvetica Neue"/>
+                          <a:cs typeface="Helvetica Neue"/>
+                        </a:rPr>
+                        <a:t>промышленных продуктов</a:t>
+                      </a:r>
+                    </a:p>
+                  </a:txBody>
+                  <a:tcPr marL="91440" marR="91440" marT="45720" marB="45720">
+                    <a:solidFill>
+                      <a:srgbClr val="F7F6F1"/>
+                    </a:solidFill>
+                  </a:tcPr>
+                </a:tc>
+                <a:tc>
+                  <a:txBody>
+                    <a:bodyPr>
+                      <a:noAutofit/>
+                    </a:bodyPr>
+                    <a:lstStyle/>
+                    <a:p>
+                      <a:r>
+                        <a:rPr sz="1875" b="0">
+                          <a:solidFill>
+                            <a:srgbClr val="102A30"/>
+                          </a:solidFill>
+                          <a:latin typeface="Helvetica Neue"/>
+                          <a:ea typeface="Helvetica Neue"/>
+                          <a:cs typeface="Helvetica Neue"/>
+                        </a:rPr>
+                        <a:t>TaskFlow не относится</a:t>
+                      </a:r>
+                    </a:p>
+                    <a:p>
+                      <a:r>
+                        <a:rPr sz="1875" b="0">
+                          <a:solidFill>
+                            <a:srgbClr val="102A30"/>
+                          </a:solidFill>
+                          <a:latin typeface="Helvetica Neue"/>
+                          <a:ea typeface="Helvetica Neue"/>
+                          <a:cs typeface="Helvetica Neue"/>
+                        </a:rPr>
+                        <a:t>к промышленной автоматизации.</a:t>
                       </a:r>
                     </a:p>
                   </a:txBody>
@@ -7171,7 +7576,7 @@
                   </a:tcPr>
                 </a:tc>
               </a:tr>
-              <a:tr h="513159">
+              <a:tr h="1104900">
                 <a:tc>
                   <a:txBody>
                     <a:bodyPr>
@@ -7180,7 +7585,7 @@
                     <a:lstStyle/>
                     <a:p>
                       <a:r>
-                        <a:rPr sz="1800" b="0">
+                        <a:rPr sz="1875" b="0">
                           <a:solidFill>
                             <a:srgbClr val="102A30"/>
                           </a:solidFill>
@@ -7188,7 +7593,7 @@
                           <a:ea typeface="Helvetica Neue"/>
                           <a:cs typeface="Helvetica Neue"/>
                         </a:rPr>
-                        <a:t>PS.1.1</a:t>
+                        <a:t>BSIMM</a:t>
                       </a:r>
                     </a:p>
                   </a:txBody>
@@ -7206,7 +7611,7 @@
                     <a:lstStyle/>
                     <a:p>
                       <a:r>
-                        <a:rPr sz="1800" b="0">
+                        <a:rPr sz="1875" b="0">
                           <a:solidFill>
                             <a:srgbClr val="102A30"/>
                           </a:solidFill>
@@ -7214,27 +7619,12 @@
                           <a:ea typeface="Helvetica Neue"/>
                           <a:cs typeface="Helvetica Neue"/>
                         </a:rPr>
-                        <a:t>Минимальные права, отсутствие секретов в поставке</a:t>
+                        <a:t>Практики безопасности,</a:t>
                       </a:r>
                     </a:p>
-                  </a:txBody>
-                  <a:tcPr marL="91440" marR="91440" marT="45720" marB="45720">
-                    <a:solidFill>
-                      <a:srgbClr val="FFFFFF"/>
-                    </a:solidFill>
-                  </a:tcPr>
-                </a:tc>
-              </a:tr>
-              <a:tr h="513159">
-                <a:tc>
-                  <a:txBody>
-                    <a:bodyPr>
-                      <a:noAutofit/>
-                    </a:bodyPr>
-                    <a:lstStyle/>
                     <a:p>
                       <a:r>
-                        <a:rPr sz="1800" b="0">
+                        <a:rPr sz="1875" b="0">
                           <a:solidFill>
                             <a:srgbClr val="102A30"/>
                           </a:solidFill>
@@ -7242,61 +7632,7 @@
                           <a:ea typeface="Helvetica Neue"/>
                           <a:cs typeface="Helvetica Neue"/>
                         </a:rPr>
-                        <a:t>PW.7.1–7.2</a:t>
-                      </a:r>
-                    </a:p>
-                  </a:txBody>
-                  <a:tcPr marL="91440" marR="91440" marT="45720" marB="45720">
-                    <a:solidFill>
-                      <a:srgbClr val="F7F6F1"/>
-                    </a:solidFill>
-                  </a:tcPr>
-                </a:tc>
-                <a:tc>
-                  <a:txBody>
-                    <a:bodyPr>
-                      <a:noAutofit/>
-                    </a:bodyPr>
-                    <a:lstStyle/>
-                    <a:p>
-                      <a:r>
-                        <a:rPr sz="1800" b="0">
-                          <a:solidFill>
-                            <a:srgbClr val="102A30"/>
-                          </a:solidFill>
-                          <a:latin typeface="Helvetica Neue"/>
-                          <a:ea typeface="Helvetica Neue"/>
-                          <a:cs typeface="Helvetica Neue"/>
-                        </a:rPr>
-                        <a:t>Независимое чтение значимого кода</a:t>
-                      </a:r>
-                    </a:p>
-                  </a:txBody>
-                  <a:tcPr marL="91440" marR="91440" marT="45720" marB="45720">
-                    <a:solidFill>
-                      <a:srgbClr val="F7F6F1"/>
-                    </a:solidFill>
-                  </a:tcPr>
-                </a:tc>
-              </a:tr>
-              <a:tr h="513159">
-                <a:tc>
-                  <a:txBody>
-                    <a:bodyPr>
-                      <a:noAutofit/>
-                    </a:bodyPr>
-                    <a:lstStyle/>
-                    <a:p>
-                      <a:r>
-                        <a:rPr sz="1800" b="0">
-                          <a:solidFill>
-                            <a:srgbClr val="102A30"/>
-                          </a:solidFill>
-                          <a:latin typeface="Helvetica Neue"/>
-                          <a:ea typeface="Helvetica Neue"/>
-                          <a:cs typeface="Helvetica Neue"/>
-                        </a:rPr>
-                        <a:t>PW.8.1–8.2</a:t>
+                        <a:t>наблюдаемые в организациях</a:t>
                       </a:r>
                     </a:p>
                   </a:txBody>
@@ -7314,7 +7650,7 @@
                     <a:lstStyle/>
                     <a:p>
                       <a:r>
-                        <a:rPr sz="1800" b="0">
+                        <a:rPr sz="1875" b="0">
                           <a:solidFill>
                             <a:srgbClr val="102A30"/>
                           </a:solidFill>
@@ -7322,27 +7658,12 @@
                           <a:ea typeface="Helvetica Neue"/>
                           <a:cs typeface="Helvetica Neue"/>
                         </a:rPr>
-                        <a:t>Положительные и отрицательные проверки</a:t>
+                        <a:t>Сравнение с другими</a:t>
                       </a:r>
                     </a:p>
-                  </a:txBody>
-                  <a:tcPr marL="91440" marR="91440" marT="45720" marB="45720">
-                    <a:solidFill>
-                      <a:srgbClr val="FFFFFF"/>
-                    </a:solidFill>
-                  </a:tcPr>
-                </a:tc>
-              </a:tr>
-              <a:tr h="513159">
-                <a:tc>
-                  <a:txBody>
-                    <a:bodyPr>
-                      <a:noAutofit/>
-                    </a:bodyPr>
-                    <a:lstStyle/>
                     <a:p>
                       <a:r>
-                        <a:rPr sz="1800" b="0">
+                        <a:rPr sz="1875" b="0">
                           <a:solidFill>
                             <a:srgbClr val="102A30"/>
                           </a:solidFill>
@@ -7350,25 +7671,12 @@
                           <a:ea typeface="Helvetica Neue"/>
                           <a:cs typeface="Helvetica Neue"/>
                         </a:rPr>
-                        <a:t>PS.3.1</a:t>
+                        <a:t>организациями не является</a:t>
                       </a:r>
                     </a:p>
-                  </a:txBody>
-                  <a:tcPr marL="91440" marR="91440" marT="45720" marB="45720">
-                    <a:solidFill>
-                      <a:srgbClr val="F7F6F1"/>
-                    </a:solidFill>
-                  </a:tcPr>
-                </a:tc>
-                <a:tc>
-                  <a:txBody>
-                    <a:bodyPr>
-                      <a:noAutofit/>
-                    </a:bodyPr>
-                    <a:lstStyle/>
                     <a:p>
                       <a:r>
-                        <a:rPr sz="1800" b="0">
+                        <a:rPr sz="1875" b="0">
                           <a:solidFill>
                             <a:srgbClr val="102A30"/>
                           </a:solidFill>
@@ -7376,61 +7684,7 @@
                           <a:ea typeface="Helvetica Neue"/>
                           <a:cs typeface="Helvetica Neue"/>
                         </a:rPr>
-                        <a:t>Версия, архив, SHA-256 и повтор установки</a:t>
-                      </a:r>
-                    </a:p>
-                  </a:txBody>
-                  <a:tcPr marL="91440" marR="91440" marT="45720" marB="45720">
-                    <a:solidFill>
-                      <a:srgbClr val="F7F6F1"/>
-                    </a:solidFill>
-                  </a:tcPr>
-                </a:tc>
-              </a:tr>
-              <a:tr h="513159">
-                <a:tc>
-                  <a:txBody>
-                    <a:bodyPr>
-                      <a:noAutofit/>
-                    </a:bodyPr>
-                    <a:lstStyle/>
-                    <a:p>
-                      <a:r>
-                        <a:rPr sz="1800" b="0">
-                          <a:solidFill>
-                            <a:srgbClr val="102A30"/>
-                          </a:solidFill>
-                          <a:latin typeface="Helvetica Neue"/>
-                          <a:ea typeface="Helvetica Neue"/>
-                          <a:cs typeface="Helvetica Neue"/>
-                        </a:rPr>
-                        <a:t>RV.2.1–2.2</a:t>
-                      </a:r>
-                    </a:p>
-                  </a:txBody>
-                  <a:tcPr marL="91440" marR="91440" marT="45720" marB="45720">
-                    <a:solidFill>
-                      <a:srgbClr val="FFFFFF"/>
-                    </a:solidFill>
-                  </a:tcPr>
-                </a:tc>
-                <a:tc>
-                  <a:txBody>
-                    <a:bodyPr>
-                      <a:noAutofit/>
-                    </a:bodyPr>
-                    <a:lstStyle/>
-                    <a:p>
-                      <a:r>
-                        <a:rPr sz="1800" b="0">
-                          <a:solidFill>
-                            <a:srgbClr val="102A30"/>
-                          </a:solidFill>
-                          <a:latin typeface="Helvetica Neue"/>
-                          <a:ea typeface="Helvetica Neue"/>
-                          <a:cs typeface="Helvetica Neue"/>
-                        </a:rPr>
-                        <a:t>Применимость дефекта, исправление и повтор проверки</a:t>
+                        <a:t>целью нашего проекта.</a:t>
                       </a:r>
                     </a:p>
                   </a:txBody>
@@ -7508,6 +7762,7 @@
           <a:lstStyle xmlns:a="http://schemas.openxmlformats.org/drawingml/2006/main"/>
           <a:p xmlns:a="http://schemas.openxmlformats.org/drawingml/2006/main">
             <a:pPr>
+              <a:buNone/>
               <a:defRPr sz="1350" b="1">
                 <a:solidFill>
                   <a:srgbClr val="26756C"/>
@@ -7565,6 +7820,7 @@
           <a:lstStyle xmlns:a="http://schemas.openxmlformats.org/drawingml/2006/main"/>
           <a:p xmlns:a="http://schemas.openxmlformats.org/drawingml/2006/main">
             <a:pPr>
+              <a:buNone/>
               <a:defRPr sz="3300" b="1">
                 <a:solidFill>
                   <a:srgbClr val="102A30"/>
@@ -7583,7 +7839,7 @@
                 <a:ea typeface="Helvetica Neue"/>
                 <a:cs typeface="Helvetica Neue"/>
               </a:rPr>
-              <a:t>Использование генеративного ИИ</a:t>
+              <a:t>Как использовали ИИ</a:t>
             </a:r>
           </a:p>
         </p:txBody>
@@ -7622,6 +7878,7 @@
           <a:lstStyle xmlns:a="http://schemas.openxmlformats.org/drawingml/2006/main"/>
           <a:p xmlns:a="http://schemas.openxmlformats.org/drawingml/2006/main">
             <a:pPr>
+              <a:buNone/>
               <a:defRPr sz="1350" b="0">
                 <a:solidFill>
                   <a:srgbClr val="59686B"/>
@@ -7679,6 +7936,7 @@
           <a:lstStyle xmlns:a="http://schemas.openxmlformats.org/drawingml/2006/main"/>
           <a:p xmlns:a="http://schemas.openxmlformats.org/drawingml/2006/main">
             <a:pPr>
+              <a:buNone/>
               <a:defRPr sz="1800" b="1">
                 <a:solidFill>
                   <a:srgbClr val="26756C"/>
@@ -7736,6 +7994,7 @@
           <a:lstStyle xmlns:a="http://schemas.openxmlformats.org/drawingml/2006/main"/>
           <a:p xmlns:a="http://schemas.openxmlformats.org/drawingml/2006/main">
             <a:pPr>
+              <a:buNone/>
               <a:defRPr sz="2550" b="1">
                 <a:solidFill>
                   <a:srgbClr val="26756C"/>
@@ -7793,6 +8052,7 @@
           <a:lstStyle xmlns:a="http://schemas.openxmlformats.org/drawingml/2006/main"/>
           <a:p xmlns:a="http://schemas.openxmlformats.org/drawingml/2006/main">
             <a:pPr>
+              <a:buNone/>
               <a:defRPr sz="2175" b="0">
                 <a:solidFill>
                   <a:srgbClr val="102A30"/>
@@ -7811,11 +8071,12 @@
                 <a:ea typeface="Helvetica Neue"/>
                 <a:cs typeface="Helvetica Neue"/>
               </a:rPr>
-              <a:t>Автоматизация текста, кода MVP, тестов и оформления.</a:t>
-            </a:r>
-          </a:p>
-          <a:p xmlns:a="http://schemas.openxmlformats.org/drawingml/2006/main">
-            <a:pPr>
+              <a:t>Помощь с текстом, кодом приложения, тестами и слайдами.</a:t>
+            </a:r>
+          </a:p>
+          <a:p xmlns:a="http://schemas.openxmlformats.org/drawingml/2006/main">
+            <a:pPr>
+              <a:buNone/>
               <a:defRPr sz="2175" b="0">
                 <a:solidFill>
                   <a:srgbClr val="102A30"/>
@@ -7834,11 +8095,12 @@
                 <a:ea typeface="Helvetica Neue"/>
                 <a:cs typeface="Helvetica Neue"/>
               </a:rPr>
-              <a:t>Предложения по структуре, методологии и плану проверок.</a:t>
-            </a:r>
-          </a:p>
-          <a:p xmlns:a="http://schemas.openxmlformats.org/drawingml/2006/main">
-            <a:pPr>
+              <a:t>Предложения по методологии и плану проверок.</a:t>
+            </a:r>
+          </a:p>
+          <a:p xmlns:a="http://schemas.openxmlformats.org/drawingml/2006/main">
+            <a:pPr>
+              <a:buNone/>
               <a:defRPr sz="2175" b="0">
                 <a:solidFill>
                   <a:srgbClr val="102A30"/>
@@ -7857,7 +8119,7 @@
                 <a:ea typeface="Helvetica Neue"/>
                 <a:cs typeface="Helvetica Neue"/>
               </a:rPr>
-              <a:t>Обложка презентации: иллюстрация OpenAI.</a:t>
+              <a:t>Обложка: иллюстрация OpenAI.</a:t>
             </a:r>
           </a:p>
         </p:txBody>
@@ -7896,6 +8158,7 @@
           <a:lstStyle xmlns:a="http://schemas.openxmlformats.org/drawingml/2006/main"/>
           <a:p xmlns:a="http://schemas.openxmlformats.org/drawingml/2006/main">
             <a:pPr>
+              <a:buNone/>
               <a:defRPr sz="2550" b="1">
                 <a:solidFill>
                   <a:srgbClr val="26756C"/>
@@ -7953,6 +8216,7 @@
           <a:lstStyle xmlns:a="http://schemas.openxmlformats.org/drawingml/2006/main"/>
           <a:p xmlns:a="http://schemas.openxmlformats.org/drawingml/2006/main">
             <a:pPr>
+              <a:buNone/>
               <a:defRPr sz="2175" b="0">
                 <a:solidFill>
                   <a:srgbClr val="102A30"/>
@@ -7971,11 +8235,12 @@
                 <a:ea typeface="Helvetica Neue"/>
                 <a:cs typeface="Helvetica Neue"/>
               </a:rPr>
-              <a:t>Участники выбирают и обосновывают проектные решения.</a:t>
-            </a:r>
-          </a:p>
-          <a:p xmlns:a="http://schemas.openxmlformats.org/drawingml/2006/main">
-            <a:pPr>
+              <a:t>Участники выбирают решения и отвечают за них.</a:t>
+            </a:r>
+          </a:p>
+          <a:p xmlns:a="http://schemas.openxmlformats.org/drawingml/2006/main">
+            <a:pPr>
+              <a:buNone/>
               <a:defRPr sz="2175" b="0">
                 <a:solidFill>
                   <a:srgbClr val="102A30"/>
@@ -7994,7 +8259,7 @@
                 <a:ea typeface="Helvetica Neue"/>
                 <a:cs typeface="Helvetica Neue"/>
               </a:rPr>
-              <a:t>ИИ не заменяет независимое review и решение о выпуске.</a:t>
+              <a:t>Код проверяет партнёр, выпуск одобряют оба участника.</a:t>
             </a:r>
           </a:p>
         </p:txBody>
@@ -8033,6 +8298,7 @@
           <a:lstStyle xmlns:a="http://schemas.openxmlformats.org/drawingml/2006/main"/>
           <a:p xmlns:a="http://schemas.openxmlformats.org/drawingml/2006/main">
             <a:pPr>
+              <a:buNone/>
               <a:defRPr sz="1800" b="0">
                 <a:solidFill>
                   <a:srgbClr val="59686B"/>
@@ -8051,7 +8317,7 @@
                 <a:ea typeface="Helvetica Neue"/>
                 <a:cs typeface="Helvetica Neue"/>
               </a:rPr>
-              <a:t>Данные: материалы курса, учебные исходники и синтетические сценарии.</a:t>
+              <a:t>Данные: материалы курса, учебный код и вымышленные примеры.</a:t>
             </a:r>
           </a:p>
         </p:txBody>

</xml_diff>